<commit_message>
W01/D5: study notes, Saturday pre-read, provenance, and the decks rebuilt from their final markdown
The study notes walk the method as one invented worked case with every trap, answer the day's four
interview questions in full and repeat the deck's five crux lines word for word. Round one of the
rehearsal is re-timed to fit its briefing. Links checked on 29 September 2026.

Co-Authored-By: Claude Opus 5.5 <noreply@anthropic.com>
Claude-Session: https://claude.ai/code/session_01YDoM6EtBGzABMak6HtBLgj
</commit_message>
<xml_diff>
--- a/content/W01/D5/slides/C2_W01_D05_debrief_STUDENT.pptx
+++ b/content/W01/D5/slides/C2_W01_D05_debrief_STUDENT.pptx
@@ -9119,7 +9119,7 @@
                 </a:solidFill>
                 <a:latin typeface="Calibri"/>
               </a:rPr>
-              <a:t>A rate on ten orders is a rumour with a percent sign.</a:t>
+              <a:t>A rate on a handful of orders is a rumour with a percent sign.</a:t>
             </a:r>
           </a:p>
         </p:txBody>
@@ -9560,7 +9560,7 @@
                 </a:solidFill>
                 <a:latin typeface="Georgia"/>
               </a:rPr>
-              <a:t>The corporate book fell 30 percent</a:t>
+              <a:t>The corporate book fell 45 percent</a:t>
             </a:r>
           </a:p>
         </p:txBody>
@@ -9595,7 +9595,7 @@
                 </a:solidFill>
                 <a:latin typeface="Calibri"/>
               </a:rPr>
-              <a:t>Invented numbers: a segment's revenue, true to the rupee, on eight orders.</a:t>
+              <a:t>Invented numbers: a segment's revenue, true to the rupee, on nine orders.</a:t>
             </a:r>
           </a:p>
         </p:txBody>
@@ -9630,7 +9630,7 @@
                 </a:solidFill>
                 <a:latin typeface="Georgia"/>
               </a:rPr>
-              <a:t>-30.0%</a:t>
+              <a:t>-45.0%</a:t>
             </a:r>
           </a:p>
         </p:txBody>
@@ -9779,7 +9779,7 @@
                 </a:solidFill>
                 <a:latin typeface="Georgia"/>
               </a:rPr>
-              <a:t>5 then 3</a:t>
+              <a:t>6 then 3</a:t>
             </a:r>
           </a:p>
         </p:txBody>
@@ -9928,7 +9928,7 @@
                 </a:solidFill>
                 <a:latin typeface="Georgia"/>
               </a:rPr>
-              <a:t>2</a:t>
+              <a:t>3</a:t>
             </a:r>
           </a:p>
         </p:txBody>
@@ -9998,7 +9998,7 @@
                 </a:solidFill>
                 <a:latin typeface="Calibri"/>
               </a:rPr>
-              <a:t>out of eight</a:t>
+              <a:t>out of nine</a:t>
             </a:r>
           </a:p>
         </p:txBody>
@@ -10081,7 +10081,7 @@
                 </a:solidFill>
                 <a:latin typeface="Calibri"/>
               </a:rPr>
-              <a:t>The rupees reconcile and the percentage is right. A note that leads with it sends Meera after two invoices.</a:t>
+              <a:t>The rupees reconcile and the percentage is right. A note that leads with it sends Meera after three invoices.</a:t>
             </a:r>
           </a:p>
         </p:txBody>
@@ -11251,7 +11251,7 @@
       </p:sp>
       <p:pic>
         <p:nvPicPr>
-          <p:cNvPr id="9" name="mermaid diagram" descr="b8a05fd91c30f453.png"/>
+          <p:cNvPr id="9" name="mermaid diagram" descr="e2dbc016c9c86fd1.png"/>
           <p:cNvPicPr>
             <a:picLocks noChangeAspect="1"/>
           </p:cNvPicPr>
@@ -11459,7 +11459,7 @@
                 </a:solidFill>
                 <a:latin typeface="Calibri"/>
               </a:rPr>
-              <a:t>Say the count before the rate, every time: "8 orders, down 30 percent" is honest, and "down 30 percent" alone is a headline.</a:t>
+              <a:t>Say the count before the rate, every time: "9 orders, down 45 percent" is honest, and "down 45 percent" alone is a headline.</a:t>
             </a:r>
           </a:p>
         </p:txBody>
@@ -19661,7 +19661,7 @@
       </p:sp>
       <p:pic>
         <p:nvPicPr>
-          <p:cNvPr id="9" name="mermaid diagram" descr="87a96a87ce97cbae.png"/>
+          <p:cNvPr id="9" name="mermaid diagram" descr="92fba2adbc553768.png"/>
           <p:cNvPicPr>
             <a:picLocks noChangeAspect="1"/>
           </p:cNvPicPr>
@@ -19717,7 +19717,7 @@
                 </a:solidFill>
                 <a:latin typeface="Calibri"/>
               </a:rPr>
-              <a:t>On the rows as read, customers seem to order a fifth more often and the segment looks flat. Clean, frequency holds and the basket falls by a sixth, which is a different branch and a different owner.</a:t>
+              <a:t>On the rows as read, customers seem to order a quarter more often and the segment looks flat. Clean, frequency holds and the basket falls by an eighth, which is a different branch and a different owner.</a:t>
             </a:r>
           </a:p>
         </p:txBody>

</xml_diff>

<commit_message>
W01/D5: the debrief replays the empty segment, the seventh trap
Reserve slides D16 and D17 run the empty-segment round on labelled invented
numbers: the Retail-Plus fall a blank cell manufactures, the win-back plan it
would have sent Meera, the check that segments add back to the total, and the
restore-or-flag fix. The close is renumbered S18, the section notes point at
D14 to D17, and the day sheet's debrief row follows. Deck rebuilt to 22 slides.

Co-Authored-By: Claude Opus 5.5 <noreply@anthropic.com>
Claude-Session: https://claude.ai/code/session_01WTK44oNvVnJFNNgVMHezV4
</commit_message>
<xml_diff>
--- a/content/W01/D5/slides/C2_W01_D05_debrief_STUDENT.pptx
+++ b/content/W01/D5/slides/C2_W01_D05_debrief_STUDENT.pptx
@@ -25,6 +25,8 @@
     <p:sldId id="273" r:id="rId25"/>
     <p:sldId id="274" r:id="rId26"/>
     <p:sldId id="275" r:id="rId27"/>
+    <p:sldId id="276" r:id="rId28"/>
+    <p:sldId id="277" r:id="rId29"/>
   </p:sldIdLst>
   <p:sldSz cx="12191695" cy="6858000" type="screen4x3"/>
   <p:notesSz cx="6858000" cy="9144000"/>
@@ -921,12 +923,12 @@
           </a:p>
           <a:p>
             <a:r>
-              <a:t>rate without its order count, or a shuffle on the wrong unit. The reserve slides D14 and D15 cover</a:t>
-            </a:r>
-          </a:p>
-          <a:p>
-            <a:r>
-              <a:t>the other two breaks the lab produces.</a:t>
+              <a:t>rate without its order count, or a shuffle on the wrong unit. The reserve slides D14 to D17 cover</a:t>
+            </a:r>
+          </a:p>
+          <a:p>
+            <a:r>
+              <a:t>the other three breaks the lab produces.</a:t>
             </a:r>
           </a:p>
         </p:txBody>
@@ -1461,6 +1463,161 @@
           <a:lstStyle/>
           <a:p>
             <a:r>
+              <a:t>RESERVE, 2 minutes. Read the three numbers as a hurried note would. Ask where the empty cell went:</a:t>
+            </a:r>
+          </a:p>
+          <a:p>
+            <a:r>
+              <a:t>the honest answer on most screens is that nobody decided, the filter did.</a:t>
+            </a:r>
+          </a:p>
+        </p:txBody>
+      </p:sp>
+      <p:sp>
+        <p:nvSpPr>
+          <p:cNvPr id="4" name="Slide Number Placeholder 3"/>
+          <p:cNvSpPr>
+            <a:spLocks noGrp="1"/>
+          </p:cNvSpPr>
+          <p:nvPr>
+            <p:ph type="sldNum" idx="5" sz="quarter"/>
+          </p:nvPr>
+        </p:nvSpPr>
+        <p:spPr/>
+      </p:sp>
+    </p:spTree>
+  </p:cSld>
+  <p:clrMapOvr>
+    <a:masterClrMapping/>
+  </p:clrMapOvr>
+</p:notes>
+</file>
+
+<file path=ppt/notesSlides/notesSlide21.xml><?xml version="1.0" encoding="utf-8"?>
+<p:notes xmlns:a="http://schemas.openxmlformats.org/drawingml/2006/main" xmlns:p="http://schemas.openxmlformats.org/presentationml/2006/main" xmlns:r="http://schemas.openxmlformats.org/officeDocument/2006/relationships">
+  <p:cSld>
+    <p:spTree>
+      <p:nvGrpSpPr>
+        <p:cNvPr id="1" name=""/>
+        <p:cNvGrpSpPr/>
+        <p:nvPr/>
+      </p:nvGrpSpPr>
+      <p:grpSpPr>
+        <a:xfrm>
+          <a:off x="0" y="0"/>
+          <a:ext cx="0" cy="0"/>
+          <a:chOff x="0" y="0"/>
+          <a:chExt cx="0" cy="0"/>
+        </a:xfrm>
+      </p:grpSpPr>
+      <p:sp>
+        <p:nvSpPr>
+          <p:cNvPr id="2" name="Slide Image Placeholder 1"/>
+          <p:cNvSpPr>
+            <a:spLocks noGrp="1"/>
+          </p:cNvSpPr>
+          <p:nvPr>
+            <p:ph type="sldImg" idx="2"/>
+          </p:nvPr>
+        </p:nvSpPr>
+        <p:spPr/>
+      </p:sp>
+      <p:sp>
+        <p:nvSpPr>
+          <p:cNvPr id="3" name="Notes Placeholder 2"/>
+          <p:cNvSpPr>
+            <a:spLocks noGrp="1"/>
+          </p:cNvSpPr>
+          <p:nvPr>
+            <p:ph type="body" idx="3" sz="quarter"/>
+          </p:nvPr>
+        </p:nvSpPr>
+        <p:spPr/>
+        <p:txBody>
+          <a:bodyPr/>
+          <a:lstStyle/>
+          <a:p>
+            <a:r>
+              <a:t>RESERVE, 3 minutes. Run it after D16 in place of chapter 2 or 3 when the tally's C4 count is</a:t>
+            </a:r>
+          </a:p>
+          <a:p>
+            <a:r>
+              <a:t>higher. Then open the reference notebook, section 2, and show the empty-segment row with its</a:t>
+            </a:r>
+          </a:p>
+          <a:p>
+            <a:r>
+              <a:t>decision and reason. Ask two learners which branch their row took and where it sits in their log.</a:t>
+            </a:r>
+          </a:p>
+        </p:txBody>
+      </p:sp>
+      <p:sp>
+        <p:nvSpPr>
+          <p:cNvPr id="4" name="Slide Number Placeholder 3"/>
+          <p:cNvSpPr>
+            <a:spLocks noGrp="1"/>
+          </p:cNvSpPr>
+          <p:nvPr>
+            <p:ph type="sldNum" idx="5" sz="quarter"/>
+          </p:nvPr>
+        </p:nvSpPr>
+        <p:spPr/>
+      </p:sp>
+    </p:spTree>
+  </p:cSld>
+  <p:clrMapOvr>
+    <a:masterClrMapping/>
+  </p:clrMapOvr>
+</p:notes>
+</file>
+
+<file path=ppt/notesSlides/notesSlide22.xml><?xml version="1.0" encoding="utf-8"?>
+<p:notes xmlns:a="http://schemas.openxmlformats.org/drawingml/2006/main" xmlns:p="http://schemas.openxmlformats.org/presentationml/2006/main" xmlns:r="http://schemas.openxmlformats.org/officeDocument/2006/relationships">
+  <p:cSld>
+    <p:spTree>
+      <p:nvGrpSpPr>
+        <p:cNvPr id="1" name=""/>
+        <p:cNvGrpSpPr/>
+        <p:nvPr/>
+      </p:nvGrpSpPr>
+      <p:grpSpPr>
+        <a:xfrm>
+          <a:off x="0" y="0"/>
+          <a:ext cx="0" cy="0"/>
+          <a:chOff x="0" y="0"/>
+          <a:chExt cx="0" cy="0"/>
+        </a:xfrm>
+      </p:grpSpPr>
+      <p:sp>
+        <p:nvSpPr>
+          <p:cNvPr id="2" name="Slide Image Placeholder 1"/>
+          <p:cNvSpPr>
+            <a:spLocks noGrp="1"/>
+          </p:cNvSpPr>
+          <p:nvPr>
+            <p:ph type="sldImg" idx="2"/>
+          </p:nvPr>
+        </p:nvSpPr>
+        <p:spPr/>
+      </p:sp>
+      <p:sp>
+        <p:nvSpPr>
+          <p:cNvPr id="3" name="Notes Placeholder 2"/>
+          <p:cNvSpPr>
+            <a:spLocks noGrp="1"/>
+          </p:cNvSpPr>
+          <p:nvPr>
+            <p:ph type="body" idx="3" sz="quarter"/>
+          </p:nvPr>
+        </p:nvSpPr>
+        <p:spPr/>
+        <p:txBody>
+          <a:bodyPr/>
+          <a:lstStyle/>
+          <a:p>
+            <a:r>
               <a:t>LIVE, 2 minutes. Close the debrief. Each learner already has a step marked on their observation</a:t>
             </a:r>
           </a:p>
@@ -2021,7 +2178,7 @@
           </a:p>
           <a:p>
             <a:r>
-              <a:t>and run S14 in its place.</a:t>
+              <a:t>and run D14 in its place.</a:t>
             </a:r>
           </a:p>
         </p:txBody>
@@ -5624,7 +5781,7 @@
                 </a:solidFill>
                 <a:latin typeface="Calibri"/>
               </a:rPr>
-              <a:t>1 / 20</a:t>
+              <a:t>1 / 22</a:t>
             </a:r>
           </a:p>
         </p:txBody>
@@ -6894,7 +7051,7 @@
                 </a:solidFill>
                 <a:latin typeface="Calibri"/>
               </a:rPr>
-              <a:t>S7  ·  10 / 20</a:t>
+              <a:t>S7  ·  10 / 22</a:t>
             </a:r>
           </a:p>
         </p:txBody>
@@ -7544,7 +7701,7 @@
                 </a:solidFill>
                 <a:latin typeface="Calibri"/>
               </a:rPr>
-              <a:t>S8  ·  11 / 20</a:t>
+              <a:t>S8  ·  11 / 22</a:t>
             </a:r>
           </a:p>
         </p:txBody>
@@ -8272,7 +8429,7 @@
                 </a:solidFill>
                 <a:latin typeface="Calibri"/>
               </a:rPr>
-              <a:t>S9  ·  12 / 20</a:t>
+              <a:t>S9  ·  12 / 22</a:t>
             </a:r>
           </a:p>
         </p:txBody>
@@ -8843,7 +9000,7 @@
                 </a:solidFill>
                 <a:latin typeface="Calibri"/>
               </a:rPr>
-              <a:t>S10  ·  13 / 20</a:t>
+              <a:t>S10  ·  13 / 22</a:t>
             </a:r>
           </a:p>
         </p:txBody>
@@ -9354,7 +9511,7 @@
                 </a:solidFill>
                 <a:latin typeface="Calibri"/>
               </a:rPr>
-              <a:t>14 / 20</a:t>
+              <a:t>14 / 22</a:t>
             </a:r>
           </a:p>
         </p:txBody>
@@ -10353,7 +10510,7 @@
                 </a:solidFill>
                 <a:latin typeface="Calibri"/>
               </a:rPr>
-              <a:t>S11  ·  15 / 20</a:t>
+              <a:t>S11  ·  15 / 22</a:t>
             </a:r>
           </a:p>
         </p:txBody>
@@ -11003,7 +11160,7 @@
                 </a:solidFill>
                 <a:latin typeface="Calibri"/>
               </a:rPr>
-              <a:t>S12  ·  16 / 20</a:t>
+              <a:t>S12  ·  16 / 22</a:t>
             </a:r>
           </a:p>
         </p:txBody>
@@ -11731,7 +11888,7 @@
                 </a:solidFill>
                 <a:latin typeface="Calibri"/>
               </a:rPr>
-              <a:t>S13  ·  17 / 20</a:t>
+              <a:t>S13  ·  17 / 22</a:t>
             </a:r>
           </a:p>
         </p:txBody>
@@ -12950,7 +13107,7 @@
                 </a:solidFill>
                 <a:latin typeface="Calibri"/>
               </a:rPr>
-              <a:t>D14  ·  18 / 20</a:t>
+              <a:t>D14  ·  18 / 22</a:t>
             </a:r>
           </a:p>
         </p:txBody>
@@ -14156,7 +14313,7 @@
                 </a:solidFill>
                 <a:latin typeface="Calibri"/>
               </a:rPr>
-              <a:t>D15  ·  19 / 20</a:t>
+              <a:t>D15  ·  19 / 22</a:t>
             </a:r>
           </a:p>
         </p:txBody>
@@ -14667,7 +14824,7 @@
                 </a:solidFill>
                 <a:latin typeface="Calibri"/>
               </a:rPr>
-              <a:t>2 / 20</a:t>
+              <a:t>2 / 22</a:t>
             </a:r>
           </a:p>
         </p:txBody>
@@ -14852,6 +15009,1995 @@
         <p:spPr>
           <a:xfrm>
             <a:off x="530352" y="676656"/>
+            <a:ext cx="10033711" cy="512064"/>
+          </a:xfrm>
+          <a:prstGeom prst="rect">
+            <a:avLst/>
+          </a:prstGeom>
+          <a:noFill/>
+        </p:spPr>
+        <p:txBody>
+          <a:bodyPr wrap="square" anchor="b" lIns="0" rIns="0" tIns="0" bIns="0">
+            <a:spAutoFit/>
+          </a:bodyPr>
+          <a:lstStyle/>
+          <a:p>
+            <a:pPr algn="l"/>
+            <a:r>
+              <a:rPr sz="2600" b="0" i="0">
+                <a:solidFill>
+                  <a:srgbClr val="1A0F5C"/>
+                </a:solidFill>
+                <a:latin typeface="Georgia"/>
+              </a:rPr>
+              <a:t>Reserve: one order with no segment</a:t>
+            </a:r>
+          </a:p>
+        </p:txBody>
+      </p:sp>
+      <p:sp>
+        <p:nvSpPr>
+          <p:cNvPr id="8" name="Rounded Rectangle 7"/>
+          <p:cNvSpPr/>
+          <p:nvPr/>
+        </p:nvSpPr>
+        <p:spPr>
+          <a:xfrm>
+            <a:off x="10701223" y="822960"/>
+            <a:ext cx="960120" cy="256032"/>
+          </a:xfrm>
+          <a:prstGeom prst="roundRect">
+            <a:avLst>
+              <a:gd name="adj" fmla="val 50000"/>
+            </a:avLst>
+          </a:prstGeom>
+          <a:solidFill>
+            <a:srgbClr val="1A0F5C"/>
+          </a:solidFill>
+          <a:ln>
+            <a:noFill/>
+          </a:ln>
+          <a:effectLst/>
+        </p:spPr>
+        <p:style>
+          <a:lnRef idx="1">
+            <a:schemeClr val="accent1"/>
+          </a:lnRef>
+          <a:fillRef idx="3">
+            <a:schemeClr val="accent1"/>
+          </a:fillRef>
+          <a:effectRef idx="2">
+            <a:schemeClr val="accent1"/>
+          </a:effectRef>
+          <a:fontRef idx="minor">
+            <a:schemeClr val="lt1"/>
+          </a:fontRef>
+        </p:style>
+        <p:txBody>
+          <a:bodyPr rtlCol="0" anchor="ctr" wrap="none" lIns="25400" rIns="25400" tIns="0" bIns="0"/>
+          <a:lstStyle/>
+          <a:p>
+            <a:pPr algn="ctr"/>
+            <a:r>
+              <a:rPr sz="800" b="1" spc="200">
+                <a:solidFill>
+                  <a:srgbClr val="FFFFFF"/>
+                </a:solidFill>
+                <a:latin typeface="Calibri"/>
+              </a:rPr>
+              <a:t>DEPTH</a:t>
+            </a:r>
+          </a:p>
+        </p:txBody>
+      </p:sp>
+      <p:sp>
+        <p:nvSpPr>
+          <p:cNvPr id="9" name="TextBox 8"/>
+          <p:cNvSpPr txBox="1"/>
+          <p:nvPr/>
+        </p:nvSpPr>
+        <p:spPr>
+          <a:xfrm>
+            <a:off x="530352" y="1243584"/>
+            <a:ext cx="11130991" cy="234696"/>
+          </a:xfrm>
+          <a:prstGeom prst="rect">
+            <a:avLst/>
+          </a:prstGeom>
+          <a:noFill/>
+        </p:spPr>
+        <p:txBody>
+          <a:bodyPr wrap="square" anchor="t" lIns="0" rIns="0" tIns="0" bIns="0">
+            <a:spAutoFit/>
+          </a:bodyPr>
+          <a:lstStyle/>
+          <a:p>
+            <a:pPr algn="l"/>
+            <a:r>
+              <a:rPr sz="1200" b="0" i="0">
+                <a:solidFill>
+                  <a:srgbClr val="6B6690"/>
+                </a:solidFill>
+                <a:latin typeface="Calibri"/>
+              </a:rPr>
+              <a:t>Invented numbers: Retail-Plus on 30 orders a quarter as read, and one Q2 order whose segment cell is empty.</a:t>
+            </a:r>
+          </a:p>
+        </p:txBody>
+      </p:sp>
+      <p:sp>
+        <p:nvSpPr>
+          <p:cNvPr id="10" name="TextBox 9"/>
+          <p:cNvSpPr txBox="1"/>
+          <p:nvPr/>
+        </p:nvSpPr>
+        <p:spPr>
+          <a:xfrm>
+            <a:off x="530352" y="1956816"/>
+            <a:ext cx="3527450" cy="698500"/>
+          </a:xfrm>
+          <a:prstGeom prst="rect">
+            <a:avLst/>
+          </a:prstGeom>
+          <a:noFill/>
+        </p:spPr>
+        <p:txBody>
+          <a:bodyPr wrap="square" anchor="t" lIns="0" rIns="0" tIns="0" bIns="0">
+            <a:spAutoFit/>
+          </a:bodyPr>
+          <a:lstStyle/>
+          <a:p>
+            <a:pPr algn="l"/>
+            <a:r>
+              <a:rPr sz="4400" b="0" i="0">
+                <a:solidFill>
+                  <a:srgbClr val="5B3FD6"/>
+                </a:solidFill>
+                <a:latin typeface="Georgia"/>
+              </a:rPr>
+              <a:t>Rs 84,000</a:t>
+            </a:r>
+          </a:p>
+        </p:txBody>
+      </p:sp>
+      <p:sp>
+        <p:nvSpPr>
+          <p:cNvPr id="11" name="TextBox 10"/>
+          <p:cNvSpPr txBox="1"/>
+          <p:nvPr/>
+        </p:nvSpPr>
+        <p:spPr>
+          <a:xfrm>
+            <a:off x="530352" y="2691892"/>
+            <a:ext cx="3527450" cy="168656"/>
+          </a:xfrm>
+          <a:prstGeom prst="rect">
+            <a:avLst/>
+          </a:prstGeom>
+          <a:noFill/>
+        </p:spPr>
+        <p:txBody>
+          <a:bodyPr wrap="square" anchor="t" lIns="0" rIns="0" tIns="0" bIns="0">
+            <a:spAutoFit/>
+          </a:bodyPr>
+          <a:lstStyle/>
+          <a:p>
+            <a:pPr algn="l"/>
+            <a:r>
+              <a:rPr sz="800" b="1" i="0" spc="250">
+                <a:solidFill>
+                  <a:srgbClr val="1A0F5C"/>
+                </a:solidFill>
+                <a:latin typeface="Calibri"/>
+              </a:rPr>
+              <a:t>RETAIL-PLUS Q1</a:t>
+            </a:r>
+          </a:p>
+        </p:txBody>
+      </p:sp>
+      <p:sp>
+        <p:nvSpPr>
+          <p:cNvPr id="12" name="TextBox 11"/>
+          <p:cNvSpPr txBox="1"/>
+          <p:nvPr/>
+        </p:nvSpPr>
+        <p:spPr>
+          <a:xfrm>
+            <a:off x="530352" y="2893060"/>
+            <a:ext cx="3527450" cy="193421"/>
+          </a:xfrm>
+          <a:prstGeom prst="rect">
+            <a:avLst/>
+          </a:prstGeom>
+          <a:noFill/>
+        </p:spPr>
+        <p:txBody>
+          <a:bodyPr wrap="square" anchor="t" lIns="0" rIns="0" tIns="0" bIns="0">
+            <a:spAutoFit/>
+          </a:bodyPr>
+          <a:lstStyle/>
+          <a:p>
+            <a:pPr algn="l"/>
+            <a:r>
+              <a:rPr sz="950" b="0" i="0">
+                <a:solidFill>
+                  <a:srgbClr val="6B6690"/>
+                </a:solidFill>
+                <a:latin typeface="Calibri"/>
+              </a:rPr>
+              <a:t>invented</a:t>
+            </a:r>
+          </a:p>
+        </p:txBody>
+      </p:sp>
+      <p:sp>
+        <p:nvSpPr>
+          <p:cNvPr id="13" name="Rectangle 12"/>
+          <p:cNvSpPr/>
+          <p:nvPr/>
+        </p:nvSpPr>
+        <p:spPr>
+          <a:xfrm>
+            <a:off x="530352" y="3145536"/>
+            <a:ext cx="3527450" cy="10972"/>
+          </a:xfrm>
+          <a:prstGeom prst="rect">
+            <a:avLst/>
+          </a:prstGeom>
+          <a:solidFill>
+            <a:srgbClr val="E4E1F1"/>
+          </a:solidFill>
+          <a:ln>
+            <a:noFill/>
+          </a:ln>
+          <a:effectLst/>
+        </p:spPr>
+        <p:style>
+          <a:lnRef idx="1">
+            <a:schemeClr val="accent1"/>
+          </a:lnRef>
+          <a:fillRef idx="3">
+            <a:schemeClr val="accent1"/>
+          </a:fillRef>
+          <a:effectRef idx="2">
+            <a:schemeClr val="accent1"/>
+          </a:effectRef>
+          <a:fontRef idx="minor">
+            <a:schemeClr val="lt1"/>
+          </a:fontRef>
+        </p:style>
+        <p:txBody>
+          <a:bodyPr rtlCol="0" anchor="ctr" wrap="square"/>
+          <a:lstStyle/>
+          <a:p>
+            <a:pPr algn="ctr"/>
+          </a:p>
+        </p:txBody>
+      </p:sp>
+      <p:sp>
+        <p:nvSpPr>
+          <p:cNvPr id="14" name="TextBox 13"/>
+          <p:cNvSpPr txBox="1"/>
+          <p:nvPr/>
+        </p:nvSpPr>
+        <p:spPr>
+          <a:xfrm>
+            <a:off x="4332122" y="1956816"/>
+            <a:ext cx="3527450" cy="698500"/>
+          </a:xfrm>
+          <a:prstGeom prst="rect">
+            <a:avLst/>
+          </a:prstGeom>
+          <a:noFill/>
+        </p:spPr>
+        <p:txBody>
+          <a:bodyPr wrap="square" anchor="t" lIns="0" rIns="0" tIns="0" bIns="0">
+            <a:spAutoFit/>
+          </a:bodyPr>
+          <a:lstStyle/>
+          <a:p>
+            <a:pPr algn="l"/>
+            <a:r>
+              <a:rPr sz="4400" b="0" i="0">
+                <a:solidFill>
+                  <a:srgbClr val="5B3FD6"/>
+                </a:solidFill>
+                <a:latin typeface="Georgia"/>
+              </a:rPr>
+              <a:t>Rs 82,100</a:t>
+            </a:r>
+          </a:p>
+        </p:txBody>
+      </p:sp>
+      <p:sp>
+        <p:nvSpPr>
+          <p:cNvPr id="15" name="TextBox 14"/>
+          <p:cNvSpPr txBox="1"/>
+          <p:nvPr/>
+        </p:nvSpPr>
+        <p:spPr>
+          <a:xfrm>
+            <a:off x="4332122" y="2691892"/>
+            <a:ext cx="3527450" cy="168656"/>
+          </a:xfrm>
+          <a:prstGeom prst="rect">
+            <a:avLst/>
+          </a:prstGeom>
+          <a:noFill/>
+        </p:spPr>
+        <p:txBody>
+          <a:bodyPr wrap="square" anchor="t" lIns="0" rIns="0" tIns="0" bIns="0">
+            <a:spAutoFit/>
+          </a:bodyPr>
+          <a:lstStyle/>
+          <a:p>
+            <a:pPr algn="l"/>
+            <a:r>
+              <a:rPr sz="800" b="1" i="0" spc="250">
+                <a:solidFill>
+                  <a:srgbClr val="1A0F5C"/>
+                </a:solidFill>
+                <a:latin typeface="Calibri"/>
+              </a:rPr>
+              <a:t>Q2, BLANK LEFT OUT</a:t>
+            </a:r>
+          </a:p>
+        </p:txBody>
+      </p:sp>
+      <p:sp>
+        <p:nvSpPr>
+          <p:cNvPr id="16" name="TextBox 15"/>
+          <p:cNvSpPr txBox="1"/>
+          <p:nvPr/>
+        </p:nvSpPr>
+        <p:spPr>
+          <a:xfrm>
+            <a:off x="4332122" y="2893060"/>
+            <a:ext cx="3527450" cy="193421"/>
+          </a:xfrm>
+          <a:prstGeom prst="rect">
+            <a:avLst/>
+          </a:prstGeom>
+          <a:noFill/>
+        </p:spPr>
+        <p:txBody>
+          <a:bodyPr wrap="square" anchor="t" lIns="0" rIns="0" tIns="0" bIns="0">
+            <a:spAutoFit/>
+          </a:bodyPr>
+          <a:lstStyle/>
+          <a:p>
+            <a:pPr algn="l"/>
+            <a:r>
+              <a:rPr sz="950" b="0" i="0">
+                <a:solidFill>
+                  <a:srgbClr val="6B6690"/>
+                </a:solidFill>
+                <a:latin typeface="Calibri"/>
+              </a:rPr>
+              <a:t>invented</a:t>
+            </a:r>
+          </a:p>
+        </p:txBody>
+      </p:sp>
+      <p:sp>
+        <p:nvSpPr>
+          <p:cNvPr id="17" name="Rectangle 16"/>
+          <p:cNvSpPr/>
+          <p:nvPr/>
+        </p:nvSpPr>
+        <p:spPr>
+          <a:xfrm>
+            <a:off x="4332122" y="3145536"/>
+            <a:ext cx="3527450" cy="10972"/>
+          </a:xfrm>
+          <a:prstGeom prst="rect">
+            <a:avLst/>
+          </a:prstGeom>
+          <a:solidFill>
+            <a:srgbClr val="E4E1F1"/>
+          </a:solidFill>
+          <a:ln>
+            <a:noFill/>
+          </a:ln>
+          <a:effectLst/>
+        </p:spPr>
+        <p:style>
+          <a:lnRef idx="1">
+            <a:schemeClr val="accent1"/>
+          </a:lnRef>
+          <a:fillRef idx="3">
+            <a:schemeClr val="accent1"/>
+          </a:fillRef>
+          <a:effectRef idx="2">
+            <a:schemeClr val="accent1"/>
+          </a:effectRef>
+          <a:fontRef idx="minor">
+            <a:schemeClr val="lt1"/>
+          </a:fontRef>
+        </p:style>
+        <p:txBody>
+          <a:bodyPr rtlCol="0" anchor="ctr" wrap="square"/>
+          <a:lstStyle/>
+          <a:p>
+            <a:pPr algn="ctr"/>
+          </a:p>
+        </p:txBody>
+      </p:sp>
+      <p:sp>
+        <p:nvSpPr>
+          <p:cNvPr id="18" name="TextBox 17"/>
+          <p:cNvSpPr txBox="1"/>
+          <p:nvPr/>
+        </p:nvSpPr>
+        <p:spPr>
+          <a:xfrm>
+            <a:off x="8133892" y="1956816"/>
+            <a:ext cx="3527450" cy="698500"/>
+          </a:xfrm>
+          <a:prstGeom prst="rect">
+            <a:avLst/>
+          </a:prstGeom>
+          <a:noFill/>
+        </p:spPr>
+        <p:txBody>
+          <a:bodyPr wrap="square" anchor="t" lIns="0" rIns="0" tIns="0" bIns="0">
+            <a:spAutoFit/>
+          </a:bodyPr>
+          <a:lstStyle/>
+          <a:p>
+            <a:pPr algn="l"/>
+            <a:r>
+              <a:rPr sz="4400" b="0" i="0">
+                <a:solidFill>
+                  <a:srgbClr val="5B3FD6"/>
+                </a:solidFill>
+                <a:latin typeface="Georgia"/>
+              </a:rPr>
+              <a:t>-2.3%</a:t>
+            </a:r>
+          </a:p>
+        </p:txBody>
+      </p:sp>
+      <p:sp>
+        <p:nvSpPr>
+          <p:cNvPr id="19" name="TextBox 18"/>
+          <p:cNvSpPr txBox="1"/>
+          <p:nvPr/>
+        </p:nvSpPr>
+        <p:spPr>
+          <a:xfrm>
+            <a:off x="8133892" y="2691892"/>
+            <a:ext cx="3527450" cy="168656"/>
+          </a:xfrm>
+          <a:prstGeom prst="rect">
+            <a:avLst/>
+          </a:prstGeom>
+          <a:noFill/>
+        </p:spPr>
+        <p:txBody>
+          <a:bodyPr wrap="square" anchor="t" lIns="0" rIns="0" tIns="0" bIns="0">
+            <a:spAutoFit/>
+          </a:bodyPr>
+          <a:lstStyle/>
+          <a:p>
+            <a:pPr algn="l"/>
+            <a:r>
+              <a:rPr sz="800" b="1" i="0" spc="250">
+                <a:solidFill>
+                  <a:srgbClr val="1A0F5C"/>
+                </a:solidFill>
+                <a:latin typeface="Calibri"/>
+              </a:rPr>
+              <a:t>Q1 TO Q2</a:t>
+            </a:r>
+          </a:p>
+        </p:txBody>
+      </p:sp>
+      <p:sp>
+        <p:nvSpPr>
+          <p:cNvPr id="20" name="TextBox 19"/>
+          <p:cNvSpPr txBox="1"/>
+          <p:nvPr/>
+        </p:nvSpPr>
+        <p:spPr>
+          <a:xfrm>
+            <a:off x="8133892" y="2893060"/>
+            <a:ext cx="3527450" cy="193421"/>
+          </a:xfrm>
+          <a:prstGeom prst="rect">
+            <a:avLst/>
+          </a:prstGeom>
+          <a:noFill/>
+        </p:spPr>
+        <p:txBody>
+          <a:bodyPr wrap="square" anchor="t" lIns="0" rIns="0" tIns="0" bIns="0">
+            <a:spAutoFit/>
+          </a:bodyPr>
+          <a:lstStyle/>
+          <a:p>
+            <a:pPr algn="l"/>
+            <a:r>
+              <a:rPr sz="950" b="0" i="0">
+                <a:solidFill>
+                  <a:srgbClr val="6B6690"/>
+                </a:solidFill>
+                <a:latin typeface="Calibri"/>
+              </a:rPr>
+              <a:t>"Retail-Plus has turned down"</a:t>
+            </a:r>
+          </a:p>
+        </p:txBody>
+      </p:sp>
+      <p:sp>
+        <p:nvSpPr>
+          <p:cNvPr id="21" name="Rectangle 20"/>
+          <p:cNvSpPr/>
+          <p:nvPr/>
+        </p:nvSpPr>
+        <p:spPr>
+          <a:xfrm>
+            <a:off x="8133892" y="3145536"/>
+            <a:ext cx="3527450" cy="10972"/>
+          </a:xfrm>
+          <a:prstGeom prst="rect">
+            <a:avLst/>
+          </a:prstGeom>
+          <a:solidFill>
+            <a:srgbClr val="E4E1F1"/>
+          </a:solidFill>
+          <a:ln>
+            <a:noFill/>
+          </a:ln>
+          <a:effectLst/>
+        </p:spPr>
+        <p:style>
+          <a:lnRef idx="1">
+            <a:schemeClr val="accent1"/>
+          </a:lnRef>
+          <a:fillRef idx="3">
+            <a:schemeClr val="accent1"/>
+          </a:fillRef>
+          <a:effectRef idx="2">
+            <a:schemeClr val="accent1"/>
+          </a:effectRef>
+          <a:fontRef idx="minor">
+            <a:schemeClr val="lt1"/>
+          </a:fontRef>
+        </p:style>
+        <p:txBody>
+          <a:bodyPr rtlCol="0" anchor="ctr" wrap="square"/>
+          <a:lstStyle/>
+          <a:p>
+            <a:pPr algn="ctr"/>
+          </a:p>
+        </p:txBody>
+      </p:sp>
+      <p:sp>
+        <p:nvSpPr>
+          <p:cNvPr id="22" name="Rounded Rectangle 21"/>
+          <p:cNvSpPr/>
+          <p:nvPr/>
+        </p:nvSpPr>
+        <p:spPr>
+          <a:xfrm>
+            <a:off x="530352" y="3419856"/>
+            <a:ext cx="11130991" cy="1380744"/>
+          </a:xfrm>
+          <a:prstGeom prst="roundRect">
+            <a:avLst>
+              <a:gd name="adj" fmla="val 5000"/>
+            </a:avLst>
+          </a:prstGeom>
+          <a:solidFill>
+            <a:srgbClr val="F7F5FD"/>
+          </a:solidFill>
+          <a:ln w="9525">
+            <a:solidFill>
+              <a:srgbClr val="E4E1F1"/>
+            </a:solidFill>
+          </a:ln>
+          <a:effectLst>
+            <a:outerShdw blurRad="76200" dist="19050" dir="5400000" algn="bl" rotWithShape="0">
+              <a:srgbClr val="1A0F5C">
+                <a:alpha val="12000"/>
+              </a:srgbClr>
+            </a:outerShdw>
+          </a:effectLst>
+        </p:spPr>
+        <p:style>
+          <a:lnRef idx="1">
+            <a:schemeClr val="accent1"/>
+          </a:lnRef>
+          <a:fillRef idx="3">
+            <a:schemeClr val="accent1"/>
+          </a:fillRef>
+          <a:effectRef idx="2">
+            <a:schemeClr val="accent1"/>
+          </a:effectRef>
+          <a:fontRef idx="minor">
+            <a:schemeClr val="lt1"/>
+          </a:fontRef>
+        </p:style>
+        <p:txBody>
+          <a:bodyPr rtlCol="0" anchor="ctr" wrap="square"/>
+          <a:lstStyle/>
+          <a:p>
+            <a:pPr algn="ctr"/>
+          </a:p>
+        </p:txBody>
+      </p:sp>
+      <p:sp>
+        <p:nvSpPr>
+          <p:cNvPr id="23" name="Oval 22"/>
+          <p:cNvSpPr/>
+          <p:nvPr/>
+        </p:nvSpPr>
+        <p:spPr>
+          <a:xfrm>
+            <a:off x="758952" y="3881628"/>
+            <a:ext cx="457200" cy="457200"/>
+          </a:xfrm>
+          <a:prstGeom prst="ellipse">
+            <a:avLst/>
+          </a:prstGeom>
+          <a:solidFill>
+            <a:srgbClr val="5B3FD6"/>
+          </a:solidFill>
+          <a:ln>
+            <a:noFill/>
+          </a:ln>
+          <a:effectLst/>
+        </p:spPr>
+        <p:style>
+          <a:lnRef idx="1">
+            <a:schemeClr val="accent1"/>
+          </a:lnRef>
+          <a:fillRef idx="3">
+            <a:schemeClr val="accent1"/>
+          </a:fillRef>
+          <a:effectRef idx="2">
+            <a:schemeClr val="accent1"/>
+          </a:effectRef>
+          <a:fontRef idx="minor">
+            <a:schemeClr val="lt1"/>
+          </a:fontRef>
+        </p:style>
+        <p:txBody>
+          <a:bodyPr rtlCol="0" anchor="ctr" wrap="square"/>
+          <a:lstStyle/>
+          <a:p>
+            <a:pPr algn="ctr"/>
+          </a:p>
+        </p:txBody>
+      </p:sp>
+      <p:pic>
+        <p:nvPicPr>
+          <p:cNvPr id="24" name="Picture 23" descr="bug_39ada6eff46d.png"/>
+          <p:cNvPicPr>
+            <a:picLocks noChangeAspect="1"/>
+          </p:cNvPicPr>
+          <p:nvPr/>
+        </p:nvPicPr>
+        <p:blipFill>
+          <a:blip r:embed="rId4"/>
+          <a:stretch>
+            <a:fillRect/>
+          </a:stretch>
+        </p:blipFill>
+        <p:spPr>
+          <a:xfrm>
+            <a:off x="868680" y="3991356"/>
+            <a:ext cx="237744" cy="237744"/>
+          </a:xfrm>
+          <a:prstGeom prst="rect">
+            <a:avLst/>
+          </a:prstGeom>
+        </p:spPr>
+      </p:pic>
+      <p:sp>
+        <p:nvSpPr>
+          <p:cNvPr id="25" name="TextBox 24"/>
+          <p:cNvSpPr txBox="1"/>
+          <p:nvPr/>
+        </p:nvSpPr>
+        <p:spPr>
+          <a:xfrm>
+            <a:off x="1399031" y="3566160"/>
+            <a:ext cx="9987991" cy="160401"/>
+          </a:xfrm>
+          <a:prstGeom prst="rect">
+            <a:avLst/>
+          </a:prstGeom>
+          <a:noFill/>
+        </p:spPr>
+        <p:txBody>
+          <a:bodyPr wrap="square" anchor="t" lIns="0" rIns="0" tIns="0" bIns="0">
+            <a:spAutoFit/>
+          </a:bodyPr>
+          <a:lstStyle/>
+          <a:p>
+            <a:pPr algn="l"/>
+            <a:r>
+              <a:rPr sz="750" b="1" i="0" spc="250">
+                <a:solidFill>
+                  <a:srgbClr val="5B3FD6"/>
+                </a:solidFill>
+                <a:latin typeface="Calibri"/>
+              </a:rPr>
+              <a:t>WHAT BREAKS</a:t>
+            </a:r>
+          </a:p>
+        </p:txBody>
+      </p:sp>
+      <p:sp>
+        <p:nvSpPr>
+          <p:cNvPr id="26" name="TextBox 25"/>
+          <p:cNvSpPr txBox="1"/>
+          <p:nvPr/>
+        </p:nvSpPr>
+        <p:spPr>
+          <a:xfrm>
+            <a:off x="1399031" y="3785616"/>
+            <a:ext cx="9987991" cy="941832"/>
+          </a:xfrm>
+          <a:prstGeom prst="rect">
+            <a:avLst/>
+          </a:prstGeom>
+          <a:noFill/>
+        </p:spPr>
+        <p:txBody>
+          <a:bodyPr wrap="square" anchor="t" lIns="0" rIns="0" tIns="0" bIns="0">
+            <a:spAutoFit/>
+          </a:bodyPr>
+          <a:lstStyle/>
+          <a:p>
+            <a:r>
+              <a:rPr sz="1500" b="0" i="0">
+                <a:solidFill>
+                  <a:srgbClr val="1A1440"/>
+                </a:solidFill>
+                <a:latin typeface="Calibri"/>
+              </a:rPr>
+              <a:t>A filter on the segment name never sees the empty cell, so the Rs 3,100 order drops out of Retail-Plus without an error. A tier that grew reads as a second falling segment, and the note sends Meera a Retail-Plus win-back plan for a fall that never happened.</a:t>
+            </a:r>
+          </a:p>
+        </p:txBody>
+      </p:sp>
+      <p:sp>
+        <p:nvSpPr>
+          <p:cNvPr id="27" name="Oval 26"/>
+          <p:cNvSpPr/>
+          <p:nvPr/>
+        </p:nvSpPr>
+        <p:spPr>
+          <a:xfrm>
+            <a:off x="530352" y="6492240"/>
+            <a:ext cx="64008" cy="64008"/>
+          </a:xfrm>
+          <a:prstGeom prst="ellipse">
+            <a:avLst/>
+          </a:prstGeom>
+          <a:solidFill>
+            <a:srgbClr val="CFC9EE"/>
+          </a:solidFill>
+          <a:ln>
+            <a:noFill/>
+          </a:ln>
+          <a:effectLst/>
+        </p:spPr>
+        <p:style>
+          <a:lnRef idx="1">
+            <a:schemeClr val="accent1"/>
+          </a:lnRef>
+          <a:fillRef idx="3">
+            <a:schemeClr val="accent1"/>
+          </a:fillRef>
+          <a:effectRef idx="2">
+            <a:schemeClr val="accent1"/>
+          </a:effectRef>
+          <a:fontRef idx="minor">
+            <a:schemeClr val="lt1"/>
+          </a:fontRef>
+        </p:style>
+        <p:txBody>
+          <a:bodyPr rtlCol="0" anchor="ctr" wrap="square"/>
+          <a:lstStyle/>
+          <a:p>
+            <a:pPr algn="ctr"/>
+          </a:p>
+        </p:txBody>
+      </p:sp>
+      <p:sp>
+        <p:nvSpPr>
+          <p:cNvPr id="28" name="TextBox 27"/>
+          <p:cNvSpPr txBox="1"/>
+          <p:nvPr/>
+        </p:nvSpPr>
+        <p:spPr>
+          <a:xfrm>
+            <a:off x="640080" y="6437376"/>
+            <a:ext cx="1516475" cy="152146"/>
+          </a:xfrm>
+          <a:prstGeom prst="rect">
+            <a:avLst/>
+          </a:prstGeom>
+          <a:noFill/>
+        </p:spPr>
+        <p:txBody>
+          <a:bodyPr wrap="square" anchor="t" lIns="0" rIns="0" tIns="0" bIns="0">
+            <a:spAutoFit/>
+          </a:bodyPr>
+          <a:lstStyle/>
+          <a:p>
+            <a:pPr algn="l"/>
+            <a:r>
+              <a:rPr sz="700" b="0" i="0">
+                <a:solidFill>
+                  <a:srgbClr val="6B6690"/>
+                </a:solidFill>
+                <a:latin typeface="Calibri"/>
+              </a:rPr>
+              <a:t>The reconciliation, skipped</a:t>
+            </a:r>
+          </a:p>
+        </p:txBody>
+      </p:sp>
+      <p:sp>
+        <p:nvSpPr>
+          <p:cNvPr id="29" name="Oval 28"/>
+          <p:cNvSpPr/>
+          <p:nvPr/>
+        </p:nvSpPr>
+        <p:spPr>
+          <a:xfrm>
+            <a:off x="2247995" y="6492240"/>
+            <a:ext cx="64008" cy="64008"/>
+          </a:xfrm>
+          <a:prstGeom prst="ellipse">
+            <a:avLst/>
+          </a:prstGeom>
+          <a:solidFill>
+            <a:srgbClr val="CFC9EE"/>
+          </a:solidFill>
+          <a:ln>
+            <a:noFill/>
+          </a:ln>
+          <a:effectLst/>
+        </p:spPr>
+        <p:style>
+          <a:lnRef idx="1">
+            <a:schemeClr val="accent1"/>
+          </a:lnRef>
+          <a:fillRef idx="3">
+            <a:schemeClr val="accent1"/>
+          </a:fillRef>
+          <a:effectRef idx="2">
+            <a:schemeClr val="accent1"/>
+          </a:effectRef>
+          <a:fontRef idx="minor">
+            <a:schemeClr val="lt1"/>
+          </a:fontRef>
+        </p:style>
+        <p:txBody>
+          <a:bodyPr rtlCol="0" anchor="ctr" wrap="square"/>
+          <a:lstStyle/>
+          <a:p>
+            <a:pPr algn="ctr"/>
+          </a:p>
+        </p:txBody>
+      </p:sp>
+      <p:sp>
+        <p:nvSpPr>
+          <p:cNvPr id="30" name="TextBox 29"/>
+          <p:cNvSpPr txBox="1"/>
+          <p:nvPr/>
+        </p:nvSpPr>
+        <p:spPr>
+          <a:xfrm>
+            <a:off x="2357723" y="6437376"/>
+            <a:ext cx="1424463" cy="152146"/>
+          </a:xfrm>
+          <a:prstGeom prst="rect">
+            <a:avLst/>
+          </a:prstGeom>
+          <a:noFill/>
+        </p:spPr>
+        <p:txBody>
+          <a:bodyPr wrap="square" anchor="t" lIns="0" rIns="0" tIns="0" bIns="0">
+            <a:spAutoFit/>
+          </a:bodyPr>
+          <a:lstStyle/>
+          <a:p>
+            <a:pPr algn="l"/>
+            <a:r>
+              <a:rPr sz="700" b="0" i="0">
+                <a:solidFill>
+                  <a:srgbClr val="6B6690"/>
+                </a:solidFill>
+                <a:latin typeface="Calibri"/>
+              </a:rPr>
+              <a:t>The pass that looks clean</a:t>
+            </a:r>
+          </a:p>
+        </p:txBody>
+      </p:sp>
+      <p:sp>
+        <p:nvSpPr>
+          <p:cNvPr id="31" name="Oval 30"/>
+          <p:cNvSpPr/>
+          <p:nvPr/>
+        </p:nvSpPr>
+        <p:spPr>
+          <a:xfrm>
+            <a:off x="3873627" y="6492240"/>
+            <a:ext cx="64008" cy="64008"/>
+          </a:xfrm>
+          <a:prstGeom prst="ellipse">
+            <a:avLst/>
+          </a:prstGeom>
+          <a:solidFill>
+            <a:srgbClr val="5B3FD6"/>
+          </a:solidFill>
+          <a:ln>
+            <a:noFill/>
+          </a:ln>
+          <a:effectLst/>
+        </p:spPr>
+        <p:style>
+          <a:lnRef idx="1">
+            <a:schemeClr val="accent1"/>
+          </a:lnRef>
+          <a:fillRef idx="3">
+            <a:schemeClr val="accent1"/>
+          </a:fillRef>
+          <a:effectRef idx="2">
+            <a:schemeClr val="accent1"/>
+          </a:effectRef>
+          <a:fontRef idx="minor">
+            <a:schemeClr val="lt1"/>
+          </a:fontRef>
+        </p:style>
+        <p:txBody>
+          <a:bodyPr rtlCol="0" anchor="ctr" wrap="square"/>
+          <a:lstStyle/>
+          <a:p>
+            <a:pPr algn="ctr"/>
+          </a:p>
+        </p:txBody>
+      </p:sp>
+      <p:sp>
+        <p:nvSpPr>
+          <p:cNvPr id="32" name="TextBox 31"/>
+          <p:cNvSpPr txBox="1"/>
+          <p:nvPr/>
+        </p:nvSpPr>
+        <p:spPr>
+          <a:xfrm>
+            <a:off x="3983355" y="6437376"/>
+            <a:ext cx="1654492" cy="152146"/>
+          </a:xfrm>
+          <a:prstGeom prst="rect">
+            <a:avLst/>
+          </a:prstGeom>
+          <a:noFill/>
+        </p:spPr>
+        <p:txBody>
+          <a:bodyPr wrap="square" anchor="t" lIns="0" rIns="0" tIns="0" bIns="0">
+            <a:spAutoFit/>
+          </a:bodyPr>
+          <a:lstStyle/>
+          <a:p>
+            <a:pPr algn="l"/>
+            <a:r>
+              <a:rPr sz="700" b="1" i="0">
+                <a:solidFill>
+                  <a:srgbClr val="5B3FD6"/>
+                </a:solidFill>
+                <a:latin typeface="Calibri"/>
+              </a:rPr>
+              <a:t>The headline on too few orders</a:t>
+            </a:r>
+          </a:p>
+        </p:txBody>
+      </p:sp>
+      <p:sp>
+        <p:nvSpPr>
+          <p:cNvPr id="33" name="TextBox 32"/>
+          <p:cNvSpPr txBox="1"/>
+          <p:nvPr/>
+        </p:nvSpPr>
+        <p:spPr>
+          <a:xfrm>
+            <a:off x="10198303" y="6437376"/>
+            <a:ext cx="1463040" cy="160401"/>
+          </a:xfrm>
+          <a:prstGeom prst="rect">
+            <a:avLst/>
+          </a:prstGeom>
+          <a:noFill/>
+        </p:spPr>
+        <p:txBody>
+          <a:bodyPr wrap="square" anchor="t" lIns="0" rIns="0" tIns="0" bIns="0">
+            <a:spAutoFit/>
+          </a:bodyPr>
+          <a:lstStyle/>
+          <a:p>
+            <a:pPr algn="r"/>
+            <a:r>
+              <a:rPr sz="750" b="0" i="0">
+                <a:solidFill>
+                  <a:srgbClr val="6B6690"/>
+                </a:solidFill>
+                <a:latin typeface="Calibri"/>
+              </a:rPr>
+              <a:t>D16  ·  20 / 22</a:t>
+            </a:r>
+          </a:p>
+        </p:txBody>
+      </p:sp>
+    </p:spTree>
+  </p:cSld>
+  <p:clrMapOvr>
+    <a:masterClrMapping/>
+  </p:clrMapOvr>
+</p:sld>
+</file>
+
+<file path=ppt/slides/slide21.xml><?xml version="1.0" encoding="utf-8"?>
+<p:sld xmlns:a="http://schemas.openxmlformats.org/drawingml/2006/main" xmlns:p="http://schemas.openxmlformats.org/presentationml/2006/main" xmlns:r="http://schemas.openxmlformats.org/officeDocument/2006/relationships">
+  <p:cSld>
+    <p:spTree>
+      <p:nvGrpSpPr>
+        <p:cNvPr id="1" name=""/>
+        <p:cNvGrpSpPr/>
+        <p:nvPr/>
+      </p:nvGrpSpPr>
+      <p:grpSpPr/>
+      <p:pic>
+        <p:nvPicPr>
+          <p:cNvPr id="2" name="Picture 1" descr="bg_light.jpg"/>
+          <p:cNvPicPr>
+            <a:picLocks noChangeAspect="1"/>
+          </p:cNvPicPr>
+          <p:nvPr/>
+        </p:nvPicPr>
+        <p:blipFill>
+          <a:blip r:embed="rId2"/>
+          <a:stretch>
+            <a:fillRect/>
+          </a:stretch>
+        </p:blipFill>
+        <p:spPr>
+          <a:xfrm>
+            <a:off x="0" y="0"/>
+            <a:ext cx="12191695" cy="6858000"/>
+          </a:xfrm>
+          <a:prstGeom prst="rect">
+            <a:avLst/>
+          </a:prstGeom>
+        </p:spPr>
+      </p:pic>
+      <p:pic>
+        <p:nvPicPr>
+          <p:cNvPr id="3" name="Picture 2" descr="iitgn_logo.png"/>
+          <p:cNvPicPr>
+            <a:picLocks noChangeAspect="1"/>
+          </p:cNvPicPr>
+          <p:nvPr/>
+        </p:nvPicPr>
+        <p:blipFill>
+          <a:blip r:embed="rId3"/>
+          <a:stretch>
+            <a:fillRect/>
+          </a:stretch>
+        </p:blipFill>
+        <p:spPr>
+          <a:xfrm>
+            <a:off x="530352" y="201168"/>
+            <a:ext cx="420624" cy="420624"/>
+          </a:xfrm>
+          <a:prstGeom prst="rect">
+            <a:avLst/>
+          </a:prstGeom>
+        </p:spPr>
+      </p:pic>
+      <p:sp>
+        <p:nvSpPr>
+          <p:cNvPr id="4" name="TextBox 3"/>
+          <p:cNvSpPr txBox="1"/>
+          <p:nvPr/>
+        </p:nvSpPr>
+        <p:spPr>
+          <a:xfrm>
+            <a:off x="1042416" y="228600"/>
+            <a:ext cx="5120640" cy="185166"/>
+          </a:xfrm>
+          <a:prstGeom prst="rect">
+            <a:avLst/>
+          </a:prstGeom>
+          <a:noFill/>
+        </p:spPr>
+        <p:txBody>
+          <a:bodyPr wrap="square" anchor="t" lIns="0" rIns="0" tIns="0" bIns="0">
+            <a:spAutoFit/>
+          </a:bodyPr>
+          <a:lstStyle/>
+          <a:p>
+            <a:pPr algn="l"/>
+            <a:r>
+              <a:rPr sz="900" b="1" i="0">
+                <a:solidFill>
+                  <a:srgbClr val="1A0F5C"/>
+                </a:solidFill>
+                <a:latin typeface="Calibri"/>
+              </a:rPr>
+              <a:t>Indian Institute of Technology Gandhinagar</a:t>
+            </a:r>
+          </a:p>
+        </p:txBody>
+      </p:sp>
+      <p:sp>
+        <p:nvSpPr>
+          <p:cNvPr id="5" name="TextBox 4"/>
+          <p:cNvSpPr txBox="1"/>
+          <p:nvPr/>
+        </p:nvSpPr>
+        <p:spPr>
+          <a:xfrm>
+            <a:off x="1042416" y="420623"/>
+            <a:ext cx="5852160" cy="127381"/>
+          </a:xfrm>
+          <a:prstGeom prst="rect">
+            <a:avLst/>
+          </a:prstGeom>
+          <a:noFill/>
+        </p:spPr>
+        <p:txBody>
+          <a:bodyPr wrap="square" anchor="t" lIns="0" rIns="0" tIns="0" bIns="0">
+            <a:spAutoFit/>
+          </a:bodyPr>
+          <a:lstStyle/>
+          <a:p>
+            <a:pPr algn="l"/>
+            <a:r>
+              <a:rPr sz="550" b="1" i="0" spc="300">
+                <a:solidFill>
+                  <a:srgbClr val="6B6690"/>
+                </a:solidFill>
+                <a:latin typeface="Calibri"/>
+              </a:rPr>
+              <a:t>ADMINISTERED THROUGH THE COMPETENCY ADVANCEMENT ACADEMY</a:t>
+            </a:r>
+          </a:p>
+        </p:txBody>
+      </p:sp>
+      <p:sp>
+        <p:nvSpPr>
+          <p:cNvPr id="6" name="TextBox 5"/>
+          <p:cNvSpPr txBox="1"/>
+          <p:nvPr/>
+        </p:nvSpPr>
+        <p:spPr>
+          <a:xfrm>
+            <a:off x="5992063" y="310896"/>
+            <a:ext cx="5669280" cy="127381"/>
+          </a:xfrm>
+          <a:prstGeom prst="rect">
+            <a:avLst/>
+          </a:prstGeom>
+          <a:noFill/>
+        </p:spPr>
+        <p:txBody>
+          <a:bodyPr wrap="square" anchor="t" lIns="0" rIns="0" tIns="0" bIns="0">
+            <a:spAutoFit/>
+          </a:bodyPr>
+          <a:lstStyle/>
+          <a:p>
+            <a:pPr algn="r"/>
+            <a:r>
+              <a:rPr sz="550" b="1" i="0" spc="300">
+                <a:solidFill>
+                  <a:srgbClr val="6B6690"/>
+                </a:solidFill>
+                <a:latin typeface="Calibri"/>
+              </a:rPr>
+              <a:t>WEEK 1  ·  DAY 5  ·  KALPA GLOBAL CAPABILITY CENTRE</a:t>
+            </a:r>
+          </a:p>
+        </p:txBody>
+      </p:sp>
+      <p:sp>
+        <p:nvSpPr>
+          <p:cNvPr id="7" name="TextBox 6"/>
+          <p:cNvSpPr txBox="1"/>
+          <p:nvPr/>
+        </p:nvSpPr>
+        <p:spPr>
+          <a:xfrm>
+            <a:off x="530352" y="676656"/>
+            <a:ext cx="10033711" cy="512064"/>
+          </a:xfrm>
+          <a:prstGeom prst="rect">
+            <a:avLst/>
+          </a:prstGeom>
+          <a:noFill/>
+        </p:spPr>
+        <p:txBody>
+          <a:bodyPr wrap="square" anchor="b" lIns="0" rIns="0" tIns="0" bIns="0">
+            <a:spAutoFit/>
+          </a:bodyPr>
+          <a:lstStyle/>
+          <a:p>
+            <a:pPr algn="l"/>
+            <a:r>
+              <a:rPr sz="2600" b="0" i="0">
+                <a:solidFill>
+                  <a:srgbClr val="1A0F5C"/>
+                </a:solidFill>
+                <a:latin typeface="Georgia"/>
+              </a:rPr>
+              <a:t>Reserve answer: the segments add back to the total</a:t>
+            </a:r>
+          </a:p>
+        </p:txBody>
+      </p:sp>
+      <p:sp>
+        <p:nvSpPr>
+          <p:cNvPr id="8" name="Rounded Rectangle 7"/>
+          <p:cNvSpPr/>
+          <p:nvPr/>
+        </p:nvSpPr>
+        <p:spPr>
+          <a:xfrm>
+            <a:off x="10701223" y="822960"/>
+            <a:ext cx="960120" cy="256032"/>
+          </a:xfrm>
+          <a:prstGeom prst="roundRect">
+            <a:avLst>
+              <a:gd name="adj" fmla="val 50000"/>
+            </a:avLst>
+          </a:prstGeom>
+          <a:solidFill>
+            <a:srgbClr val="1A0F5C"/>
+          </a:solidFill>
+          <a:ln>
+            <a:noFill/>
+          </a:ln>
+          <a:effectLst/>
+        </p:spPr>
+        <p:style>
+          <a:lnRef idx="1">
+            <a:schemeClr val="accent1"/>
+          </a:lnRef>
+          <a:fillRef idx="3">
+            <a:schemeClr val="accent1"/>
+          </a:fillRef>
+          <a:effectRef idx="2">
+            <a:schemeClr val="accent1"/>
+          </a:effectRef>
+          <a:fontRef idx="minor">
+            <a:schemeClr val="lt1"/>
+          </a:fontRef>
+        </p:style>
+        <p:txBody>
+          <a:bodyPr rtlCol="0" anchor="ctr" wrap="none" lIns="25400" rIns="25400" tIns="0" bIns="0"/>
+          <a:lstStyle/>
+          <a:p>
+            <a:pPr algn="ctr"/>
+            <a:r>
+              <a:rPr sz="800" b="1" spc="200">
+                <a:solidFill>
+                  <a:srgbClr val="FFFFFF"/>
+                </a:solidFill>
+                <a:latin typeface="Calibri"/>
+              </a:rPr>
+              <a:t>DEPTH</a:t>
+            </a:r>
+          </a:p>
+        </p:txBody>
+      </p:sp>
+      <p:sp>
+        <p:nvSpPr>
+          <p:cNvPr id="9" name="TextBox 8"/>
+          <p:cNvSpPr txBox="1"/>
+          <p:nvPr/>
+        </p:nvSpPr>
+        <p:spPr>
+          <a:xfrm>
+            <a:off x="530352" y="1243584"/>
+            <a:ext cx="11130991" cy="234696"/>
+          </a:xfrm>
+          <a:prstGeom prst="rect">
+            <a:avLst/>
+          </a:prstGeom>
+          <a:noFill/>
+        </p:spPr>
+        <p:txBody>
+          <a:bodyPr wrap="square" anchor="t" lIns="0" rIns="0" tIns="0" bIns="0">
+            <a:spAutoFit/>
+          </a:bodyPr>
+          <a:lstStyle/>
+          <a:p>
+            <a:pPr algn="l"/>
+            <a:r>
+              <a:rPr sz="1200" b="0" i="0">
+                <a:solidFill>
+                  <a:srgbClr val="6B6690"/>
+                </a:solidFill>
+                <a:latin typeface="Calibri"/>
+              </a:rPr>
+              <a:t>Invented numbers: the check is one line, and it fails by exactly one order.</a:t>
+            </a:r>
+          </a:p>
+        </p:txBody>
+      </p:sp>
+      <p:pic>
+        <p:nvPicPr>
+          <p:cNvPr id="10" name="mermaid diagram" descr="f70872a39f31c56d.png"/>
+          <p:cNvPicPr>
+            <a:picLocks noChangeAspect="1"/>
+          </p:cNvPicPr>
+          <p:nvPr/>
+        </p:nvPicPr>
+        <p:blipFill>
+          <a:blip r:embed="rId6"/>
+          <a:stretch>
+            <a:fillRect/>
+          </a:stretch>
+        </p:blipFill>
+        <p:spPr>
+          <a:xfrm>
+            <a:off x="530352" y="1956816"/>
+            <a:ext cx="11130991" cy="2007989"/>
+          </a:xfrm>
+          <a:prstGeom prst="rect">
+            <a:avLst/>
+          </a:prstGeom>
+        </p:spPr>
+      </p:pic>
+      <p:sp>
+        <p:nvSpPr>
+          <p:cNvPr id="11" name="Rounded Rectangle 10"/>
+          <p:cNvSpPr/>
+          <p:nvPr/>
+        </p:nvSpPr>
+        <p:spPr>
+          <a:xfrm>
+            <a:off x="530352" y="4111109"/>
+            <a:ext cx="11130991" cy="1121664"/>
+          </a:xfrm>
+          <a:prstGeom prst="roundRect">
+            <a:avLst>
+              <a:gd name="adj" fmla="val 5000"/>
+            </a:avLst>
+          </a:prstGeom>
+          <a:solidFill>
+            <a:srgbClr val="F7F5FD"/>
+          </a:solidFill>
+          <a:ln w="9525">
+            <a:solidFill>
+              <a:srgbClr val="E4E1F1"/>
+            </a:solidFill>
+          </a:ln>
+          <a:effectLst>
+            <a:outerShdw blurRad="76200" dist="19050" dir="5400000" algn="bl" rotWithShape="0">
+              <a:srgbClr val="1A0F5C">
+                <a:alpha val="12000"/>
+              </a:srgbClr>
+            </a:outerShdw>
+          </a:effectLst>
+        </p:spPr>
+        <p:style>
+          <a:lnRef idx="1">
+            <a:schemeClr val="accent1"/>
+          </a:lnRef>
+          <a:fillRef idx="3">
+            <a:schemeClr val="accent1"/>
+          </a:fillRef>
+          <a:effectRef idx="2">
+            <a:schemeClr val="accent1"/>
+          </a:effectRef>
+          <a:fontRef idx="minor">
+            <a:schemeClr val="lt1"/>
+          </a:fontRef>
+        </p:style>
+        <p:txBody>
+          <a:bodyPr rtlCol="0" anchor="ctr" wrap="square"/>
+          <a:lstStyle/>
+          <a:p>
+            <a:pPr algn="ctr"/>
+          </a:p>
+        </p:txBody>
+      </p:sp>
+      <p:sp>
+        <p:nvSpPr>
+          <p:cNvPr id="12" name="Oval 11"/>
+          <p:cNvSpPr/>
+          <p:nvPr/>
+        </p:nvSpPr>
+        <p:spPr>
+          <a:xfrm>
+            <a:off x="758952" y="4443341"/>
+            <a:ext cx="457200" cy="457200"/>
+          </a:xfrm>
+          <a:prstGeom prst="ellipse">
+            <a:avLst/>
+          </a:prstGeom>
+          <a:solidFill>
+            <a:srgbClr val="5B3FD6"/>
+          </a:solidFill>
+          <a:ln>
+            <a:noFill/>
+          </a:ln>
+          <a:effectLst/>
+        </p:spPr>
+        <p:style>
+          <a:lnRef idx="1">
+            <a:schemeClr val="accent1"/>
+          </a:lnRef>
+          <a:fillRef idx="3">
+            <a:schemeClr val="accent1"/>
+          </a:fillRef>
+          <a:effectRef idx="2">
+            <a:schemeClr val="accent1"/>
+          </a:effectRef>
+          <a:fontRef idx="minor">
+            <a:schemeClr val="lt1"/>
+          </a:fontRef>
+        </p:style>
+        <p:txBody>
+          <a:bodyPr rtlCol="0" anchor="ctr" wrap="square"/>
+          <a:lstStyle/>
+          <a:p>
+            <a:pPr algn="ctr"/>
+          </a:p>
+        </p:txBody>
+      </p:sp>
+      <p:pic>
+        <p:nvPicPr>
+          <p:cNvPr id="13" name="Picture 12" descr="list-checks_bd88901d2a37.png"/>
+          <p:cNvPicPr>
+            <a:picLocks noChangeAspect="1"/>
+          </p:cNvPicPr>
+          <p:nvPr/>
+        </p:nvPicPr>
+        <p:blipFill>
+          <a:blip r:embed="rId5"/>
+          <a:stretch>
+            <a:fillRect/>
+          </a:stretch>
+        </p:blipFill>
+        <p:spPr>
+          <a:xfrm>
+            <a:off x="868680" y="4553069"/>
+            <a:ext cx="237744" cy="237744"/>
+          </a:xfrm>
+          <a:prstGeom prst="rect">
+            <a:avLst/>
+          </a:prstGeom>
+        </p:spPr>
+      </p:pic>
+      <p:sp>
+        <p:nvSpPr>
+          <p:cNvPr id="14" name="TextBox 13"/>
+          <p:cNvSpPr txBox="1"/>
+          <p:nvPr/>
+        </p:nvSpPr>
+        <p:spPr>
+          <a:xfrm>
+            <a:off x="1399031" y="4257413"/>
+            <a:ext cx="9987991" cy="160401"/>
+          </a:xfrm>
+          <a:prstGeom prst="rect">
+            <a:avLst/>
+          </a:prstGeom>
+          <a:noFill/>
+        </p:spPr>
+        <p:txBody>
+          <a:bodyPr wrap="square" anchor="t" lIns="0" rIns="0" tIns="0" bIns="0">
+            <a:spAutoFit/>
+          </a:bodyPr>
+          <a:lstStyle/>
+          <a:p>
+            <a:pPr algn="l"/>
+            <a:r>
+              <a:rPr sz="750" b="1" i="0" spc="250">
+                <a:solidFill>
+                  <a:srgbClr val="5B3FD6"/>
+                </a:solidFill>
+                <a:latin typeface="Calibri"/>
+              </a:rPr>
+              <a:t>THE RULE</a:t>
+            </a:r>
+          </a:p>
+        </p:txBody>
+      </p:sp>
+      <p:sp>
+        <p:nvSpPr>
+          <p:cNvPr id="15" name="TextBox 14"/>
+          <p:cNvSpPr txBox="1"/>
+          <p:nvPr/>
+        </p:nvSpPr>
+        <p:spPr>
+          <a:xfrm>
+            <a:off x="1399031" y="4476869"/>
+            <a:ext cx="9987991" cy="682752"/>
+          </a:xfrm>
+          <a:prstGeom prst="rect">
+            <a:avLst/>
+          </a:prstGeom>
+          <a:noFill/>
+        </p:spPr>
+        <p:txBody>
+          <a:bodyPr wrap="square" anchor="t" lIns="0" rIns="0" tIns="0" bIns="0">
+            <a:spAutoFit/>
+          </a:bodyPr>
+          <a:lstStyle/>
+          <a:p>
+            <a:r>
+              <a:rPr sz="1500" b="0" i="0">
+                <a:solidFill>
+                  <a:srgbClr val="1A1440"/>
+                </a:solidFill>
+                <a:latin typeface="Calibri"/>
+              </a:rPr>
+              <a:t>The segments add back to the total, in orders and in rupees, before any segment is read. A fifth group with a blank name passes that check and is still a decision to log, never a segment.</a:t>
+            </a:r>
+          </a:p>
+        </p:txBody>
+      </p:sp>
+      <p:sp>
+        <p:nvSpPr>
+          <p:cNvPr id="16" name="Oval 15"/>
+          <p:cNvSpPr/>
+          <p:nvPr/>
+        </p:nvSpPr>
+        <p:spPr>
+          <a:xfrm>
+            <a:off x="530352" y="6492240"/>
+            <a:ext cx="64008" cy="64008"/>
+          </a:xfrm>
+          <a:prstGeom prst="ellipse">
+            <a:avLst/>
+          </a:prstGeom>
+          <a:solidFill>
+            <a:srgbClr val="CFC9EE"/>
+          </a:solidFill>
+          <a:ln>
+            <a:noFill/>
+          </a:ln>
+          <a:effectLst/>
+        </p:spPr>
+        <p:style>
+          <a:lnRef idx="1">
+            <a:schemeClr val="accent1"/>
+          </a:lnRef>
+          <a:fillRef idx="3">
+            <a:schemeClr val="accent1"/>
+          </a:fillRef>
+          <a:effectRef idx="2">
+            <a:schemeClr val="accent1"/>
+          </a:effectRef>
+          <a:fontRef idx="minor">
+            <a:schemeClr val="lt1"/>
+          </a:fontRef>
+        </p:style>
+        <p:txBody>
+          <a:bodyPr rtlCol="0" anchor="ctr" wrap="square"/>
+          <a:lstStyle/>
+          <a:p>
+            <a:pPr algn="ctr"/>
+          </a:p>
+        </p:txBody>
+      </p:sp>
+      <p:sp>
+        <p:nvSpPr>
+          <p:cNvPr id="17" name="TextBox 16"/>
+          <p:cNvSpPr txBox="1"/>
+          <p:nvPr/>
+        </p:nvSpPr>
+        <p:spPr>
+          <a:xfrm>
+            <a:off x="640080" y="6437376"/>
+            <a:ext cx="1516475" cy="152146"/>
+          </a:xfrm>
+          <a:prstGeom prst="rect">
+            <a:avLst/>
+          </a:prstGeom>
+          <a:noFill/>
+        </p:spPr>
+        <p:txBody>
+          <a:bodyPr wrap="square" anchor="t" lIns="0" rIns="0" tIns="0" bIns="0">
+            <a:spAutoFit/>
+          </a:bodyPr>
+          <a:lstStyle/>
+          <a:p>
+            <a:pPr algn="l"/>
+            <a:r>
+              <a:rPr sz="700" b="0" i="0">
+                <a:solidFill>
+                  <a:srgbClr val="6B6690"/>
+                </a:solidFill>
+                <a:latin typeface="Calibri"/>
+              </a:rPr>
+              <a:t>The reconciliation, skipped</a:t>
+            </a:r>
+          </a:p>
+        </p:txBody>
+      </p:sp>
+      <p:sp>
+        <p:nvSpPr>
+          <p:cNvPr id="18" name="Oval 17"/>
+          <p:cNvSpPr/>
+          <p:nvPr/>
+        </p:nvSpPr>
+        <p:spPr>
+          <a:xfrm>
+            <a:off x="2247995" y="6492240"/>
+            <a:ext cx="64008" cy="64008"/>
+          </a:xfrm>
+          <a:prstGeom prst="ellipse">
+            <a:avLst/>
+          </a:prstGeom>
+          <a:solidFill>
+            <a:srgbClr val="CFC9EE"/>
+          </a:solidFill>
+          <a:ln>
+            <a:noFill/>
+          </a:ln>
+          <a:effectLst/>
+        </p:spPr>
+        <p:style>
+          <a:lnRef idx="1">
+            <a:schemeClr val="accent1"/>
+          </a:lnRef>
+          <a:fillRef idx="3">
+            <a:schemeClr val="accent1"/>
+          </a:fillRef>
+          <a:effectRef idx="2">
+            <a:schemeClr val="accent1"/>
+          </a:effectRef>
+          <a:fontRef idx="minor">
+            <a:schemeClr val="lt1"/>
+          </a:fontRef>
+        </p:style>
+        <p:txBody>
+          <a:bodyPr rtlCol="0" anchor="ctr" wrap="square"/>
+          <a:lstStyle/>
+          <a:p>
+            <a:pPr algn="ctr"/>
+          </a:p>
+        </p:txBody>
+      </p:sp>
+      <p:sp>
+        <p:nvSpPr>
+          <p:cNvPr id="19" name="TextBox 18"/>
+          <p:cNvSpPr txBox="1"/>
+          <p:nvPr/>
+        </p:nvSpPr>
+        <p:spPr>
+          <a:xfrm>
+            <a:off x="2357723" y="6437376"/>
+            <a:ext cx="1424463" cy="152146"/>
+          </a:xfrm>
+          <a:prstGeom prst="rect">
+            <a:avLst/>
+          </a:prstGeom>
+          <a:noFill/>
+        </p:spPr>
+        <p:txBody>
+          <a:bodyPr wrap="square" anchor="t" lIns="0" rIns="0" tIns="0" bIns="0">
+            <a:spAutoFit/>
+          </a:bodyPr>
+          <a:lstStyle/>
+          <a:p>
+            <a:pPr algn="l"/>
+            <a:r>
+              <a:rPr sz="700" b="0" i="0">
+                <a:solidFill>
+                  <a:srgbClr val="6B6690"/>
+                </a:solidFill>
+                <a:latin typeface="Calibri"/>
+              </a:rPr>
+              <a:t>The pass that looks clean</a:t>
+            </a:r>
+          </a:p>
+        </p:txBody>
+      </p:sp>
+      <p:sp>
+        <p:nvSpPr>
+          <p:cNvPr id="20" name="Oval 19"/>
+          <p:cNvSpPr/>
+          <p:nvPr/>
+        </p:nvSpPr>
+        <p:spPr>
+          <a:xfrm>
+            <a:off x="3873627" y="6492240"/>
+            <a:ext cx="64008" cy="64008"/>
+          </a:xfrm>
+          <a:prstGeom prst="ellipse">
+            <a:avLst/>
+          </a:prstGeom>
+          <a:solidFill>
+            <a:srgbClr val="5B3FD6"/>
+          </a:solidFill>
+          <a:ln>
+            <a:noFill/>
+          </a:ln>
+          <a:effectLst/>
+        </p:spPr>
+        <p:style>
+          <a:lnRef idx="1">
+            <a:schemeClr val="accent1"/>
+          </a:lnRef>
+          <a:fillRef idx="3">
+            <a:schemeClr val="accent1"/>
+          </a:fillRef>
+          <a:effectRef idx="2">
+            <a:schemeClr val="accent1"/>
+          </a:effectRef>
+          <a:fontRef idx="minor">
+            <a:schemeClr val="lt1"/>
+          </a:fontRef>
+        </p:style>
+        <p:txBody>
+          <a:bodyPr rtlCol="0" anchor="ctr" wrap="square"/>
+          <a:lstStyle/>
+          <a:p>
+            <a:pPr algn="ctr"/>
+          </a:p>
+        </p:txBody>
+      </p:sp>
+      <p:sp>
+        <p:nvSpPr>
+          <p:cNvPr id="21" name="TextBox 20"/>
+          <p:cNvSpPr txBox="1"/>
+          <p:nvPr/>
+        </p:nvSpPr>
+        <p:spPr>
+          <a:xfrm>
+            <a:off x="3983355" y="6437376"/>
+            <a:ext cx="1654492" cy="152146"/>
+          </a:xfrm>
+          <a:prstGeom prst="rect">
+            <a:avLst/>
+          </a:prstGeom>
+          <a:noFill/>
+        </p:spPr>
+        <p:txBody>
+          <a:bodyPr wrap="square" anchor="t" lIns="0" rIns="0" tIns="0" bIns="0">
+            <a:spAutoFit/>
+          </a:bodyPr>
+          <a:lstStyle/>
+          <a:p>
+            <a:pPr algn="l"/>
+            <a:r>
+              <a:rPr sz="700" b="1" i="0">
+                <a:solidFill>
+                  <a:srgbClr val="5B3FD6"/>
+                </a:solidFill>
+                <a:latin typeface="Calibri"/>
+              </a:rPr>
+              <a:t>The headline on too few orders</a:t>
+            </a:r>
+          </a:p>
+        </p:txBody>
+      </p:sp>
+      <p:sp>
+        <p:nvSpPr>
+          <p:cNvPr id="22" name="TextBox 21"/>
+          <p:cNvSpPr txBox="1"/>
+          <p:nvPr/>
+        </p:nvSpPr>
+        <p:spPr>
+          <a:xfrm>
+            <a:off x="10198303" y="6437376"/>
+            <a:ext cx="1463040" cy="160401"/>
+          </a:xfrm>
+          <a:prstGeom prst="rect">
+            <a:avLst/>
+          </a:prstGeom>
+          <a:noFill/>
+        </p:spPr>
+        <p:txBody>
+          <a:bodyPr wrap="square" anchor="t" lIns="0" rIns="0" tIns="0" bIns="0">
+            <a:spAutoFit/>
+          </a:bodyPr>
+          <a:lstStyle/>
+          <a:p>
+            <a:pPr algn="r"/>
+            <a:r>
+              <a:rPr sz="750" b="0" i="0">
+                <a:solidFill>
+                  <a:srgbClr val="6B6690"/>
+                </a:solidFill>
+                <a:latin typeface="Calibri"/>
+              </a:rPr>
+              <a:t>D17  ·  21 / 22</a:t>
+            </a:r>
+          </a:p>
+        </p:txBody>
+      </p:sp>
+    </p:spTree>
+  </p:cSld>
+  <p:clrMapOvr>
+    <a:masterClrMapping/>
+  </p:clrMapOvr>
+</p:sld>
+</file>
+
+<file path=ppt/slides/slide22.xml><?xml version="1.0" encoding="utf-8"?>
+<p:sld xmlns:a="http://schemas.openxmlformats.org/drawingml/2006/main" xmlns:p="http://schemas.openxmlformats.org/presentationml/2006/main" xmlns:r="http://schemas.openxmlformats.org/officeDocument/2006/relationships">
+  <p:cSld>
+    <p:spTree>
+      <p:nvGrpSpPr>
+        <p:cNvPr id="1" name=""/>
+        <p:cNvGrpSpPr/>
+        <p:nvPr/>
+      </p:nvGrpSpPr>
+      <p:grpSpPr/>
+      <p:pic>
+        <p:nvPicPr>
+          <p:cNvPr id="2" name="Picture 1" descr="bg_light.jpg"/>
+          <p:cNvPicPr>
+            <a:picLocks noChangeAspect="1"/>
+          </p:cNvPicPr>
+          <p:nvPr/>
+        </p:nvPicPr>
+        <p:blipFill>
+          <a:blip r:embed="rId2"/>
+          <a:stretch>
+            <a:fillRect/>
+          </a:stretch>
+        </p:blipFill>
+        <p:spPr>
+          <a:xfrm>
+            <a:off x="0" y="0"/>
+            <a:ext cx="12191695" cy="6858000"/>
+          </a:xfrm>
+          <a:prstGeom prst="rect">
+            <a:avLst/>
+          </a:prstGeom>
+        </p:spPr>
+      </p:pic>
+      <p:pic>
+        <p:nvPicPr>
+          <p:cNvPr id="3" name="Picture 2" descr="iitgn_logo.png"/>
+          <p:cNvPicPr>
+            <a:picLocks noChangeAspect="1"/>
+          </p:cNvPicPr>
+          <p:nvPr/>
+        </p:nvPicPr>
+        <p:blipFill>
+          <a:blip r:embed="rId3"/>
+          <a:stretch>
+            <a:fillRect/>
+          </a:stretch>
+        </p:blipFill>
+        <p:spPr>
+          <a:xfrm>
+            <a:off x="530352" y="201168"/>
+            <a:ext cx="420624" cy="420624"/>
+          </a:xfrm>
+          <a:prstGeom prst="rect">
+            <a:avLst/>
+          </a:prstGeom>
+        </p:spPr>
+      </p:pic>
+      <p:sp>
+        <p:nvSpPr>
+          <p:cNvPr id="4" name="TextBox 3"/>
+          <p:cNvSpPr txBox="1"/>
+          <p:nvPr/>
+        </p:nvSpPr>
+        <p:spPr>
+          <a:xfrm>
+            <a:off x="1042416" y="228600"/>
+            <a:ext cx="5120640" cy="185166"/>
+          </a:xfrm>
+          <a:prstGeom prst="rect">
+            <a:avLst/>
+          </a:prstGeom>
+          <a:noFill/>
+        </p:spPr>
+        <p:txBody>
+          <a:bodyPr wrap="square" anchor="t" lIns="0" rIns="0" tIns="0" bIns="0">
+            <a:spAutoFit/>
+          </a:bodyPr>
+          <a:lstStyle/>
+          <a:p>
+            <a:pPr algn="l"/>
+            <a:r>
+              <a:rPr sz="900" b="1" i="0">
+                <a:solidFill>
+                  <a:srgbClr val="1A0F5C"/>
+                </a:solidFill>
+                <a:latin typeface="Calibri"/>
+              </a:rPr>
+              <a:t>Indian Institute of Technology Gandhinagar</a:t>
+            </a:r>
+          </a:p>
+        </p:txBody>
+      </p:sp>
+      <p:sp>
+        <p:nvSpPr>
+          <p:cNvPr id="5" name="TextBox 4"/>
+          <p:cNvSpPr txBox="1"/>
+          <p:nvPr/>
+        </p:nvSpPr>
+        <p:spPr>
+          <a:xfrm>
+            <a:off x="1042416" y="420623"/>
+            <a:ext cx="5852160" cy="127381"/>
+          </a:xfrm>
+          <a:prstGeom prst="rect">
+            <a:avLst/>
+          </a:prstGeom>
+          <a:noFill/>
+        </p:spPr>
+        <p:txBody>
+          <a:bodyPr wrap="square" anchor="t" lIns="0" rIns="0" tIns="0" bIns="0">
+            <a:spAutoFit/>
+          </a:bodyPr>
+          <a:lstStyle/>
+          <a:p>
+            <a:pPr algn="l"/>
+            <a:r>
+              <a:rPr sz="550" b="1" i="0" spc="300">
+                <a:solidFill>
+                  <a:srgbClr val="6B6690"/>
+                </a:solidFill>
+                <a:latin typeface="Calibri"/>
+              </a:rPr>
+              <a:t>ADMINISTERED THROUGH THE COMPETENCY ADVANCEMENT ACADEMY</a:t>
+            </a:r>
+          </a:p>
+        </p:txBody>
+      </p:sp>
+      <p:sp>
+        <p:nvSpPr>
+          <p:cNvPr id="6" name="TextBox 5"/>
+          <p:cNvSpPr txBox="1"/>
+          <p:nvPr/>
+        </p:nvSpPr>
+        <p:spPr>
+          <a:xfrm>
+            <a:off x="5992063" y="310896"/>
+            <a:ext cx="5669280" cy="127381"/>
+          </a:xfrm>
+          <a:prstGeom prst="rect">
+            <a:avLst/>
+          </a:prstGeom>
+          <a:noFill/>
+        </p:spPr>
+        <p:txBody>
+          <a:bodyPr wrap="square" anchor="t" lIns="0" rIns="0" tIns="0" bIns="0">
+            <a:spAutoFit/>
+          </a:bodyPr>
+          <a:lstStyle/>
+          <a:p>
+            <a:pPr algn="r"/>
+            <a:r>
+              <a:rPr sz="550" b="1" i="0" spc="300">
+                <a:solidFill>
+                  <a:srgbClr val="6B6690"/>
+                </a:solidFill>
+                <a:latin typeface="Calibri"/>
+              </a:rPr>
+              <a:t>WEEK 1  ·  DAY 5  ·  KALPA GLOBAL CAPABILITY CENTRE</a:t>
+            </a:r>
+          </a:p>
+        </p:txBody>
+      </p:sp>
+      <p:sp>
+        <p:nvSpPr>
+          <p:cNvPr id="7" name="TextBox 6"/>
+          <p:cNvSpPr txBox="1"/>
+          <p:nvPr/>
+        </p:nvSpPr>
+        <p:spPr>
+          <a:xfrm>
+            <a:off x="530352" y="676656"/>
             <a:ext cx="11130991" cy="512064"/>
           </a:xfrm>
           <a:prstGeom prst="rect">
@@ -16024,7 +18170,7 @@
                 </a:solidFill>
                 <a:latin typeface="Calibri"/>
               </a:rPr>
-              <a:t>S16  ·  20 / 20</a:t>
+              <a:t>S18  ·  22 / 22</a:t>
             </a:r>
           </a:p>
         </p:txBody>
@@ -17023,7 +19169,7 @@
                 </a:solidFill>
                 <a:latin typeface="Calibri"/>
               </a:rPr>
-              <a:t>S1  ·  3 / 20</a:t>
+              <a:t>S1  ·  3 / 22</a:t>
             </a:r>
           </a:p>
         </p:txBody>
@@ -17673,7 +19819,7 @@
                 </a:solidFill>
                 <a:latin typeface="Calibri"/>
               </a:rPr>
-              <a:t>S2  ·  4 / 20</a:t>
+              <a:t>S2  ·  4 / 22</a:t>
             </a:r>
           </a:p>
         </p:txBody>
@@ -18249,7 +20395,7 @@
                 </a:solidFill>
                 <a:latin typeface="Calibri"/>
               </a:rPr>
-              <a:t>S3  ·  5 / 20</a:t>
+              <a:t>S3  ·  5 / 22</a:t>
             </a:r>
           </a:p>
         </p:txBody>
@@ -19413,7 +21559,7 @@
                 </a:solidFill>
                 <a:latin typeface="Calibri"/>
               </a:rPr>
-              <a:t>S4  ·  6 / 20</a:t>
+              <a:t>S4  ·  6 / 22</a:t>
             </a:r>
           </a:p>
         </p:txBody>
@@ -19989,7 +22135,7 @@
                 </a:solidFill>
                 <a:latin typeface="Calibri"/>
               </a:rPr>
-              <a:t>S5  ·  7 / 20</a:t>
+              <a:t>S5  ·  7 / 22</a:t>
             </a:r>
           </a:p>
         </p:txBody>
@@ -21236,7 +23382,7 @@
                 </a:solidFill>
                 <a:latin typeface="Calibri"/>
               </a:rPr>
-              <a:t>S6  ·  8 / 20</a:t>
+              <a:t>S6  ·  8 / 22</a:t>
             </a:r>
           </a:p>
         </p:txBody>
@@ -21747,7 +23893,7 @@
                 </a:solidFill>
                 <a:latin typeface="Calibri"/>
               </a:rPr>
-              <a:t>9 / 20</a:t>
+              <a:t>9 / 22</a:t>
             </a:r>
           </a:p>
         </p:txBody>

</xml_diff>

<commit_message>
W01/D5: the three decks rebuilt from their final markdown on mermaid-cli 11
The debrief and rehearsal decks still carried the old breadcrumb on slides 2, 9, 10, 14 and 15, and
the lab deck's four diagrams had been drawn smaller than the builder draws them. All three are rebuilt
from the committed markdown; verify passes on the pack.

Co-Authored-By: Claude Opus 5.5 <noreply@anthropic.com>
Claude-Session: https://claude.ai/code/session_01P7zaoR4dQ5pzBFnsX549JQ
</commit_message>
<xml_diff>
--- a/content/W01/D5/slides/C2_W01_D05_debrief_STUDENT.pptx
+++ b/content/W01/D5/slides/C2_W01_D05_debrief_STUDENT.pptx
@@ -9476,7 +9476,7 @@
                 </a:solidFill>
                 <a:latin typeface="Calibri"/>
               </a:rPr>
-              <a:t>Week 1 Day 5: the week rebuilt alone</a:t>
+              <a:t>Week 1, Day 5. Where the room broke</a:t>
             </a:r>
           </a:p>
         </p:txBody>
@@ -14789,7 +14789,7 @@
                 </a:solidFill>
                 <a:latin typeface="Calibri"/>
               </a:rPr>
-              <a:t>Week 1 Day 5: the week rebuilt alone</a:t>
+              <a:t>Week 1, Day 5. Where the room broke</a:t>
             </a:r>
           </a:p>
         </p:txBody>
@@ -23858,7 +23858,7 @@
                 </a:solidFill>
                 <a:latin typeface="Calibri"/>
               </a:rPr>
-              <a:t>Week 1 Day 5: the week rebuilt alone</a:t>
+              <a:t>Week 1, Day 5. Where the room broke</a:t>
             </a:r>
           </a:p>
         </p:txBody>

</xml_diff>

<commit_message>
W01 D5: depth loop round one fixed: case 3 re-sized for unequal splits, the wrong-unit mechanism corrected, practice stems name no plant, the practice lead tested both ways, contrast lines and aphorisms rewritten, chapter 1 reordered, checks made falsifiable
Co-Authored-By: Claude Opus 5.5 <noreply@anthropic.com>
Claude-Session: https://claude.ai/code/session_01GMyE3nGptgYS2FxtWfW4y9
</commit_message>
<xml_diff>
--- a/content/W01/D5/slides/C2_W01_D05_debrief_STUDENT.pptx
+++ b/content/W01/D5/slides/C2_W01_D05_debrief_STUDENT.pptx
@@ -631,7 +631,7 @@
           <a:lstStyle/>
           <a:p>
             <a:r>
-              <a:t>LIVE, 2 minutes. The error changed the sign, so it changed the decision, not the precision. Ask one</a:t>
+              <a:t>LIVE, 2 minutes. The error changed the sign, so it changed the decision itself. Ask one</a:t>
             </a:r>
           </a:p>
           <a:p>
@@ -1016,7 +1016,17 @@
           </a:p>
           <a:p>
             <a:r>
-              <a:t>every other number in the note is doubted with it.</a:t>
+              <a:t>every other number in the note is doubted with it. One sentence of likeness, even when D13 is</a:t>
+            </a:r>
+          </a:p>
+          <a:p>
+            <a:r>
+              <a:t>self-study: JPMorgan's own task force found a risk spreadsheet that divided by a sum instead of an</a:t>
+            </a:r>
+          </a:p>
+          <a:p>
+            <a:r>
+              <a:t>average and never raised an error.</a:t>
             </a:r>
           </a:p>
         </p:txBody>
@@ -1846,7 +1856,17 @@
           </a:p>
           <a:p>
             <a:r>
-              <a:t>to fix a segment that did nothing while the branch that moved goes unopened.</a:t>
+              <a:t>to fix a segment that did nothing while the branch that moved goes unopened. One sentence of</a:t>
+            </a:r>
+          </a:p>
+          <a:p>
+            <a:r>
+              <a:t>likeness, even when D22 is self-study: IMDb will not rank a title in its Top 250 until it has 25,000</a:t>
+            </a:r>
+          </a:p>
+          <a:p>
+            <a:r>
+              <a:t>ratings.</a:t>
             </a:r>
           </a:p>
         </p:txBody>
@@ -2231,7 +2251,17 @@
           </a:p>
           <a:p>
             <a:r>
-              <a:t>against a quarter that did not happen.</a:t>
+              <a:t>against a quarter that did not happen. Then one sentence of likeness, even when D2 is left to</a:t>
+            </a:r>
+          </a:p>
+          <a:p>
+            <a:r>
+              <a:t>self-study: Nykaa reports GMV of Rs 4,182 crore and revenue of Rs 2,155 crore for the same quarter,</a:t>
+            </a:r>
+          </a:p>
+          <a:p>
+            <a:r>
+              <a:t>so every figure there names its base and bridges to the books.</a:t>
             </a:r>
           </a:p>
         </p:txBody>
@@ -2449,6 +2479,16 @@
         <p:txBody>
           <a:bodyPr/>
           <a:lstStyle/>
+          <a:p>
+            <a:r>
+              <a:t>The rule to say: the shuffle says whether the gap is bigger than chance, the customer count says</a:t>
+            </a:r>
+          </a:p>
+          <a:p>
+            <a:r>
+              <a:t>whether it is broad; when they disagree, a handful of customers moved the average.</a:t>
+            </a:r>
+          </a:p>
           <a:p>
             <a:r>
               <a:t>LIVE, 1 minute. Run the second-route cell. Then close the chapter with the note as it should read,</a:t>
@@ -7767,7 +7807,7 @@
       </p:sp>
       <p:pic>
         <p:nvPicPr>
-          <p:cNvPr id="29" name="Picture 28" descr="search-check_6571e64a041f.png"/>
+          <p:cNvPr id="29" name="Picture 28" descr="mic_caee7398c80d.png"/>
           <p:cNvPicPr>
             <a:picLocks noChangeAspect="1"/>
           </p:cNvPicPr>
@@ -7819,7 +7859,7 @@
                 </a:solidFill>
                 <a:latin typeface="Calibri"/>
               </a:rPr>
-              <a:t>KAVYA'S REVIEW</a:t>
+              <a:t>IN THE INTERVIEW</a:t>
             </a:r>
           </a:p>
         </p:txBody>
@@ -7853,7 +7893,7 @@
                 </a:solidFill>
                 <a:latin typeface="Calibri"/>
               </a:rPr>
-              <a:t>A number that has not been reconciled is not a rougher version of the right number. This morning it pointed the other way.</a:t>
+              <a:t>[F] You have two hours and a raw export; what do you do first, and what do you skip? Never the reconciliation: it is fifteen minutes, and it is the step that can flip the sign.</a:t>
             </a:r>
           </a:p>
         </p:txBody>
@@ -10182,7 +10222,7 @@
       </p:sp>
       <p:pic>
         <p:nvPicPr>
-          <p:cNvPr id="19" name="Picture 18" descr="mic_caee7398c80d.png"/>
+          <p:cNvPr id="19" name="Picture 18" descr="search-check_6571e64a041f.png"/>
           <p:cNvPicPr>
             <a:picLocks noChangeAspect="1"/>
           </p:cNvPicPr>
@@ -10234,7 +10274,7 @@
                 </a:solidFill>
                 <a:latin typeface="Calibri"/>
               </a:rPr>
-              <a:t>IN THE INTERVIEW</a:t>
+              <a:t>KAVYA'S REVIEW</a:t>
             </a:r>
           </a:p>
         </p:txBody>
@@ -10268,7 +10308,7 @@
                 </a:solidFill>
                 <a:latin typeface="Calibri"/>
               </a:rPr>
-              <a:t>[F] You have two hours and a raw export; what do you do first, and what do you skip? Never the reconciliation: it is fifteen minutes, and it is the step that can flip the sign.</a:t>
+              <a:t>A number that has not been reconciled can point the wrong way, and this morning it did. Put the two checks in a cell before the first number you plan to send.</a:t>
             </a:r>
           </a:p>
         </p:txBody>
@@ -10816,7 +10856,7 @@
                 </a:solidFill>
                 <a:latin typeface="Calibri"/>
               </a:rPr>
-              <a:t>Zero rejects on a file you know is dirty is a finding, not a result.</a:t>
+              <a:t>A zero-reject pass on a file you know is dirty is the first thing to investigate.</a:t>
             </a:r>
           </a:p>
         </p:txBody>
@@ -12702,7 +12742,7 @@
                 </a:solidFill>
                 <a:latin typeface="Calibri"/>
               </a:rPr>
-              <a:t>Divided by the sum, not the average</a:t>
+              <a:t>A sum where an average belonged</a:t>
             </a:r>
           </a:p>
         </p:txBody>
@@ -17872,7 +17912,7 @@
       </p:sp>
       <p:pic>
         <p:nvPicPr>
-          <p:cNvPr id="9" name="mermaid diagram" descr="ac288d601636c669.png"/>
+          <p:cNvPr id="9" name="mermaid diagram" descr="9b4d3c5884cf6c9b.png"/>
           <p:cNvPicPr>
             <a:picLocks noChangeAspect="1"/>
           </p:cNvPicPr>
@@ -17886,8 +17926,8 @@
         </p:blipFill>
         <p:spPr>
           <a:xfrm>
-            <a:off x="3427669" y="1664208"/>
-            <a:ext cx="5336355" cy="3203447"/>
+            <a:off x="2676753" y="1664208"/>
+            <a:ext cx="6838187" cy="2944368"/>
           </a:xfrm>
           <a:prstGeom prst="rect">
             <a:avLst/>
@@ -17902,8 +17942,8 @@
         </p:nvSpPr>
         <p:spPr>
           <a:xfrm>
-            <a:off x="530352" y="4913376"/>
-            <a:ext cx="11130991" cy="1121664"/>
+            <a:off x="530352" y="4654296"/>
+            <a:ext cx="11130991" cy="1380744"/>
           </a:xfrm>
           <a:prstGeom prst="roundRect">
             <a:avLst>
@@ -17956,7 +17996,7 @@
         </p:nvSpPr>
         <p:spPr>
           <a:xfrm>
-            <a:off x="758952" y="5245608"/>
+            <a:off x="758952" y="5116068"/>
             <a:ext cx="457200" cy="457200"/>
           </a:xfrm>
           <a:prstGeom prst="ellipse">
@@ -17994,7 +18034,7 @@
       </p:sp>
       <p:pic>
         <p:nvPicPr>
-          <p:cNvPr id="12" name="Picture 11" descr="search-check_6571e64a041f.png"/>
+          <p:cNvPr id="12" name="Picture 11" descr="mic_caee7398c80d.png"/>
           <p:cNvPicPr>
             <a:picLocks noChangeAspect="1"/>
           </p:cNvPicPr>
@@ -18008,7 +18048,7 @@
         </p:blipFill>
         <p:spPr>
           <a:xfrm>
-            <a:off x="868680" y="5355336"/>
+            <a:off x="868680" y="5225796"/>
             <a:ext cx="237744" cy="237744"/>
           </a:xfrm>
           <a:prstGeom prst="rect">
@@ -18024,7 +18064,7 @@
         </p:nvSpPr>
         <p:spPr>
           <a:xfrm>
-            <a:off x="1399031" y="5059680"/>
+            <a:off x="1399031" y="4800600"/>
             <a:ext cx="9987991" cy="160401"/>
           </a:xfrm>
           <a:prstGeom prst="rect">
@@ -18046,7 +18086,7 @@
                 </a:solidFill>
                 <a:latin typeface="Calibri"/>
               </a:rPr>
-              <a:t>KAVYA'S REVIEW</a:t>
+              <a:t>IN THE INTERVIEW</a:t>
             </a:r>
           </a:p>
         </p:txBody>
@@ -18059,8 +18099,8 @@
         </p:nvSpPr>
         <p:spPr>
           <a:xfrm>
-            <a:off x="1399031" y="5279136"/>
-            <a:ext cx="9987991" cy="682752"/>
+            <a:off x="1399031" y="5020056"/>
+            <a:ext cx="9987991" cy="941832"/>
           </a:xfrm>
           <a:prstGeom prst="rect">
             <a:avLst/>
@@ -18080,7 +18120,7 @@
                 </a:solidFill>
                 <a:latin typeface="Calibri"/>
               </a:rPr>
-              <a:t>A count check proves the rows are there. Only a rupee check proves the values survived. Zero is a claim that the order was worth nothing, so never let a try make it for you.</a:t>
+              <a:t>[S] Walk me through how you clean and check a dataset you have never seen. A zero-reject pass is a finding: check ids against rows, check what the code did with a value it could not read, and reconcile the rupees.</a:t>
             </a:r>
           </a:p>
         </p:txBody>
@@ -19414,7 +19454,7 @@
         <p:spPr>
           <a:xfrm>
             <a:off x="530352" y="4403407"/>
-            <a:ext cx="11130991" cy="1380744"/>
+            <a:ext cx="11130991" cy="1121664"/>
           </a:xfrm>
           <a:prstGeom prst="roundRect">
             <a:avLst>
@@ -19467,7 +19507,7 @@
         </p:nvSpPr>
         <p:spPr>
           <a:xfrm>
-            <a:off x="758952" y="4865179"/>
+            <a:off x="758952" y="4735639"/>
             <a:ext cx="457200" cy="457200"/>
           </a:xfrm>
           <a:prstGeom prst="ellipse">
@@ -19505,7 +19545,7 @@
       </p:sp>
       <p:pic>
         <p:nvPicPr>
-          <p:cNvPr id="12" name="Picture 11" descr="mic_caee7398c80d.png"/>
+          <p:cNvPr id="12" name="Picture 11" descr="search-check_6571e64a041f.png"/>
           <p:cNvPicPr>
             <a:picLocks noChangeAspect="1"/>
           </p:cNvPicPr>
@@ -19519,7 +19559,7 @@
         </p:blipFill>
         <p:spPr>
           <a:xfrm>
-            <a:off x="868680" y="4974907"/>
+            <a:off x="868680" y="4845367"/>
             <a:ext cx="237744" cy="237744"/>
           </a:xfrm>
           <a:prstGeom prst="rect">
@@ -19557,7 +19597,7 @@
                 </a:solidFill>
                 <a:latin typeface="Calibri"/>
               </a:rPr>
-              <a:t>IN THE INTERVIEW</a:t>
+              <a:t>KAVYA'S REVIEW</a:t>
             </a:r>
           </a:p>
         </p:txBody>
@@ -19571,7 +19611,7 @@
         <p:spPr>
           <a:xfrm>
             <a:off x="1399031" y="4769167"/>
-            <a:ext cx="9987991" cy="941832"/>
+            <a:ext cx="9987991" cy="682752"/>
           </a:xfrm>
           <a:prstGeom prst="rect">
             <a:avLst/>
@@ -19591,7 +19631,7 @@
                 </a:solidFill>
                 <a:latin typeface="Calibri"/>
               </a:rPr>
-              <a:t>[S] Walk me through how you clean and check a dataset you have never seen. A zero-reject pass is a finding: check ids against rows, check what the code did with a value it could not read, and reconcile the rupees.</a:t>
+              <a:t>A count check proves the rows are there. Only a rupee check proves the values survived. Zero is a claim that the order was worth nothing, so never let a try make it for you.</a:t>
             </a:r>
           </a:p>
         </p:txBody>
@@ -20139,7 +20179,7 @@
                 </a:solidFill>
                 <a:latin typeface="Calibri"/>
               </a:rPr>
-              <a:t>A rate on a handful of orders is a rumour with a percent sign.</a:t>
+              <a:t>A rate on a handful of orders cannot lead a note until its count is said.</a:t>
             </a:r>
           </a:p>
         </p:txBody>
@@ -24424,15 +24464,15 @@
           <p:nvPr/>
         </p:nvPicPr>
         <p:blipFill>
-          <a:blip r:embed="rId6"/>
+          <a:blip r:embed="rId5"/>
           <a:stretch>
             <a:fillRect/>
           </a:stretch>
         </p:blipFill>
         <p:spPr>
           <a:xfrm>
-            <a:off x="530352" y="1847727"/>
-            <a:ext cx="4786326" cy="4186672"/>
+            <a:off x="3513786" y="1682496"/>
+            <a:ext cx="5164121" cy="4517136"/>
           </a:xfrm>
           <a:prstGeom prst="rect">
             <a:avLst/>
@@ -24441,35 +24481,25 @@
       </p:pic>
       <p:sp>
         <p:nvSpPr>
-          <p:cNvPr id="10" name="Rounded Rectangle 9"/>
+          <p:cNvPr id="10" name="Oval 9"/>
           <p:cNvSpPr/>
           <p:nvPr/>
         </p:nvSpPr>
         <p:spPr>
           <a:xfrm>
-            <a:off x="5761917" y="1956816"/>
-            <a:ext cx="5899425" cy="1380744"/>
-          </a:xfrm>
-          <a:prstGeom prst="roundRect">
-            <a:avLst>
-              <a:gd name="adj" fmla="val 5000"/>
-            </a:avLst>
+            <a:off x="530352" y="6492240"/>
+            <a:ext cx="64008" cy="64008"/>
+          </a:xfrm>
+          <a:prstGeom prst="ellipse">
+            <a:avLst/>
           </a:prstGeom>
           <a:solidFill>
-            <a:srgbClr val="F7F5FD"/>
+            <a:srgbClr val="CFC9EE"/>
           </a:solidFill>
-          <a:ln w="9525">
-            <a:solidFill>
-              <a:srgbClr val="E4E1F1"/>
-            </a:solidFill>
+          <a:ln>
+            <a:noFill/>
           </a:ln>
-          <a:effectLst>
-            <a:outerShdw blurRad="76200" dist="19050" dir="5400000" algn="bl" rotWithShape="0">
-              <a:srgbClr val="1A0F5C">
-                <a:alpha val="12000"/>
-              </a:srgbClr>
-            </a:outerShdw>
-          </a:effectLst>
+          <a:effectLst/>
         </p:spPr>
         <p:style>
           <a:lnRef idx="1">
@@ -24495,14 +24525,128 @@
       </p:sp>
       <p:sp>
         <p:nvSpPr>
-          <p:cNvPr id="11" name="Oval 10"/>
+          <p:cNvPr id="11" name="TextBox 10"/>
+          <p:cNvSpPr txBox="1"/>
+          <p:nvPr/>
+        </p:nvSpPr>
+        <p:spPr>
+          <a:xfrm>
+            <a:off x="640080" y="6437376"/>
+            <a:ext cx="1516475" cy="152146"/>
+          </a:xfrm>
+          <a:prstGeom prst="rect">
+            <a:avLst/>
+          </a:prstGeom>
+          <a:noFill/>
+        </p:spPr>
+        <p:txBody>
+          <a:bodyPr wrap="square" anchor="t" lIns="0" rIns="0" tIns="0" bIns="0">
+            <a:spAutoFit/>
+          </a:bodyPr>
+          <a:lstStyle/>
+          <a:p>
+            <a:pPr algn="l"/>
+            <a:r>
+              <a:rPr sz="700" b="0" i="0">
+                <a:solidFill>
+                  <a:srgbClr val="6B6690"/>
+                </a:solidFill>
+                <a:latin typeface="Calibri"/>
+              </a:rPr>
+              <a:t>The reconciliation, skipped</a:t>
+            </a:r>
+          </a:p>
+        </p:txBody>
+      </p:sp>
+      <p:sp>
+        <p:nvSpPr>
+          <p:cNvPr id="12" name="Oval 11"/>
           <p:cNvSpPr/>
           <p:nvPr/>
         </p:nvSpPr>
         <p:spPr>
           <a:xfrm>
-            <a:off x="5990517" y="2418588"/>
-            <a:ext cx="457200" cy="457200"/>
+            <a:off x="2247995" y="6492240"/>
+            <a:ext cx="64008" cy="64008"/>
+          </a:xfrm>
+          <a:prstGeom prst="ellipse">
+            <a:avLst/>
+          </a:prstGeom>
+          <a:solidFill>
+            <a:srgbClr val="CFC9EE"/>
+          </a:solidFill>
+          <a:ln>
+            <a:noFill/>
+          </a:ln>
+          <a:effectLst/>
+        </p:spPr>
+        <p:style>
+          <a:lnRef idx="1">
+            <a:schemeClr val="accent1"/>
+          </a:lnRef>
+          <a:fillRef idx="3">
+            <a:schemeClr val="accent1"/>
+          </a:fillRef>
+          <a:effectRef idx="2">
+            <a:schemeClr val="accent1"/>
+          </a:effectRef>
+          <a:fontRef idx="minor">
+            <a:schemeClr val="lt1"/>
+          </a:fontRef>
+        </p:style>
+        <p:txBody>
+          <a:bodyPr rtlCol="0" anchor="ctr" wrap="square"/>
+          <a:lstStyle/>
+          <a:p>
+            <a:pPr algn="ctr"/>
+          </a:p>
+        </p:txBody>
+      </p:sp>
+      <p:sp>
+        <p:nvSpPr>
+          <p:cNvPr id="13" name="TextBox 12"/>
+          <p:cNvSpPr txBox="1"/>
+          <p:nvPr/>
+        </p:nvSpPr>
+        <p:spPr>
+          <a:xfrm>
+            <a:off x="2357723" y="6437376"/>
+            <a:ext cx="1424463" cy="152146"/>
+          </a:xfrm>
+          <a:prstGeom prst="rect">
+            <a:avLst/>
+          </a:prstGeom>
+          <a:noFill/>
+        </p:spPr>
+        <p:txBody>
+          <a:bodyPr wrap="square" anchor="t" lIns="0" rIns="0" tIns="0" bIns="0">
+            <a:spAutoFit/>
+          </a:bodyPr>
+          <a:lstStyle/>
+          <a:p>
+            <a:pPr algn="l"/>
+            <a:r>
+              <a:rPr sz="700" b="0" i="0">
+                <a:solidFill>
+                  <a:srgbClr val="6B6690"/>
+                </a:solidFill>
+                <a:latin typeface="Calibri"/>
+              </a:rPr>
+              <a:t>The pass that looks clean</a:t>
+            </a:r>
+          </a:p>
+        </p:txBody>
+      </p:sp>
+      <p:sp>
+        <p:nvSpPr>
+          <p:cNvPr id="14" name="Oval 13"/>
+          <p:cNvSpPr/>
+          <p:nvPr/>
+        </p:nvSpPr>
+        <p:spPr>
+          <a:xfrm>
+            <a:off x="3873627" y="6492240"/>
+            <a:ext cx="64008" cy="64008"/>
           </a:xfrm>
           <a:prstGeom prst="ellipse">
             <a:avLst/>
@@ -24537,304 +24681,9 @@
           </a:p>
         </p:txBody>
       </p:sp>
-      <p:pic>
-        <p:nvPicPr>
-          <p:cNvPr id="12" name="Picture 11" descr="search-check_6571e64a041f.png"/>
-          <p:cNvPicPr>
-            <a:picLocks noChangeAspect="1"/>
-          </p:cNvPicPr>
-          <p:nvPr/>
-        </p:nvPicPr>
-        <p:blipFill>
-          <a:blip r:embed="rId5"/>
-          <a:stretch>
-            <a:fillRect/>
-          </a:stretch>
-        </p:blipFill>
-        <p:spPr>
-          <a:xfrm>
-            <a:off x="6100245" y="2528316"/>
-            <a:ext cx="237744" cy="237744"/>
-          </a:xfrm>
-          <a:prstGeom prst="rect">
-            <a:avLst/>
-          </a:prstGeom>
-        </p:spPr>
-      </p:pic>
-      <p:sp>
-        <p:nvSpPr>
-          <p:cNvPr id="13" name="TextBox 12"/>
-          <p:cNvSpPr txBox="1"/>
-          <p:nvPr/>
-        </p:nvSpPr>
-        <p:spPr>
-          <a:xfrm>
-            <a:off x="6630597" y="2103120"/>
-            <a:ext cx="4756425" cy="160401"/>
-          </a:xfrm>
-          <a:prstGeom prst="rect">
-            <a:avLst/>
-          </a:prstGeom>
-          <a:noFill/>
-        </p:spPr>
-        <p:txBody>
-          <a:bodyPr wrap="square" anchor="t" lIns="0" rIns="0" tIns="0" bIns="0">
-            <a:spAutoFit/>
-          </a:bodyPr>
-          <a:lstStyle/>
-          <a:p>
-            <a:pPr algn="l"/>
-            <a:r>
-              <a:rPr sz="750" b="1" i="0" spc="250">
-                <a:solidFill>
-                  <a:srgbClr val="5B3FD6"/>
-                </a:solidFill>
-                <a:latin typeface="Calibri"/>
-              </a:rPr>
-              <a:t>KAVYA'S REVIEW</a:t>
-            </a:r>
-          </a:p>
-        </p:txBody>
-      </p:sp>
-      <p:sp>
-        <p:nvSpPr>
-          <p:cNvPr id="14" name="TextBox 13"/>
-          <p:cNvSpPr txBox="1"/>
-          <p:nvPr/>
-        </p:nvSpPr>
-        <p:spPr>
-          <a:xfrm>
-            <a:off x="6630597" y="2322576"/>
-            <a:ext cx="4756425" cy="941832"/>
-          </a:xfrm>
-          <a:prstGeom prst="rect">
-            <a:avLst/>
-          </a:prstGeom>
-          <a:noFill/>
-        </p:spPr>
-        <p:txBody>
-          <a:bodyPr wrap="square" anchor="t" lIns="0" rIns="0" tIns="0" bIns="0">
-            <a:spAutoFit/>
-          </a:bodyPr>
-          <a:lstStyle/>
-          <a:p>
-            <a:r>
-              <a:rPr sz="1500" b="0" i="0">
-                <a:solidFill>
-                  <a:srgbClr val="1A1440"/>
-                </a:solidFill>
-                <a:latin typeface="Calibri"/>
-              </a:rPr>
-              <a:t>Say the count before the rate, every time. "Six orders, then four" is honest; "down 29 percent" alone is a headline.</a:t>
-            </a:r>
-          </a:p>
-        </p:txBody>
-      </p:sp>
-      <p:sp>
-        <p:nvSpPr>
-          <p:cNvPr id="15" name="Oval 14"/>
-          <p:cNvSpPr/>
-          <p:nvPr/>
-        </p:nvSpPr>
-        <p:spPr>
-          <a:xfrm>
-            <a:off x="530352" y="6492240"/>
-            <a:ext cx="64008" cy="64008"/>
-          </a:xfrm>
-          <a:prstGeom prst="ellipse">
-            <a:avLst/>
-          </a:prstGeom>
-          <a:solidFill>
-            <a:srgbClr val="CFC9EE"/>
-          </a:solidFill>
-          <a:ln>
-            <a:noFill/>
-          </a:ln>
-          <a:effectLst/>
-        </p:spPr>
-        <p:style>
-          <a:lnRef idx="1">
-            <a:schemeClr val="accent1"/>
-          </a:lnRef>
-          <a:fillRef idx="3">
-            <a:schemeClr val="accent1"/>
-          </a:fillRef>
-          <a:effectRef idx="2">
-            <a:schemeClr val="accent1"/>
-          </a:effectRef>
-          <a:fontRef idx="minor">
-            <a:schemeClr val="lt1"/>
-          </a:fontRef>
-        </p:style>
-        <p:txBody>
-          <a:bodyPr rtlCol="0" anchor="ctr" wrap="square"/>
-          <a:lstStyle/>
-          <a:p>
-            <a:pPr algn="ctr"/>
-          </a:p>
-        </p:txBody>
-      </p:sp>
-      <p:sp>
-        <p:nvSpPr>
-          <p:cNvPr id="16" name="TextBox 15"/>
-          <p:cNvSpPr txBox="1"/>
-          <p:nvPr/>
-        </p:nvSpPr>
-        <p:spPr>
-          <a:xfrm>
-            <a:off x="640080" y="6437376"/>
-            <a:ext cx="1516475" cy="152146"/>
-          </a:xfrm>
-          <a:prstGeom prst="rect">
-            <a:avLst/>
-          </a:prstGeom>
-          <a:noFill/>
-        </p:spPr>
-        <p:txBody>
-          <a:bodyPr wrap="square" anchor="t" lIns="0" rIns="0" tIns="0" bIns="0">
-            <a:spAutoFit/>
-          </a:bodyPr>
-          <a:lstStyle/>
-          <a:p>
-            <a:pPr algn="l"/>
-            <a:r>
-              <a:rPr sz="700" b="0" i="0">
-                <a:solidFill>
-                  <a:srgbClr val="6B6690"/>
-                </a:solidFill>
-                <a:latin typeface="Calibri"/>
-              </a:rPr>
-              <a:t>The reconciliation, skipped</a:t>
-            </a:r>
-          </a:p>
-        </p:txBody>
-      </p:sp>
-      <p:sp>
-        <p:nvSpPr>
-          <p:cNvPr id="17" name="Oval 16"/>
-          <p:cNvSpPr/>
-          <p:nvPr/>
-        </p:nvSpPr>
-        <p:spPr>
-          <a:xfrm>
-            <a:off x="2247995" y="6492240"/>
-            <a:ext cx="64008" cy="64008"/>
-          </a:xfrm>
-          <a:prstGeom prst="ellipse">
-            <a:avLst/>
-          </a:prstGeom>
-          <a:solidFill>
-            <a:srgbClr val="CFC9EE"/>
-          </a:solidFill>
-          <a:ln>
-            <a:noFill/>
-          </a:ln>
-          <a:effectLst/>
-        </p:spPr>
-        <p:style>
-          <a:lnRef idx="1">
-            <a:schemeClr val="accent1"/>
-          </a:lnRef>
-          <a:fillRef idx="3">
-            <a:schemeClr val="accent1"/>
-          </a:fillRef>
-          <a:effectRef idx="2">
-            <a:schemeClr val="accent1"/>
-          </a:effectRef>
-          <a:fontRef idx="minor">
-            <a:schemeClr val="lt1"/>
-          </a:fontRef>
-        </p:style>
-        <p:txBody>
-          <a:bodyPr rtlCol="0" anchor="ctr" wrap="square"/>
-          <a:lstStyle/>
-          <a:p>
-            <a:pPr algn="ctr"/>
-          </a:p>
-        </p:txBody>
-      </p:sp>
-      <p:sp>
-        <p:nvSpPr>
-          <p:cNvPr id="18" name="TextBox 17"/>
-          <p:cNvSpPr txBox="1"/>
-          <p:nvPr/>
-        </p:nvSpPr>
-        <p:spPr>
-          <a:xfrm>
-            <a:off x="2357723" y="6437376"/>
-            <a:ext cx="1424463" cy="152146"/>
-          </a:xfrm>
-          <a:prstGeom prst="rect">
-            <a:avLst/>
-          </a:prstGeom>
-          <a:noFill/>
-        </p:spPr>
-        <p:txBody>
-          <a:bodyPr wrap="square" anchor="t" lIns="0" rIns="0" tIns="0" bIns="0">
-            <a:spAutoFit/>
-          </a:bodyPr>
-          <a:lstStyle/>
-          <a:p>
-            <a:pPr algn="l"/>
-            <a:r>
-              <a:rPr sz="700" b="0" i="0">
-                <a:solidFill>
-                  <a:srgbClr val="6B6690"/>
-                </a:solidFill>
-                <a:latin typeface="Calibri"/>
-              </a:rPr>
-              <a:t>The pass that looks clean</a:t>
-            </a:r>
-          </a:p>
-        </p:txBody>
-      </p:sp>
-      <p:sp>
-        <p:nvSpPr>
-          <p:cNvPr id="19" name="Oval 18"/>
-          <p:cNvSpPr/>
-          <p:nvPr/>
-        </p:nvSpPr>
-        <p:spPr>
-          <a:xfrm>
-            <a:off x="3873627" y="6492240"/>
-            <a:ext cx="64008" cy="64008"/>
-          </a:xfrm>
-          <a:prstGeom prst="ellipse">
-            <a:avLst/>
-          </a:prstGeom>
-          <a:solidFill>
-            <a:srgbClr val="5B3FD6"/>
-          </a:solidFill>
-          <a:ln>
-            <a:noFill/>
-          </a:ln>
-          <a:effectLst/>
-        </p:spPr>
-        <p:style>
-          <a:lnRef idx="1">
-            <a:schemeClr val="accent1"/>
-          </a:lnRef>
-          <a:fillRef idx="3">
-            <a:schemeClr val="accent1"/>
-          </a:fillRef>
-          <a:effectRef idx="2">
-            <a:schemeClr val="accent1"/>
-          </a:effectRef>
-          <a:fontRef idx="minor">
-            <a:schemeClr val="lt1"/>
-          </a:fontRef>
-        </p:style>
-        <p:txBody>
-          <a:bodyPr rtlCol="0" anchor="ctr" wrap="square"/>
-          <a:lstStyle/>
-          <a:p>
-            <a:pPr algn="ctr"/>
-          </a:p>
-        </p:txBody>
-      </p:sp>
-      <p:sp>
-        <p:nvSpPr>
-          <p:cNvPr id="20" name="TextBox 19"/>
+      <p:sp>
+        <p:nvSpPr>
+          <p:cNvPr id="15" name="TextBox 14"/>
           <p:cNvSpPr txBox="1"/>
           <p:nvPr/>
         </p:nvSpPr>
@@ -24869,7 +24718,7 @@
       </p:sp>
       <p:sp>
         <p:nvSpPr>
-          <p:cNvPr id="21" name="TextBox 20"/>
+          <p:cNvPr id="16" name="TextBox 15"/>
           <p:cNvSpPr txBox="1"/>
           <p:nvPr/>
         </p:nvSpPr>
@@ -26310,7 +26159,7 @@
         </p:nvGraphicFramePr>
         <p:xfrm>
           <a:off x="530352" y="1956816"/>
-          <a:ext cx="11130990" cy="1676400"/>
+          <a:ext cx="11130989" cy="1676400"/>
         </p:xfrm>
         <a:graphic>
           <a:graphicData uri="http://schemas.openxmlformats.org/drawingml/2006/table">
@@ -26319,10 +26168,10 @@
                 <a:tableStyleId>{2D5ABB26-0587-4C30-8999-92F81FD0307C}</a:tableStyleId>
               </a:tblPr>
               <a:tblGrid>
-                <a:gridCol w="3144807"/>
-                <a:gridCol w="3673733"/>
+                <a:gridCol w="2719560"/>
+                <a:gridCol w="4434823"/>
                 <a:gridCol w="914400"/>
-                <a:gridCol w="2483650"/>
+                <a:gridCol w="2147806"/>
                 <a:gridCol w="914400"/>
               </a:tblGrid>
               <a:tr h="335280">
@@ -26696,7 +26545,7 @@
                           </a:solidFill>
                           <a:latin typeface="Calibri"/>
                         </a:rPr>
-                        <a:t>Retail-Core basket -17.1%</a:t>
+                        <a:t>Retail-Core basket -17.1%, Rs 15,400</a:t>
                       </a:r>
                     </a:p>
                   </a:txBody>
@@ -26898,7 +26747,7 @@
         <p:spPr>
           <a:xfrm>
             <a:off x="530352" y="3889248"/>
-            <a:ext cx="11130991" cy="1121664"/>
+            <a:ext cx="11130991" cy="1639824"/>
           </a:xfrm>
           <a:prstGeom prst="roundRect">
             <a:avLst>
@@ -26951,7 +26800,7 @@
         </p:nvSpPr>
         <p:spPr>
           <a:xfrm>
-            <a:off x="758952" y="4221480"/>
+            <a:off x="758952" y="4480560"/>
             <a:ext cx="457200" cy="457200"/>
           </a:xfrm>
           <a:prstGeom prst="ellipse">
@@ -27003,7 +26852,7 @@
         </p:blipFill>
         <p:spPr>
           <a:xfrm>
-            <a:off x="868680" y="4331208"/>
+            <a:off x="868680" y="4590288"/>
             <a:ext cx="237744" cy="237744"/>
           </a:xfrm>
           <a:prstGeom prst="rect">
@@ -27055,7 +26904,7 @@
         <p:spPr>
           <a:xfrm>
             <a:off x="1399031" y="4255008"/>
-            <a:ext cx="9987991" cy="682752"/>
+            <a:ext cx="9987991" cy="1200912"/>
           </a:xfrm>
           <a:prstGeom prst="rect">
             <a:avLst/>
@@ -27075,7 +26924,7 @@
                 </a:solidFill>
                 <a:latin typeface="Calibri"/>
               </a:rPr>
-              <a:t>C. Switch when Meera's question is about accounts rather than rates, when a segment carries hundreds of orders a quarter, or when a second quarter repeats the move.</a:t>
+              <a:t>C: the one consumer move on enough orders to test, small in rupees (0.9 percent of the fall) and led beside the corporate move said as counts. Switch when Meera's question is about accounts rather than rates, when a segment carries hundreds of orders a quarter, or when a second quarter repeats the move.</a:t>
             </a:r>
           </a:p>
         </p:txBody>
@@ -28746,7 +28595,7 @@
       </p:sp>
       <p:pic>
         <p:nvPicPr>
-          <p:cNvPr id="9" name="mermaid diagram" descr="59eec21f7ba113f8.png"/>
+          <p:cNvPr id="9" name="mermaid diagram" descr="8095a9870cd63487.png"/>
           <p:cNvPicPr>
             <a:picLocks noChangeAspect="1"/>
           </p:cNvPicPr>
@@ -28868,7 +28717,7 @@
       </p:sp>
       <p:pic>
         <p:nvPicPr>
-          <p:cNvPr id="12" name="Picture 11" descr="list-checks_bd88901d2a37.png"/>
+          <p:cNvPr id="12" name="Picture 11" descr="search-check_6571e64a041f.png"/>
           <p:cNvPicPr>
             <a:picLocks noChangeAspect="1"/>
           </p:cNvPicPr>
@@ -28920,7 +28769,7 @@
                 </a:solidFill>
                 <a:latin typeface="Calibri"/>
               </a:rPr>
-              <a:t>THE RULE</a:t>
+              <a:t>KAVYA'S REVIEW</a:t>
             </a:r>
           </a:p>
         </p:txBody>
@@ -28954,7 +28803,7 @@
                 </a:solidFill>
                 <a:latin typeface="Calibri"/>
               </a:rPr>
-              <a:t>The shuffle says whether the gap is bigger than chance; the customer count says whether it is broad. When they disagree, a handful of customers moved the average, and the note says so.</a:t>
+              <a:t>Say the count before the rate, every time. "Six orders, then four" is honest; "down 29 percent" alone is a headline.</a:t>
             </a:r>
           </a:p>
         </p:txBody>
@@ -29536,7 +29385,7 @@
         <p:spPr>
           <a:xfrm>
             <a:off x="530352" y="1956816"/>
-            <a:ext cx="5474055" cy="1964436"/>
+            <a:ext cx="5474055" cy="2154428"/>
           </a:xfrm>
           <a:prstGeom prst="roundRect">
             <a:avLst>
@@ -29769,7 +29618,7 @@
         <p:spPr>
           <a:xfrm>
             <a:off x="6187287" y="1956816"/>
-            <a:ext cx="5474055" cy="1964436"/>
+            <a:ext cx="5474055" cy="2154428"/>
           </a:xfrm>
           <a:prstGeom prst="roundRect">
             <a:avLst>
@@ -29961,7 +29810,7 @@
         <p:spPr>
           <a:xfrm>
             <a:off x="6388455" y="3303524"/>
-            <a:ext cx="5071719" cy="399796"/>
+            <a:ext cx="5071719" cy="581406"/>
           </a:xfrm>
           <a:prstGeom prst="rect">
             <a:avLst/>
@@ -29982,7 +29831,7 @@
                 </a:solidFill>
                 <a:latin typeface="Calibri"/>
               </a:rPr>
-              <a:t>A customer's orders split across groups, the chance spread widens, and a real gap reads as noise.</a:t>
+              <a:t>Orders treated as independent. Most often that makes p too small; here it breaks each customer's Q1 to Q2 pairing, so a real gap reads as chance.</a:t>
             </a:r>
           </a:p>
         </p:txBody>
@@ -29995,7 +29844,7 @@
         </p:nvSpPr>
         <p:spPr>
           <a:xfrm>
-            <a:off x="530352" y="4104132"/>
+            <a:off x="530352" y="4294124"/>
             <a:ext cx="11130991" cy="862584"/>
           </a:xfrm>
           <a:prstGeom prst="roundRect">
@@ -30049,7 +29898,7 @@
         </p:nvSpPr>
         <p:spPr>
           <a:xfrm>
-            <a:off x="758952" y="4306824"/>
+            <a:off x="758952" y="4496816"/>
             <a:ext cx="457200" cy="457200"/>
           </a:xfrm>
           <a:prstGeom prst="ellipse">
@@ -30101,7 +29950,7 @@
         </p:blipFill>
         <p:spPr>
           <a:xfrm>
-            <a:off x="868680" y="4416552"/>
+            <a:off x="868680" y="4606544"/>
             <a:ext cx="237744" cy="237744"/>
           </a:xfrm>
           <a:prstGeom prst="rect">
@@ -30117,7 +29966,7 @@
         </p:nvSpPr>
         <p:spPr>
           <a:xfrm>
-            <a:off x="1399031" y="4250436"/>
+            <a:off x="1399031" y="4440428"/>
             <a:ext cx="9987991" cy="160401"/>
           </a:xfrm>
           <a:prstGeom prst="rect">
@@ -30152,7 +30001,7 @@
         </p:nvSpPr>
         <p:spPr>
           <a:xfrm>
-            <a:off x="1399031" y="4469892"/>
+            <a:off x="1399031" y="4659884"/>
             <a:ext cx="9987991" cy="423672"/>
           </a:xfrm>
           <a:prstGeom prst="rect">
@@ -32559,7 +32408,7 @@
         <p:spPr>
           <a:xfrm>
             <a:off x="530352" y="4103624"/>
-            <a:ext cx="11130991" cy="1121664"/>
+            <a:ext cx="11130991" cy="862584"/>
           </a:xfrm>
           <a:prstGeom prst="roundRect">
             <a:avLst>
@@ -32612,7 +32461,7 @@
         </p:nvSpPr>
         <p:spPr>
           <a:xfrm>
-            <a:off x="758952" y="4435856"/>
+            <a:off x="758952" y="4306316"/>
             <a:ext cx="457200" cy="457200"/>
           </a:xfrm>
           <a:prstGeom prst="ellipse">
@@ -32664,7 +32513,7 @@
         </p:blipFill>
         <p:spPr>
           <a:xfrm>
-            <a:off x="868680" y="4545584"/>
+            <a:off x="868680" y="4416044"/>
             <a:ext cx="237744" cy="237744"/>
           </a:xfrm>
           <a:prstGeom prst="rect">
@@ -32716,7 +32565,7 @@
         <p:spPr>
           <a:xfrm>
             <a:off x="1399031" y="4469384"/>
-            <a:ext cx="9987991" cy="682752"/>
+            <a:ext cx="9987991" cy="423672"/>
           </a:xfrm>
           <a:prstGeom prst="rect">
             <a:avLst/>
@@ -32736,7 +32585,7 @@
                 </a:solidFill>
                 <a:latin typeface="Calibri"/>
               </a:rPr>
-              <a:t>The lab told you which step you do not own yet. One rerun tonight is worth more than rereading all four days.</a:t>
+              <a:t>The lab told you which step you do not own yet. Rerun that step tonight on the practice export.</a:t>
             </a:r>
           </a:p>
         </p:txBody>

</xml_diff>

<commit_message>
W01 D5: depth loop round two fixed: notebook openers render as prose, practice items cue nothing and gain a find-the-defect item, the practice test's handlings labelled as run, deck question keys and captions fixed
Co-Authored-By: Claude Opus 5.5 <noreply@anthropic.com>
Claude-Session: https://claude.ai/code/session_01GMyE3nGptgYS2FxtWfW4y9
</commit_message>
<xml_diff>
--- a/content/W01/D5/slides/C2_W01_D05_debrief_STUDENT.pptx
+++ b/content/W01/D5/slides/C2_W01_D05_debrief_STUDENT.pptx
@@ -7716,7 +7716,7 @@
         <p:spPr>
           <a:xfrm>
             <a:off x="530352" y="4104132"/>
-            <a:ext cx="11130991" cy="1121664"/>
+            <a:ext cx="11130991" cy="862584"/>
           </a:xfrm>
           <a:prstGeom prst="roundRect">
             <a:avLst>
@@ -7769,7 +7769,7 @@
         </p:nvSpPr>
         <p:spPr>
           <a:xfrm>
-            <a:off x="758952" y="4436364"/>
+            <a:off x="758952" y="4306824"/>
             <a:ext cx="457200" cy="457200"/>
           </a:xfrm>
           <a:prstGeom prst="ellipse">
@@ -7821,7 +7821,7 @@
         </p:blipFill>
         <p:spPr>
           <a:xfrm>
-            <a:off x="868680" y="4546092"/>
+            <a:off x="868680" y="4416552"/>
             <a:ext cx="237744" cy="237744"/>
           </a:xfrm>
           <a:prstGeom prst="rect">
@@ -7873,7 +7873,7 @@
         <p:spPr>
           <a:xfrm>
             <a:off x="1399031" y="4469892"/>
-            <a:ext cx="9987991" cy="682752"/>
+            <a:ext cx="9987991" cy="423672"/>
           </a:xfrm>
           <a:prstGeom prst="rect">
             <a:avLst/>
@@ -7893,7 +7893,7 @@
                 </a:solidFill>
                 <a:latin typeface="Calibri"/>
               </a:rPr>
-              <a:t>[F] You have two hours and a raw export; what do you do first, and what do you skip? Never the reconciliation: it is fifteen minutes, and it is the step that can flip the sign.</a:t>
+              <a:t>[F] You have two hours and a raw export; what do you do first, and what do you skip?</a:t>
             </a:r>
           </a:p>
         </p:txBody>
@@ -9765,7 +9765,7 @@
                 </a:solidFill>
                 <a:latin typeface="Calibri"/>
               </a:rPr>
-              <a:t>It produces no new number, so it feels like the step that can wait.</a:t>
+              <a:t>Fifteen of ninety minutes, and its only output is a yes or a no, so it feels like the step that can wait.</a:t>
             </a:r>
           </a:p>
         </p:txBody>
@@ -9825,42 +9825,7 @@
       </p:sp>
       <p:sp>
         <p:nvSpPr>
-          <p:cNvPr id="10" name="TextBox 9"/>
-          <p:cNvSpPr txBox="1"/>
-          <p:nvPr/>
-        </p:nvSpPr>
-        <p:spPr>
-          <a:xfrm>
-            <a:off x="530352" y="2487168"/>
-            <a:ext cx="2473553" cy="176911"/>
-          </a:xfrm>
-          <a:prstGeom prst="rect">
-            <a:avLst/>
-          </a:prstGeom>
-          <a:noFill/>
-        </p:spPr>
-        <p:txBody>
-          <a:bodyPr wrap="square" anchor="t" lIns="0" rIns="0" tIns="0" bIns="0">
-            <a:spAutoFit/>
-          </a:bodyPr>
-          <a:lstStyle/>
-          <a:p>
-            <a:pPr algn="ctr"/>
-            <a:r>
-              <a:rPr sz="850" b="0" i="0">
-                <a:solidFill>
-                  <a:srgbClr val="6B6690"/>
-                </a:solidFill>
-                <a:latin typeface="Calibri"/>
-              </a:rPr>
-              <a:t>a new picture of the file</a:t>
-            </a:r>
-          </a:p>
-        </p:txBody>
-      </p:sp>
-      <p:sp>
-        <p:nvSpPr>
-          <p:cNvPr id="11" name="Rectangle 10"/>
+          <p:cNvPr id="10" name="Rectangle 9"/>
           <p:cNvSpPr/>
           <p:nvPr/>
         </p:nvSpPr>
@@ -9913,42 +9878,7 @@
       </p:sp>
       <p:sp>
         <p:nvSpPr>
-          <p:cNvPr id="12" name="TextBox 11"/>
-          <p:cNvSpPr txBox="1"/>
-          <p:nvPr/>
-        </p:nvSpPr>
-        <p:spPr>
-          <a:xfrm>
-            <a:off x="3003905" y="2487168"/>
-            <a:ext cx="3710330" cy="176911"/>
-          </a:xfrm>
-          <a:prstGeom prst="rect">
-            <a:avLst/>
-          </a:prstGeom>
-          <a:noFill/>
-        </p:spPr>
-        <p:txBody>
-          <a:bodyPr wrap="square" anchor="t" lIns="0" rIns="0" tIns="0" bIns="0">
-            <a:spAutoFit/>
-          </a:bodyPr>
-          <a:lstStyle/>
-          <a:p>
-            <a:pPr algn="ctr"/>
-            <a:r>
-              <a:rPr sz="850" b="0" i="0">
-                <a:solidFill>
-                  <a:srgbClr val="6B6690"/>
-                </a:solidFill>
-                <a:latin typeface="Calibri"/>
-              </a:rPr>
-              <a:t>a smaller, tidier file</a:t>
-            </a:r>
-          </a:p>
-        </p:txBody>
-      </p:sp>
-      <p:sp>
-        <p:nvSpPr>
-          <p:cNvPr id="13" name="Rectangle 12"/>
+          <p:cNvPr id="11" name="Rectangle 10"/>
           <p:cNvSpPr/>
           <p:nvPr/>
         </p:nvSpPr>
@@ -10001,42 +9931,7 @@
       </p:sp>
       <p:sp>
         <p:nvSpPr>
-          <p:cNvPr id="14" name="TextBox 13"/>
-          <p:cNvSpPr txBox="1"/>
-          <p:nvPr/>
-        </p:nvSpPr>
-        <p:spPr>
-          <a:xfrm>
-            <a:off x="6714236" y="2487168"/>
-            <a:ext cx="1855165" cy="176911"/>
-          </a:xfrm>
-          <a:prstGeom prst="rect">
-            <a:avLst/>
-          </a:prstGeom>
-          <a:noFill/>
-        </p:spPr>
-        <p:txBody>
-          <a:bodyPr wrap="square" anchor="t" lIns="0" rIns="0" tIns="0" bIns="0">
-            <a:spAutoFit/>
-          </a:bodyPr>
-          <a:lstStyle/>
-          <a:p>
-            <a:pPr algn="ctr"/>
-            <a:r>
-              <a:rPr sz="850" b="0" i="0">
-                <a:solidFill>
-                  <a:srgbClr val="6B6690"/>
-                </a:solidFill>
-                <a:latin typeface="Calibri"/>
-              </a:rPr>
-              <a:t>no new number, only a yes or a no</a:t>
-            </a:r>
-          </a:p>
-        </p:txBody>
-      </p:sp>
-      <p:sp>
-        <p:nvSpPr>
-          <p:cNvPr id="15" name="Rectangle 14"/>
+          <p:cNvPr id="12" name="Rectangle 11"/>
           <p:cNvSpPr/>
           <p:nvPr/>
         </p:nvSpPr>
@@ -10089,42 +9984,7 @@
       </p:sp>
       <p:sp>
         <p:nvSpPr>
-          <p:cNvPr id="16" name="TextBox 15"/>
-          <p:cNvSpPr txBox="1"/>
-          <p:nvPr/>
-        </p:nvSpPr>
-        <p:spPr>
-          <a:xfrm>
-            <a:off x="8569401" y="2487168"/>
-            <a:ext cx="3091941" cy="176911"/>
-          </a:xfrm>
-          <a:prstGeom prst="rect">
-            <a:avLst/>
-          </a:prstGeom>
-          <a:noFill/>
-        </p:spPr>
-        <p:txBody>
-          <a:bodyPr wrap="square" anchor="t" lIns="0" rIns="0" tIns="0" bIns="0">
-            <a:spAutoFit/>
-          </a:bodyPr>
-          <a:lstStyle/>
-          <a:p>
-            <a:pPr algn="ctr"/>
-            <a:r>
-              <a:rPr sz="850" b="0" i="0">
-                <a:solidFill>
-                  <a:srgbClr val="6B6690"/>
-                </a:solidFill>
-                <a:latin typeface="Calibri"/>
-              </a:rPr>
-              <a:t>the finding</a:t>
-            </a:r>
-          </a:p>
-        </p:txBody>
-      </p:sp>
-      <p:sp>
-        <p:nvSpPr>
-          <p:cNvPr id="17" name="Rounded Rectangle 16"/>
+          <p:cNvPr id="13" name="Rounded Rectangle 12"/>
           <p:cNvSpPr/>
           <p:nvPr/>
         </p:nvSpPr>
@@ -10178,7 +10038,7 @@
       </p:sp>
       <p:sp>
         <p:nvSpPr>
-          <p:cNvPr id="18" name="Oval 17"/>
+          <p:cNvPr id="14" name="Oval 13"/>
           <p:cNvSpPr/>
           <p:nvPr/>
         </p:nvSpPr>
@@ -10222,7 +10082,7 @@
       </p:sp>
       <p:pic>
         <p:nvPicPr>
-          <p:cNvPr id="19" name="Picture 18" descr="search-check_6571e64a041f.png"/>
+          <p:cNvPr id="15" name="Picture 14" descr="search-check_6571e64a041f.png"/>
           <p:cNvPicPr>
             <a:picLocks noChangeAspect="1"/>
           </p:cNvPicPr>
@@ -10246,7 +10106,7 @@
       </p:pic>
       <p:sp>
         <p:nvSpPr>
-          <p:cNvPr id="20" name="TextBox 19"/>
+          <p:cNvPr id="16" name="TextBox 15"/>
           <p:cNvSpPr txBox="1"/>
           <p:nvPr/>
         </p:nvSpPr>
@@ -10281,7 +10141,7 @@
       </p:sp>
       <p:sp>
         <p:nvSpPr>
-          <p:cNvPr id="21" name="TextBox 20"/>
+          <p:cNvPr id="17" name="TextBox 16"/>
           <p:cNvSpPr txBox="1"/>
           <p:nvPr/>
         </p:nvSpPr>
@@ -10315,7 +10175,7 @@
       </p:sp>
       <p:sp>
         <p:nvSpPr>
-          <p:cNvPr id="22" name="Oval 21"/>
+          <p:cNvPr id="18" name="Oval 17"/>
           <p:cNvSpPr/>
           <p:nvPr/>
         </p:nvSpPr>
@@ -10359,7 +10219,7 @@
       </p:sp>
       <p:sp>
         <p:nvSpPr>
-          <p:cNvPr id="23" name="TextBox 22"/>
+          <p:cNvPr id="19" name="TextBox 18"/>
           <p:cNvSpPr txBox="1"/>
           <p:nvPr/>
         </p:nvSpPr>
@@ -10394,7 +10254,7 @@
       </p:sp>
       <p:sp>
         <p:nvSpPr>
-          <p:cNvPr id="24" name="Oval 23"/>
+          <p:cNvPr id="20" name="Oval 19"/>
           <p:cNvSpPr/>
           <p:nvPr/>
         </p:nvSpPr>
@@ -10438,7 +10298,7 @@
       </p:sp>
       <p:sp>
         <p:nvSpPr>
-          <p:cNvPr id="25" name="TextBox 24"/>
+          <p:cNvPr id="21" name="TextBox 20"/>
           <p:cNvSpPr txBox="1"/>
           <p:nvPr/>
         </p:nvSpPr>
@@ -10473,7 +10333,7 @@
       </p:sp>
       <p:sp>
         <p:nvSpPr>
-          <p:cNvPr id="26" name="Oval 25"/>
+          <p:cNvPr id="22" name="Oval 21"/>
           <p:cNvSpPr/>
           <p:nvPr/>
         </p:nvSpPr>
@@ -10517,7 +10377,7 @@
       </p:sp>
       <p:sp>
         <p:nvSpPr>
-          <p:cNvPr id="27" name="TextBox 26"/>
+          <p:cNvPr id="23" name="TextBox 22"/>
           <p:cNvSpPr txBox="1"/>
           <p:nvPr/>
         </p:nvSpPr>
@@ -10552,7 +10412,7 @@
       </p:sp>
       <p:sp>
         <p:nvSpPr>
-          <p:cNvPr id="28" name="TextBox 27"/>
+          <p:cNvPr id="24" name="TextBox 23"/>
           <p:cNvSpPr txBox="1"/>
           <p:nvPr/>
         </p:nvSpPr>
@@ -17392,7 +17252,7 @@
                 </a:solidFill>
                 <a:latin typeface="Calibri"/>
               </a:rPr>
-              <a:t>C, when the value can be read without guessing, as digits with an Indian ledger's grouping commas can. D when it cannot: a word, a unit that could be lakh or crore. B when the row is not an order. A never, because it is the one that hides.</a:t>
+              <a:t>C, when the value can be read without guessing, as digits with an Indian ledger's grouping commas can. D when it cannot: a word, a unit that could be lakh or crore. B when the row is not an order. A is the one option that hides its gap.</a:t>
             </a:r>
           </a:p>
         </p:txBody>
@@ -23937,7 +23797,7 @@
                 </a:solidFill>
                 <a:latin typeface="Calibri"/>
               </a:rPr>
-              <a:t>Choose one: a) as the headline trend, since it is the largest move in rupees; b) as the headline, with a p-value beside it; c) left out, since ten orders are too few to matter; d) as counts, two fewer corporate orders, with the account owner asked which two, and the lead given to the branch that moved on enough orders.</a:t>
+              <a:t>Choose one: a) as the headline trend, since it is the largest move in rupees on the page; b) as the headline, with a shuffle test's p-value printed beside the rate; c) left out of the note, since ten orders are too few to matter to anyone; d) as counts, two fewer corporate orders, with a question to their owner.</a:t>
             </a:r>
           </a:p>
         </p:txBody>
@@ -27805,7 +27665,7 @@
                 </a:solidFill>
                 <a:latin typeface="Calibri"/>
               </a:rPr>
-              <a:t>A SHARE OF</a:t>
+              <a:t>A SHARE OF CHANCE-ONLY WORLDS</a:t>
             </a:r>
           </a:p>
         </p:txBody>
@@ -27840,7 +27700,7 @@
                 </a:solidFill>
                 <a:latin typeface="Calibri"/>
               </a:rPr>
-              <a:t>chance-only worlds, never the chance of being wrong</a:t>
+              <a:t>never the chance of being wrong</a:t>
             </a:r>
           </a:p>
         </p:txBody>
@@ -28626,7 +28486,7 @@
         <p:spPr>
           <a:xfrm>
             <a:off x="530352" y="4146232"/>
-            <a:ext cx="11130991" cy="1121664"/>
+            <a:ext cx="11130991" cy="862584"/>
           </a:xfrm>
           <a:prstGeom prst="roundRect">
             <a:avLst>
@@ -28679,7 +28539,7 @@
         </p:nvSpPr>
         <p:spPr>
           <a:xfrm>
-            <a:off x="758952" y="4478464"/>
+            <a:off x="758952" y="4348924"/>
             <a:ext cx="457200" cy="457200"/>
           </a:xfrm>
           <a:prstGeom prst="ellipse">
@@ -28731,7 +28591,7 @@
         </p:blipFill>
         <p:spPr>
           <a:xfrm>
-            <a:off x="868680" y="4588192"/>
+            <a:off x="868680" y="4458652"/>
             <a:ext cx="237744" cy="237744"/>
           </a:xfrm>
           <a:prstGeom prst="rect">
@@ -28783,7 +28643,7 @@
         <p:spPr>
           <a:xfrm>
             <a:off x="1399031" y="4511992"/>
-            <a:ext cx="9987991" cy="682752"/>
+            <a:ext cx="9987991" cy="423672"/>
           </a:xfrm>
           <a:prstGeom prst="rect">
             <a:avLst/>
@@ -28803,7 +28663,7 @@
                 </a:solidFill>
                 <a:latin typeface="Calibri"/>
               </a:rPr>
-              <a:t>Say the count before the rate, every time. "Six orders, then four" is honest; "down 29 percent" alone is a headline.</a:t>
+              <a:t>Say the count before the rate, every time: "six orders, then four", and then the percentage.</a:t>
             </a:r>
           </a:p>
         </p:txBody>
@@ -31228,7 +31088,7 @@
                 </a:solidFill>
                 <a:latin typeface="Calibri"/>
               </a:rPr>
-              <a:t>Describe a file with its median and say what sits above it. The mean belongs in anything that has to reconcile, never in a sentence about a typical order.</a:t>
+              <a:t>Describe a file with its median and say what sits above it. Keep the mean for anything that has to reconcile.</a:t>
             </a:r>
           </a:p>
         </p:txBody>
@@ -35262,7 +35122,7 @@
                 </a:solidFill>
                 <a:latin typeface="Calibri"/>
               </a:rPr>
-              <a:t>Choose one: a) the median order, in case one large order moved the total; b) the p-value of the Q1 to Q2 change; c) rows against Finance's order counts, and each quarter's rupees against its control total; d) the segment split, to see which segment grew.</a:t>
+              <a:t>Choose one: a) the median order, in case one large order moved the total on its own; b) the p-value of the Q1 to Q2 change, with 2,000 shuffles on customers; c) orders and rupees per quarter against Finance's control totals; d) the segment split, to see which of the four segments grew the most.</a:t>
             </a:r>
           </a:p>
         </p:txBody>

</xml_diff>

<commit_message>
W01 D5: depth loop round three fixed: practice items set on other exports and no longer cue each other, p-value wording held to its definition, deck question keys and client lines give nothing away, last contrast lines rewritten
Co-Authored-By: Claude Opus 5.5 <noreply@anthropic.com>
Claude-Session: https://claude.ai/code/session_01GMyE3nGptgYS2FxtWfW4y9
</commit_message>
<xml_diff>
--- a/content/W01/D5/slides/C2_W01_D05_debrief_STUDENT.pptx
+++ b/content/W01/D5/slides/C2_W01_D05_debrief_STUDENT.pptx
@@ -11836,7 +11836,7 @@
                 </a:solidFill>
                 <a:latin typeface="Calibri"/>
               </a:rPr>
-              <a:t>Your pass reports zero rejects and every count lands. Show me the rupees.</a:t>
+              <a:t>Your pass reports zero rejects and every count lands. Is it finished?</a:t>
             </a:r>
           </a:p>
         </p:txBody>
@@ -14638,7 +14638,7 @@
         <p:spPr>
           <a:xfrm>
             <a:off x="530352" y="1956816"/>
-            <a:ext cx="11130991" cy="1074420"/>
+            <a:ext cx="11130991" cy="807720"/>
           </a:xfrm>
           <a:prstGeom prst="roundRect">
             <a:avLst>
@@ -14686,7 +14686,7 @@
         <p:spPr>
           <a:xfrm>
             <a:off x="676656" y="2084832"/>
-            <a:ext cx="45720" cy="818388"/>
+            <a:ext cx="45720" cy="551688"/>
           </a:xfrm>
           <a:prstGeom prst="roundRect">
             <a:avLst>
@@ -14732,7 +14732,7 @@
         <p:spPr>
           <a:xfrm>
             <a:off x="877824" y="2075688"/>
-            <a:ext cx="10564063" cy="891540"/>
+            <a:ext cx="10564063" cy="624840"/>
           </a:xfrm>
           <a:prstGeom prst="rect">
             <a:avLst/>
@@ -14761,7 +14761,7 @@
                 </a:solidFill>
                 <a:latin typeface="Calibri"/>
               </a:rPr>
-              <a:t>Choose one: a) nothing, since every row is accounted for; b) the rupees, each quarter against its control total; c) the median, since one large order may have gone; d) the dates, since the quarter may be cut wrong.</a:t>
+              <a:t>Choose one: a) nothing, since every row is accounted for; b) the rupees against each control total; c) the median, since one large order may have gone; d) the dates, since the quarter may be cut wrong.</a:t>
             </a:r>
           </a:p>
         </p:txBody>
@@ -25308,7 +25308,7 @@
         <p:spPr>
           <a:xfrm>
             <a:off x="530352" y="3419856"/>
-            <a:ext cx="11130991" cy="1121664"/>
+            <a:ext cx="11130991" cy="862584"/>
           </a:xfrm>
           <a:prstGeom prst="roundRect">
             <a:avLst>
@@ -25367,7 +25367,7 @@
         </p:nvSpPr>
         <p:spPr>
           <a:xfrm>
-            <a:off x="758952" y="3752088"/>
+            <a:off x="758952" y="3622548"/>
             <a:ext cx="457200" cy="457200"/>
           </a:xfrm>
           <a:prstGeom prst="ellipse">
@@ -25419,7 +25419,7 @@
         </p:blipFill>
         <p:spPr>
           <a:xfrm>
-            <a:off x="868680" y="3861816"/>
+            <a:off x="868680" y="3732276"/>
             <a:ext cx="237744" cy="237744"/>
           </a:xfrm>
           <a:prstGeom prst="rect">
@@ -25471,7 +25471,7 @@
         <p:spPr>
           <a:xfrm>
             <a:off x="1399031" y="3785616"/>
-            <a:ext cx="9987991" cy="682752"/>
+            <a:ext cx="9987991" cy="423672"/>
           </a:xfrm>
           <a:prstGeom prst="rect">
             <a:avLst/>
@@ -25491,7 +25491,7 @@
                 </a:solidFill>
                 <a:latin typeface="Calibri"/>
               </a:rPr>
-              <a:t>Does the data you cleaned still add up to what Finance booked, before anyone reads a branch of the tree?</a:t>
+              <a:t>Can the number in your note go to Meera as it stands?</a:t>
             </a:r>
           </a:p>
         </p:txBody>

</xml_diff>

<commit_message>
W01 D5: depth loop round four fixed: no slide or item cues another's key, the last contrast lines restated
Co-Authored-By: Claude Opus 5.5 <noreply@anthropic.com>
Claude-Session: https://claude.ai/code/session_01GMyE3nGptgYS2FxtWfW4y9
</commit_message>
<xml_diff>
--- a/content/W01/D5/slides/C2_W01_D05_debrief_STUDENT.pptx
+++ b/content/W01/D5/slides/C2_W01_D05_debrief_STUDENT.pptx
@@ -11157,7 +11157,7 @@
                 </a:solidFill>
                 <a:latin typeface="Georgia"/>
               </a:rPr>
-              <a:t>The base of every rate is Q1's rupees</a:t>
+              <a:t>Anand's analyst audits the note first</a:t>
             </a:r>
           </a:p>
         </p:txBody>
@@ -11192,7 +11192,7 @@
                 </a:solidFill>
                 <a:latin typeface="Calibri"/>
               </a:rPr>
-              <a:t>Anand's analyst audits the note, and their first question is always the rupees.</a:t>
+              <a:t>The Q1 total is the base every Q1 to Q2 rate divides by.</a:t>
             </a:r>
           </a:p>
         </p:txBody>
@@ -14067,7 +14067,7 @@
                 </a:solidFill>
                 <a:latin typeface="Calibri"/>
               </a:rPr>
-              <a:t>the base of every rate</a:t>
+              <a:t>every row kept</a:t>
             </a:r>
           </a:p>
         </p:txBody>
@@ -15864,7 +15864,7 @@
         <p:spPr>
           <a:xfrm>
             <a:off x="731519" y="3520440"/>
-            <a:ext cx="9509760" cy="531876"/>
+            <a:ext cx="9509760" cy="284226"/>
           </a:xfrm>
           <a:prstGeom prst="rect">
             <a:avLst/>
@@ -15885,7 +15885,7 @@
                 </a:solidFill>
                 <a:latin typeface="Calibri"/>
               </a:rPr>
-              <a:t>The step with no new number in it is the one a clock removes first, and it is the one Finance reads.</a:t>
+              <a:t>The step with no new number in it goes first when the clock runs, and Finance reads it first.</a:t>
             </a:r>
           </a:p>
         </p:txBody>
@@ -17730,7 +17730,7 @@
                 </a:solidFill>
                 <a:latin typeface="Georgia"/>
               </a:rPr>
-              <a:t>Three honest answers, and zero is none of them</a:t>
+              <a:t>Three honest answers to a value that fails</a:t>
             </a:r>
           </a:p>
         </p:txBody>
@@ -19491,7 +19491,7 @@
                 </a:solidFill>
                 <a:latin typeface="Calibri"/>
               </a:rPr>
-              <a:t>A count check proves the rows are there. Only a rupee check proves the values survived. Zero is a claim that the order was worth nothing, so never let a try make it for you.</a:t>
+              <a:t>A count check proves the rows are there. Only a rupee check proves the values survived. Setting a value to zero claims the order was worth nothing, so that decision belongs in the log with a reason.</a:t>
             </a:r>
           </a:p>
         </p:txBody>
@@ -24812,7 +24812,7 @@
                 </a:solidFill>
                 <a:latin typeface="Georgia"/>
               </a:rPr>
-              <a:t>Anand acts only on a number that ties to his</a:t>
+              <a:t>Anand reads the note before Meera does</a:t>
             </a:r>
           </a:p>
         </p:txBody>

</xml_diff>

<commit_message>
W01 D5: depth loop round five passed; its three recommendations applied
Co-Authored-By: Claude Opus 5.5 <noreply@anthropic.com>
Claude-Session: https://claude.ai/code/session_01GMyE3nGptgYS2FxtWfW4y9
</commit_message>
<xml_diff>
--- a/content/W01/D5/slides/C2_W01_D05_debrief_STUDENT.pptx
+++ b/content/W01/D5/slides/C2_W01_D05_debrief_STUDENT.pptx
@@ -2016,7 +2016,7 @@
           </a:p>
           <a:p>
             <a:r>
-              <a:t>The number is correct; the question is what ten orders can carry.</a:t>
+              <a:t>The number is correct. What can ten orders carry?</a:t>
             </a:r>
           </a:p>
         </p:txBody>
@@ -20039,7 +20039,7 @@
                 </a:solidFill>
                 <a:latin typeface="Calibri"/>
               </a:rPr>
-              <a:t>A rate on a handful of orders cannot lead a note until its count is said.</a:t>
+              <a:t>What can ten orders carry in the note's first line?</a:t>
             </a:r>
           </a:p>
         </p:txBody>
@@ -20515,7 +20515,7 @@
                 </a:solidFill>
                 <a:latin typeface="Calibri"/>
               </a:rPr>
-              <a:t>The data now ties to the books; the question is which finding Meera reads first.</a:t>
+              <a:t>The data ties to the books. Which finding does Meera read first?</a:t>
             </a:r>
           </a:p>
         </p:txBody>
@@ -36014,7 +36014,7 @@
         <p:spPr>
           <a:xfrm>
             <a:off x="530352" y="3218688"/>
-            <a:ext cx="11130991" cy="772160"/>
+            <a:ext cx="11130991" cy="495807"/>
           </a:xfrm>
           <a:prstGeom prst="rect">
             <a:avLst/>
@@ -36039,7 +36039,7 @@
                 </a:solidFill>
                 <a:latin typeface="Calibri"/>
               </a:rPr>
-              <a:t>Q1 lands on orders and misses on rupees; Q2 misses on both. Two different errors, and the headline carries them both.</a:t>
+              <a:t>Two different errors, and the headline carries them both.</a:t>
             </a:r>
           </a:p>
         </p:txBody>

</xml_diff>

<commit_message>
W01 D5: debrief deck shows every trap's mechanism on the invented export, labelled invented, and names no planted value; the lead tested on each customer's own two quarters, D29 states keep each customer's own two quarters together, option D run, terms explained, and each half sums to 20 minutes
Co-Authored-By: Claude Opus 5.5 <noreply@anthropic.com>
Claude-Session: https://claude.ai/code/session_01P7zaoR4dQ5pzBFnsX549JQ
</commit_message>
<xml_diff>
--- a/content/W01/D5/slides/C2_W01_D05_debrief_STUDENT.pptx
+++ b/content/W01/D5/slides/C2_W01_D05_debrief_STUDENT.pptx
@@ -546,22 +546,32 @@
           </a:p>
           <a:p>
             <a:r>
-              <a:t>rooms break: chapter 1 before lunch (20 minutes), chapters 2 and 3 after it (10 minutes each). Each</a:t>
-            </a:r>
-          </a:p>
-          <a:p>
-            <a:r>
-              <a:t>chapter pairs with a notebook of the same number and title in notebooks/, which runs on this</a:t>
-            </a:r>
-          </a:p>
-          <a:p>
-            <a:r>
-              <a:t>morning's export and opens now that the clock has stopped. The numbers on these slides are the lab</a:t>
-            </a:r>
-          </a:p>
-          <a:p>
-            <a:r>
-              <a:t>export's own; no slide names a row.</a:t>
+              <a:t>rooms break: chapter 1 before lunch (20 minutes, this minute included), chapters 2 and 3 after it</a:t>
+            </a:r>
+          </a:p>
+          <a:p>
+            <a:r>
+              <a:t>(10 minutes each, the last slide included). Each chapter pairs with a notebook of the same number in</a:t>
+            </a:r>
+          </a:p>
+          <a:p>
+            <a:r>
+              <a:t>notebooks/, which runs on this morning's export and opens now that the clock has stopped. The slides</a:t>
+            </a:r>
+          </a:p>
+          <a:p>
+            <a:r>
+              <a:t>that show a trap's mechanism carry an invented export's numbers, labelled invented on the slide;</a:t>
+            </a:r>
+          </a:p>
+          <a:p>
+            <a:r>
+              <a:t>this morning's own numbers are in the day sheet's debrief table, to say aloud, and in the notebooks'</a:t>
+            </a:r>
+          </a:p>
+          <a:p>
+            <a:r>
+              <a:t>your-turn cells, to type live on the projector.</a:t>
             </a:r>
           </a:p>
         </p:txBody>
@@ -631,12 +641,17 @@
           <a:lstStyle/>
           <a:p>
             <a:r>
-              <a:t>LIVE, 2 minutes. The error changed the sign, so it changed the decision itself. Ask one</a:t>
-            </a:r>
-          </a:p>
-          <a:p>
-            <a:r>
-              <a:t>learner what Meera would have done on Monday with each of the three notes.</a:t>
+              <a:t>LIVE, 2 minutes. The error changed the sign, so it changed the decision itself. Say this morning's</a:t>
+            </a:r>
+          </a:p>
+          <a:p>
+            <a:r>
+              <a:t>three headlines aloud from the day sheet's debrief table, then ask one learner what Meera would have</a:t>
+            </a:r>
+          </a:p>
+          <a:p>
+            <a:r>
+              <a:t>done on Monday with each of the three notes.</a:t>
             </a:r>
           </a:p>
         </p:txBody>
@@ -706,12 +721,22 @@
           <a:lstStyle/>
           <a:p>
             <a:r>
-              <a:t>LIVE, 2 minutes. Run the second-route cell in notebook 1. Both routes give -28.5 percent, which is</a:t>
-            </a:r>
-          </a:p>
-          <a:p>
-            <a:r>
-              <a:t>the check that the log itself is right.</a:t>
+              <a:t>LIVE, 2 minutes. Run the second-route cell in notebook 1; both checks pass on this morning's file.</a:t>
+            </a:r>
+          </a:p>
+          <a:p>
+            <a:r>
+              <a:t>Say what the route proves and what it leaves open: the bridge's moves were found by subtracting</a:t>
+            </a:r>
+          </a:p>
+          <a:p>
+            <a:r>
+              <a:t>totals, and these sums count the decisions themselves, so a row set aside without its log line, or a</a:t>
+            </a:r>
+          </a:p>
+          <a:p>
+            <a:r>
+              <a:t>value zeroed where it should have been read, makes the two disagree.</a:t>
             </a:r>
           </a:p>
         </p:txBody>
@@ -781,12 +806,17 @@
           <a:lstStyle/>
           <a:p>
             <a:r>
-              <a:t>SELF-STUDY, in the depth section of notebook 1. Run it live for two minutes only if the tally shows</a:t>
-            </a:r>
-          </a:p>
-          <a:p>
-            <a:r>
-              <a:t>more than a quarter of notes named a frequency branch.</a:t>
+              <a:t>SELF-STUDY, in the depth section of notebook 1, whose your-turn cell runs the same comparison on</a:t>
+            </a:r>
+          </a:p>
+          <a:p>
+            <a:r>
+              <a:t>this morning's file. Run it live for two minutes only if the tally shows more than a quarter of notes</a:t>
+            </a:r>
+          </a:p>
+          <a:p>
+            <a:r>
+              <a:t>named a frequency branch.</a:t>
             </a:r>
           </a:p>
         </p:txBody>
@@ -931,12 +961,12 @@
           <a:lstStyle/>
           <a:p>
             <a:r>
-              <a:t>LIVE, after lunch. Ten minutes. Notebook 2, C2_W01_D05_02_pass_that_looks_clean_STUDENT.ipynb, on</a:t>
-            </a:r>
-          </a:p>
-          <a:p>
-            <a:r>
-              <a:t>the projector from S14.</a:t>
+              <a:t>LIVE, after lunch. Ten minutes. Notebook 2, C2_W01_D05_02_debrief_values_STUDENT.ipynb, on the</a:t>
+            </a:r>
+          </a:p>
+          <a:p>
+            <a:r>
+              <a:t>projector from S14.</a:t>
             </a:r>
           </a:p>
         </p:txBody>
@@ -1006,27 +1036,27 @@
           <a:lstStyle/>
           <a:p>
             <a:r>
-              <a:t>LIVE, 1 minute. A base that is short by one large order halves the fall the note reports. Nobody</a:t>
-            </a:r>
-          </a:p>
-          <a:p>
-            <a:r>
-              <a:t>argues with the direction, so nobody acts at the right scale, and when Finance finds the order,</a:t>
-            </a:r>
-          </a:p>
-          <a:p>
-            <a:r>
-              <a:t>every other number in the note is doubted with it. One sentence of likeness, even when D13 is</a:t>
-            </a:r>
-          </a:p>
-          <a:p>
-            <a:r>
-              <a:t>self-study: JPMorgan's own task force found a risk spreadsheet that divided by a sum instead of an</a:t>
-            </a:r>
-          </a:p>
-          <a:p>
-            <a:r>
-              <a:t>average and never raised an error.</a:t>
+              <a:t>LIVE, 1 minute. A base that is short by one large order can halve the fall the note reports. Nobody</a:t>
+            </a:r>
+          </a:p>
+          <a:p>
+            <a:r>
+              <a:t>argues with the direction, so nobody acts at the right scale, and when Finance finds the order, every</a:t>
+            </a:r>
+          </a:p>
+          <a:p>
+            <a:r>
+              <a:t>other number in the note is doubted with it. One sentence of likeness, even when D13 is self-study:</a:t>
+            </a:r>
+          </a:p>
+          <a:p>
+            <a:r>
+              <a:t>JPMorgan's own task force found a risk spreadsheet that divided by a sum instead of an average and</a:t>
+            </a:r>
+          </a:p>
+          <a:p>
+            <a:r>
+              <a:t>never raised an error.</a:t>
             </a:r>
           </a:p>
         </p:txBody>
@@ -1171,12 +1201,17 @@
           <a:lstStyle/>
           <a:p>
             <a:r>
-              <a:t>LIVE, 2 minutes. Read the code as a hurried analyst's honest attempt: it runs, it reports nothing</a:t>
-            </a:r>
-          </a:p>
-          <a:p>
-            <a:r>
-              <a:t>and every count lands. Nobody in the room should feel caught.</a:t>
+              <a:t>LIVE, 2 minutes. Read the code as a hurried analyst's honest attempt: it runs, it reports nothing and</a:t>
+            </a:r>
+          </a:p>
+          <a:p>
+            <a:r>
+              <a:t>every count lands. Nobody in the room should feel caught. Notebook 2's first level prints this</a:t>
+            </a:r>
+          </a:p>
+          <a:p>
+            <a:r>
+              <a:t>morning's count and rejects beside it.</a:t>
             </a:r>
           </a:p>
         </p:txBody>
@@ -1321,12 +1356,22 @@
           <a:lstStyle/>
           <a:p>
             <a:r>
-              <a:t>LIVE, 2 minutes. The answer is b. Run level 2 of notebook 2. The your-turn cell finds the row;</a:t>
-            </a:r>
-          </a:p>
-          <a:p>
-            <a:r>
-              <a:t>leave it for the room.</a:t>
+              <a:t>LIVE, 2 minutes. The answer is b. Run level 2 of notebook 2: its checks say this morning's rupees</a:t>
+            </a:r>
+          </a:p>
+          <a:p>
+            <a:r>
+              <a:t>miss in one quarter while every count lands, and its your-turn cell, typed live, prints which quarter</a:t>
+            </a:r>
+          </a:p>
+          <a:p>
+            <a:r>
+              <a:t>and by how much; the day sheet's debrief table has the figure. The your-turn cell that finds the row</a:t>
+            </a:r>
+          </a:p>
+          <a:p>
+            <a:r>
+              <a:t>is for the room tonight.</a:t>
             </a:r>
           </a:p>
         </p:txBody>
@@ -1396,17 +1441,17 @@
           <a:lstStyle/>
           <a:p>
             <a:r>
-              <a:t>LIVE. Twenty minutes, before lunch. Notebook 1, C2_W01_D05_01_reconciliation_skipped_STUDENT.ipynb,</a:t>
-            </a:r>
-          </a:p>
-          <a:p>
-            <a:r>
-              <a:t>goes on the projector at S5 and stays there to S9. Close with two learners reading their</a:t>
-            </a:r>
-          </a:p>
-          <a:p>
-            <a:r>
-              <a:t>second-look line from the lab notebook.</a:t>
+              <a:t>LIVE. Twenty minutes, before lunch. Notebook 1, C2_W01_D05_01_debrief_quarters_STUDENT.ipynb, goes on</a:t>
+            </a:r>
+          </a:p>
+          <a:p>
+            <a:r>
+              <a:t>the projector at S5 and stays there to S9. Close with two learners reading their second-look line</a:t>
+            </a:r>
+          </a:p>
+          <a:p>
+            <a:r>
+              <a:t>from the lab notebook.</a:t>
             </a:r>
           </a:p>
         </p:txBody>
@@ -1476,12 +1521,17 @@
           <a:lstStyle/>
           <a:p>
             <a:r>
-              <a:t>LIVE, 3 minutes. Run the options cell. Land the contrast between A and B: the same wrong headline,</a:t>
-            </a:r>
-          </a:p>
-          <a:p>
-            <a:r>
-              <a:t>but B fails the count check, so B's gap is visible and A's is not.</a:t>
+              <a:t>LIVE, 2 minutes. Run the options cell in notebook 2, which sizes the same four on this morning's</a:t>
+            </a:r>
+          </a:p>
+          <a:p>
+            <a:r>
+              <a:t>file. Land the contrast between A and B: the same wrong headline, and B fails the count check, so B's</a:t>
+            </a:r>
+          </a:p>
+          <a:p>
+            <a:r>
+              <a:t>gap is visible and A's is not.</a:t>
             </a:r>
           </a:p>
         </p:txBody>
@@ -1621,12 +1671,12 @@
           <a:lstStyle/>
           <a:p>
             <a:r>
-              <a:t>SELF-STUDY, level 4 of notebook 2. Run it live for two minutes if the tally shows notes that named</a:t>
-            </a:r>
-          </a:p>
-          <a:p>
-            <a:r>
-              <a:t>Retail-Plus as falling.</a:t>
+              <a:t>SELF-STUDY, level 4 of notebook 2, whose your-turn cells run the same check on this morning's file.</a:t>
+            </a:r>
+          </a:p>
+          <a:p>
+            <a:r>
+              <a:t>Run it live for two minutes if the tally shows notes that read a segment's move the wrong way round.</a:t>
             </a:r>
           </a:p>
         </p:txBody>
@@ -1696,12 +1746,17 @@
           <a:lstStyle/>
           <a:p>
             <a:r>
-              <a:t>LIVE, 1 minute. On a file with no control total, this is the check you still have: it needs nothing</a:t>
-            </a:r>
-          </a:p>
-          <a:p>
-            <a:r>
-              <a:t>outside the file and tells you where, where the rupee check tells you how much.</a:t>
+              <a:t>LIVE, 1 minute. Run the second-route cell of notebook 2; both checks pass on this morning's file. On</a:t>
+            </a:r>
+          </a:p>
+          <a:p>
+            <a:r>
+              <a:t>a file with no control total, this is the check you still have: it needs nothing outside the file and</a:t>
+            </a:r>
+          </a:p>
+          <a:p>
+            <a:r>
+              <a:t>tells you where, where the rupee check tells you how much.</a:t>
             </a:r>
           </a:p>
         </p:txBody>
@@ -1771,12 +1826,12 @@
           <a:lstStyle/>
           <a:p>
             <a:r>
-              <a:t>LIVE, after lunch. Ten minutes. Notebook 3, C2_W01_D05_03_headline_on_few_orders_STUDENT.ipynb, on</a:t>
-            </a:r>
-          </a:p>
-          <a:p>
-            <a:r>
-              <a:t>the projector from S23.</a:t>
+              <a:t>LIVE, after lunch. Ten minutes, the last slide included. Notebook 3,</a:t>
+            </a:r>
+          </a:p>
+          <a:p>
+            <a:r>
+              <a:t>C2_W01_D05_03_debrief_segments_STUDENT.ipynb, on the projector from S25.</a:t>
             </a:r>
           </a:p>
         </p:txBody>
@@ -2016,7 +2071,12 @@
           </a:p>
           <a:p>
             <a:r>
-              <a:t>The number is correct. What can ten orders carry?</a:t>
+              <a:t>The number is correct. What can seven orders carry? This morning's own corporate headline and its</a:t>
+            </a:r>
+          </a:p>
+          <a:p>
+            <a:r>
+              <a:t>count are in the day sheet's debrief table; say them after the room answers S24.</a:t>
             </a:r>
           </a:p>
         </p:txBody>
@@ -2086,12 +2146,12 @@
           <a:lstStyle/>
           <a:p>
             <a:r>
-              <a:t>LIVE, 1 minute. Take letters. Option c is the overcorrection: Rs 17,10,000 is real money and Meera</a:t>
-            </a:r>
-          </a:p>
-          <a:p>
-            <a:r>
-              <a:t>should hear it, as counts.</a:t>
+              <a:t>LIVE, 1 minute. Take letters. Option c is the overcorrection: the corporate rupees are real money</a:t>
+            </a:r>
+          </a:p>
+          <a:p>
+            <a:r>
+              <a:t>and Meera should hear them, as counts.</a:t>
             </a:r>
           </a:p>
         </p:txBody>
@@ -2161,12 +2221,22 @@
           <a:lstStyle/>
           <a:p>
             <a:r>
-              <a:t>LIVE, 2 minutes. The answer is d. Run the coin-flip cell in notebook 3: 0.754. The corporate action</a:t>
-            </a:r>
-          </a:p>
-          <a:p>
-            <a:r>
-              <a:t>is a phone call, which costs nothing; a retention plan built on ten orders costs a quarter.</a:t>
+              <a:t>LIVE, 1 minute. The answer is d. The coin flips in the subtitle are the invented export's; type the</a:t>
+            </a:r>
+          </a:p>
+          <a:p>
+            <a:r>
+              <a:t>your-turn cell in notebook 3 live for this morning's corporate count and its share. The corporate</a:t>
+            </a:r>
+          </a:p>
+          <a:p>
+            <a:r>
+              <a:t>action is a phone call, which costs nothing; a retention plan built on a handful of orders costs a</a:t>
+            </a:r>
+          </a:p>
+          <a:p>
+            <a:r>
+              <a:t>quarter.</a:t>
             </a:r>
           </a:p>
         </p:txBody>
@@ -2246,22 +2316,22 @@
           </a:p>
           <a:p>
             <a:r>
-              <a:t>Monday's review home with nothing to investigate, while Marketing's Rs 12 crore request is judged</a:t>
-            </a:r>
-          </a:p>
-          <a:p>
-            <a:r>
-              <a:t>against a quarter that did not happen. Then one sentence of likeness, even when D2 is left to</a:t>
-            </a:r>
-          </a:p>
-          <a:p>
-            <a:r>
-              <a:t>self-study: Nykaa reports GMV of Rs 4,182 crore and revenue of Rs 2,155 crore for the same quarter,</a:t>
-            </a:r>
-          </a:p>
-          <a:p>
-            <a:r>
-              <a:t>so every figure there names its base and bridges to the books.</a:t>
+              <a:t>Monday's review after the wrong question, while Marketing's Rs 12 crore request is judged against a</a:t>
+            </a:r>
+          </a:p>
+          <a:p>
+            <a:r>
+              <a:t>quarter that did not happen. Then one sentence of likeness, even when D2 is left to self-study:</a:t>
+            </a:r>
+          </a:p>
+          <a:p>
+            <a:r>
+              <a:t>Nykaa reports gross merchandise value of Rs 4,182 crore and revenue from operations of Rs 2,155</a:t>
+            </a:r>
+          </a:p>
+          <a:p>
+            <a:r>
+              <a:t>crore for the same quarter, so every figure there names its base and bridges to the books.</a:t>
             </a:r>
           </a:p>
         </p:txBody>
@@ -2331,12 +2401,22 @@
           <a:lstStyle/>
           <a:p>
             <a:r>
-              <a:t>LIVE, 2 minutes. Run the options cell. B hides that 99 percent of the fall is two orders; D runs</a:t>
-            </a:r>
-          </a:p>
-          <a:p>
-            <a:r>
-              <a:t>four tests at 0.05, and the chance at least one looks real by luck is about 19 percent.</a:t>
+              <a:t>LIVE, 2 minutes. Run the options cell in notebook 3; it runs D's four tests, Retail-Core at 0.006 and</a:t>
+            </a:r>
+          </a:p>
+          <a:p>
+            <a:r>
+              <a:t>the other three from 0.27 to 0.79. B hides that nearly all of the fall is the corporate book. D finds</a:t>
+            </a:r>
+          </a:p>
+          <a:p>
+            <a:r>
+              <a:t>the same lead here at three times the minutes, and four tests at 0.05 carry about a one-in-five chance</a:t>
+            </a:r>
+          </a:p>
+          <a:p>
+            <a:r>
+              <a:t>that one looks real by luck, so on another file D leads with a fluke.</a:t>
             </a:r>
           </a:p>
         </p:txBody>
@@ -2406,12 +2486,22 @@
           <a:lstStyle/>
           <a:p>
             <a:r>
-              <a:t>LIVE, 1 minute. Run the strip chart in notebook 3. Read the p-value sentence aloud once, word for</a:t>
-            </a:r>
-          </a:p>
-          <a:p>
-            <a:r>
-              <a:t>word, because Saturday's paper asks for it.</a:t>
+              <a:t>LIVE, 1 minute. Run the flip cell in notebook 3. The fall was found in the tree, so the note reports</a:t>
+            </a:r>
+          </a:p>
+          <a:p>
+            <a:r>
+              <a:t>both directions. Read the p-value sentence aloud once, word for word, because Saturday's paper asks</a:t>
+            </a:r>
+          </a:p>
+          <a:p>
+            <a:r>
+              <a:t>for it. A learner who shuffled segment labels across whole customers reached 0.0195: that answers a</a:t>
+            </a:r>
+          </a:p>
+          <a:p>
+            <a:r>
+              <a:t>different question, whether Retail-Core moved differently from Retail-Plus, and it is fair for it.</a:t>
             </a:r>
           </a:p>
         </p:txBody>
@@ -2481,22 +2571,22 @@
           <a:lstStyle/>
           <a:p>
             <a:r>
-              <a:t>The rule to say: the shuffle says whether the gap is bigger than chance, the customer count says</a:t>
-            </a:r>
-          </a:p>
-          <a:p>
-            <a:r>
-              <a:t>whether it is broad; when they disagree, a handful of customers moved the average.</a:t>
-            </a:r>
-          </a:p>
-          <a:p>
-            <a:r>
-              <a:t>LIVE, 1 minute. Run the second-route cell. Then close the chapter with the note as it should read,</a:t>
-            </a:r>
-          </a:p>
-          <a:p>
-            <a:r>
-              <a:t>from notebook 3.</a:t>
+              <a:t>The rule to say: the flips say whether the change is bigger than chance, the customer count says</a:t>
+            </a:r>
+          </a:p>
+          <a:p>
+            <a:r>
+              <a:t>whether it is broad; when they disagree, a handful of customers moved the average. The sign test uses</a:t>
+            </a:r>
+          </a:p>
+          <a:p>
+            <a:r>
+              <a:t>only each customer's direction, so its p sits above the flips'. LIVE, 1 minute. Run the second-route</a:t>
+            </a:r>
+          </a:p>
+          <a:p>
+            <a:r>
+              <a:t>cell. Then close the chapter with the note as it should read, from notebook 3.</a:t>
             </a:r>
           </a:p>
         </p:txBody>
@@ -2566,12 +2656,22 @@
           <a:lstStyle/>
           <a:p>
             <a:r>
-              <a:t>SELF-STUDY, in the depth section of notebook 3, unless more than a quarter of the room shuffled</a:t>
-            </a:r>
-          </a:p>
-          <a:p>
-            <a:r>
-              <a:t>orders; then run it for three minutes in place of S28.</a:t>
+              <a:t>SELF-STUDY, in the depth section of notebook 3, unless more than a quarter of the room pooled the</a:t>
+            </a:r>
+          </a:p>
+          <a:p>
+            <a:r>
+              <a:t>quarters or shuffled single orders; then run it for three minutes in place of S28. Both cards are</a:t>
+            </a:r>
+          </a:p>
+          <a:p>
+            <a:r>
+              <a:t>2,000 runs on random.Random(7). The same cell shows single orders shuffled between segments at</a:t>
+            </a:r>
+          </a:p>
+          <a:p>
+            <a:r>
+              <a:t>0.0755, against 0.0195 with the label moving with the whole customer.</a:t>
             </a:r>
           </a:p>
         </p:txBody>
@@ -2861,12 +2961,22 @@
           <a:lstStyle/>
           <a:p>
             <a:r>
-              <a:t>LIVE, 2 minutes. Read the three numbers and the sentence. Ask how many sent a headline with a plus</a:t>
-            </a:r>
-          </a:p>
-          <a:p>
-            <a:r>
-              <a:t>sign this morning, without naming anyone; the TA tally already knows, and the room should say it.</a:t>
+              <a:t>LIVE, 2 minutes. The numbers are the invented export's, so the mechanism shows without naming what</a:t>
+            </a:r>
+          </a:p>
+          <a:p>
+            <a:r>
+              <a:t>this morning's file holds. Read the three numbers and the sentence, then say the room's own hurried</a:t>
+            </a:r>
+          </a:p>
+          <a:p>
+            <a:r>
+              <a:t>headline aloud from the day sheet's debrief table and ask how many sent a headline with a plus sign,</a:t>
+            </a:r>
+          </a:p>
+          <a:p>
+            <a:r>
+              <a:t>without naming anyone; the TA tally already knows, and the room should say it.</a:t>
             </a:r>
           </a:p>
         </p:txBody>
@@ -2936,7 +3046,7 @@
           <a:lstStyle/>
           <a:p>
             <a:r>
-              <a:t>LIVE, 2 minutes. Take letters. Option a is Monday's instinct and a good one on a different day; d</a:t>
+              <a:t>LIVE, 1 minute. Take letters. Option a is Monday's instinct and a good one on a different day; d</a:t>
             </a:r>
           </a:p>
           <a:p>
@@ -3011,12 +3121,22 @@
           <a:lstStyle/>
           <a:p>
             <a:r>
-              <a:t>LIVE, 2 minutes. The answer is c. Open notebook 1 on the projector and run its first level. Point</a:t>
-            </a:r>
-          </a:p>
-          <a:p>
-            <a:r>
-              <a:t>at the two kinds of miss: the Q1 row has the right count and the wrong rupees, which is chapter 2.</a:t>
+              <a:t>LIVE, 2 minutes. The answer is c. Open notebook 1 on the projector: its first level prints this</a:t>
+            </a:r>
+          </a:p>
+          <a:p>
+            <a:r>
+              <a:t>morning's hurried headline beside the books, and its your-turn cell, typed live, prints this</a:t>
+            </a:r>
+          </a:p>
+          <a:p>
+            <a:r>
+              <a:t>morning's version of this table. Point at the two kinds of miss: a quarter with the right count and</a:t>
+            </a:r>
+          </a:p>
+          <a:p>
+            <a:r>
+              <a:t>the wrong rupees is chapter 2.</a:t>
             </a:r>
           </a:p>
         </p:txBody>
@@ -3086,17 +3206,27 @@
           <a:lstStyle/>
           <a:p>
             <a:r>
-              <a:t>LIVE, 3 minutes. Run the sizing cell in notebook 1. Land two points: B is where most people who did</a:t>
-            </a:r>
-          </a:p>
-          <a:p>
-            <a:r>
-              <a:t>check stopped, and it still leaves the headline 14 points off; D is right and costs the afternoon.</a:t>
-            </a:r>
-          </a:p>
-          <a:p>
-            <a:r>
-              <a:t>Minutes are the lab brief's pace, D's is an estimate for a request to Finance and a join.</a:t>
+              <a:t>LIVE, 3 minutes. Then run the sizing cell in notebook 1, which sizes the same options on this</a:t>
+            </a:r>
+          </a:p>
+          <a:p>
+            <a:r>
+              <a:t>morning's file, with D marked not run because the lab had no ledger. Land two points: B is where</a:t>
+            </a:r>
+          </a:p>
+          <a:p>
+            <a:r>
+              <a:t>most people who did check stopped, and it still leaves the headline well off the books; D is right</a:t>
+            </a:r>
+          </a:p>
+          <a:p>
+            <a:r>
+              <a:t>and costs the afternoon. Minutes are the lab brief's pace, D's an estimate for a request to Finance</a:t>
+            </a:r>
+          </a:p>
+          <a:p>
+            <a:r>
+              <a:t>and a join.</a:t>
             </a:r>
           </a:p>
         </p:txBody>
@@ -3166,12 +3296,22 @@
           <a:lstStyle/>
           <a:p>
             <a:r>
-              <a:t>LIVE, 3 minutes. Run level 3 of notebook 1 and show the bridge chart. Ask which move is larger</a:t>
-            </a:r>
-          </a:p>
-          <a:p>
-            <a:r>
-              <a:t>before revealing it. The your-turn cell after it lists the rows; leave that to the room tonight.</a:t>
+              <a:t>LIVE, 3 minutes. Ask which move is larger before revealing it. Then run level 3 of notebook 1: its</a:t>
+            </a:r>
+          </a:p>
+          <a:p>
+            <a:r>
+              <a:t>checks say this morning's bridge lands, and its your-turn cell, typed live, draws it; say this</a:t>
+            </a:r>
+          </a:p>
+          <a:p>
+            <a:r>
+              <a:t>morning's two moves aloud from the day sheet. The your-turn cell after it lists the rows; leave that</a:t>
+            </a:r>
+          </a:p>
+          <a:p>
+            <a:r>
+              <a:t>to the room tonight.</a:t>
             </a:r>
           </a:p>
         </p:txBody>
@@ -7015,7 +7155,7 @@
                 </a:solidFill>
                 <a:latin typeface="Calibri"/>
               </a:rPr>
-              <a:t>Growth reads as no action; a fall reads as find the branch, and only one of them is true.</a:t>
+              <a:t>Invented export: growth reads as no action, a fall reads as find the branch, and only one is true.</a:t>
             </a:r>
           </a:p>
         </p:txBody>
@@ -7213,7 +7353,7 @@
                 </a:solidFill>
                 <a:latin typeface="Calibri"/>
               </a:rPr>
-              <a:t>Q2 grew 11.8%</a:t>
+              <a:t>Q2 grew 21.2%</a:t>
             </a:r>
           </a:p>
         </p:txBody>
@@ -7440,7 +7580,7 @@
                 </a:solidFill>
                 <a:latin typeface="Calibri"/>
               </a:rPr>
-              <a:t>Q2 fell 14.6%</a:t>
+              <a:t>Q2 fell 17.5%</a:t>
             </a:r>
           </a:p>
         </p:txBody>
@@ -7667,7 +7807,7 @@
                 </a:solidFill>
                 <a:latin typeface="Calibri"/>
               </a:rPr>
-              <a:t>Q2 fell 28.5%</a:t>
+              <a:t>Q2 fell 35.0%</a:t>
             </a:r>
           </a:p>
         </p:txBody>
@@ -7702,7 +7842,7 @@
                 </a:solidFill>
                 <a:latin typeface="Calibri"/>
               </a:rPr>
-              <a:t>Rs 17,22,520 to explain, and the tree says where.</a:t>
+              <a:t>Rs 14,00,000 to explain, and the tree says where.</a:t>
             </a:r>
           </a:p>
         </p:txBody>
@@ -8371,7 +8511,7 @@
                 </a:solidFill>
                 <a:latin typeface="Georgia"/>
               </a:rPr>
-              <a:t>A second route: walk back from Finance's side</a:t>
+              <a:t>A second route: sum the decisions themselves</a:t>
             </a:r>
           </a:p>
         </p:txBody>
@@ -8406,14 +8546,14 @@
                 </a:solidFill>
                 <a:latin typeface="Calibri"/>
               </a:rPr>
-              <a:t>Start at the control total, undo each logged decision, and land on what the hurried run summed.</a:t>
+              <a:t>Invented export: the set-aside list and the log, each summed on its own, against the bridge's moves.</a:t>
             </a:r>
           </a:p>
         </p:txBody>
       </p:sp>
       <p:pic>
         <p:nvPicPr>
-          <p:cNvPr id="9" name="mermaid diagram" descr="44cac503fe234bb0.png"/>
+          <p:cNvPr id="9" name="mermaid diagram" descr="c405589d215684cd.png"/>
           <p:cNvPicPr>
             <a:picLocks noChangeAspect="1"/>
           </p:cNvPicPr>
@@ -8427,8 +8567,8 @@
         </p:blipFill>
         <p:spPr>
           <a:xfrm>
-            <a:off x="530352" y="1956816"/>
-            <a:ext cx="11130991" cy="863855"/>
+            <a:off x="3224060" y="1956816"/>
+            <a:ext cx="5743575" cy="2300287"/>
           </a:xfrm>
           <a:prstGeom prst="rect">
             <a:avLst/>
@@ -8443,8 +8583,8 @@
         </p:nvSpPr>
         <p:spPr>
           <a:xfrm>
-            <a:off x="530352" y="2966975"/>
-            <a:ext cx="11130991" cy="1121664"/>
+            <a:off x="530352" y="4403407"/>
+            <a:ext cx="11130991" cy="1380744"/>
           </a:xfrm>
           <a:prstGeom prst="roundRect">
             <a:avLst>
@@ -8497,7 +8637,7 @@
         </p:nvSpPr>
         <p:spPr>
           <a:xfrm>
-            <a:off x="758952" y="3299207"/>
+            <a:off x="758952" y="4865179"/>
             <a:ext cx="457200" cy="457200"/>
           </a:xfrm>
           <a:prstGeom prst="ellipse">
@@ -8549,7 +8689,7 @@
         </p:blipFill>
         <p:spPr>
           <a:xfrm>
-            <a:off x="868680" y="3408935"/>
+            <a:off x="868680" y="4974907"/>
             <a:ext cx="237744" cy="237744"/>
           </a:xfrm>
           <a:prstGeom prst="rect">
@@ -8565,7 +8705,7 @@
         </p:nvSpPr>
         <p:spPr>
           <a:xfrm>
-            <a:off x="1399031" y="3113279"/>
+            <a:off x="1399031" y="4549711"/>
             <a:ext cx="9987991" cy="160401"/>
           </a:xfrm>
           <a:prstGeom prst="rect">
@@ -8600,8 +8740,8 @@
         </p:nvSpPr>
         <p:spPr>
           <a:xfrm>
-            <a:off x="1399031" y="3332735"/>
-            <a:ext cx="9987991" cy="682752"/>
+            <a:off x="1399031" y="4769167"/>
+            <a:ext cx="9987991" cy="941832"/>
           </a:xfrm>
           <a:prstGeom prst="rect">
             <a:avLst/>
@@ -8621,7 +8761,7 @@
                 </a:solidFill>
                 <a:latin typeface="Calibri"/>
               </a:rPr>
-              <a:t>Show Finance the forward bridge, because it starts from their export. Run the walk back when a bridge closes suspiciously neatly: two mistakes that cancel pass one route and fail the other.</a:t>
+              <a:t>Show Finance the forward bridge, because it starts from their export. Run the two sums before you send it: they prove every rupee the bridge moved is a row set aside or a value in the log, and whether each decision was right is the order-level match's question.</a:t>
             </a:r>
           </a:p>
         </p:txBody>
@@ -9099,7 +9239,7 @@
                 </a:solidFill>
                 <a:latin typeface="Georgia"/>
               </a:rPr>
-              <a:t>The same rows also move a branch</a:t>
+              <a:t>The same rows can also move a branch</a:t>
             </a:r>
           </a:p>
         </p:txBody>
@@ -9189,14 +9329,14 @@
                 </a:solidFill>
                 <a:latin typeface="Calibri"/>
               </a:rPr>
-              <a:t>On the rows as they arrived, Retail-Core's customers seem to order a fifth more often.</a:t>
+              <a:t>Invented export: repeated rows for the same customers read as customers ordering more often.</a:t>
             </a:r>
           </a:p>
         </p:txBody>
       </p:sp>
       <p:pic>
         <p:nvPicPr>
-          <p:cNvPr id="10" name="mermaid diagram" descr="b9379099fa616a9e.png"/>
+          <p:cNvPr id="10" name="mermaid diagram" descr="abf48e521da9dae3.png"/>
           <p:cNvPicPr>
             <a:picLocks noChangeAspect="1"/>
           </p:cNvPicPr>
@@ -9211,7 +9351,7 @@
         <p:spPr>
           <a:xfrm>
             <a:off x="3095472" y="1956816"/>
-            <a:ext cx="6000750" cy="2014537"/>
+            <a:ext cx="6000750" cy="2271712"/>
           </a:xfrm>
           <a:prstGeom prst="rect">
             <a:avLst/>
@@ -9226,7 +9366,7 @@
         </p:nvSpPr>
         <p:spPr>
           <a:xfrm>
-            <a:off x="530352" y="4117657"/>
+            <a:off x="530352" y="4374832"/>
             <a:ext cx="11130991" cy="772160"/>
           </a:xfrm>
           <a:prstGeom prst="rect">
@@ -9252,7 +9392,7 @@
                 </a:solidFill>
                 <a:latin typeface="Calibri"/>
               </a:rPr>
-              <a:t>Rows Finance does not hold manufacture a frequency rise where nothing changed, and hide a basket fall behind a flat segment. Chapter 3 reads the clean tree.</a:t>
+              <a:t>Rows Finance does not hold manufacture a frequency rise where nothing changed, and hide a basket fall behind a segment that looks steady. Chapter 3 reads the clean tree.</a:t>
             </a:r>
           </a:p>
         </p:txBody>
@@ -10916,7 +11056,7 @@
                 </a:solidFill>
                 <a:latin typeface="Calibri"/>
               </a:rPr>
-              <a:t>Week 1 Day 5: the week rebuilt alone</a:t>
+              <a:t>Week 1, Day 5. Where the room broke</a:t>
             </a:r>
           </a:p>
         </p:txBody>
@@ -11560,7 +11700,7 @@
                 </a:solidFill>
                 <a:latin typeface="Calibri"/>
               </a:rPr>
-              <a:t>WHAT A WRONG BASE COSTS</a:t>
+              <a:t>WHAT A WRONG BASE CAN COST</a:t>
             </a:r>
           </a:p>
         </p:txBody>
@@ -12418,7 +12558,7 @@
         <p:spPr>
           <a:xfrm>
             <a:off x="530352" y="1956816"/>
-            <a:ext cx="5474055" cy="2344420"/>
+            <a:ext cx="5474055" cy="2534412"/>
           </a:xfrm>
           <a:prstGeom prst="roundRect">
             <a:avLst>
@@ -12616,7 +12756,7 @@
         <p:spPr>
           <a:xfrm>
             <a:off x="731519" y="3303524"/>
-            <a:ext cx="5071719" cy="763016"/>
+            <a:ext cx="5071719" cy="944626"/>
           </a:xfrm>
           <a:prstGeom prst="rect">
             <a:avLst/>
@@ -12637,7 +12777,7 @@
                 </a:solidFill>
                 <a:latin typeface="Calibri"/>
               </a:rPr>
-              <a:t>A risk model run through spreadsheets "divided by their sum instead of their average", likely muting volatility by a factor of two and lowering the VaR. Source: the task force report, January 2013, as quoted by The Baseline Scenario, 9 February 2013.</a:t>
+              <a:t>A risk model run through spreadsheets "divided by their sum instead of their average", likely muting volatility, how far prices were shown to swing, by a factor of two, and lowering the VaR, the bank's estimate of a bad day's loss. Source: the task force report, January 2013, as quoted by The Baseline Scenario, 9 February 2013.</a:t>
             </a:r>
           </a:p>
         </p:txBody>
@@ -12651,7 +12791,7 @@
         <p:spPr>
           <a:xfrm>
             <a:off x="6187287" y="1956816"/>
-            <a:ext cx="5474055" cy="2344420"/>
+            <a:ext cx="5474055" cy="2534412"/>
           </a:xfrm>
           <a:prstGeom prst="roundRect">
             <a:avLst>
@@ -12843,7 +12983,7 @@
         <p:spPr>
           <a:xfrm>
             <a:off x="6388455" y="3303524"/>
-            <a:ext cx="5071719" cy="399796"/>
+            <a:ext cx="5071719" cy="581406"/>
           </a:xfrm>
           <a:prstGeom prst="rect">
             <a:avLst/>
@@ -12864,7 +13004,7 @@
                 </a:solidFill>
                 <a:latin typeface="Calibri"/>
               </a:rPr>
-              <a:t>The trading losses the FCA's fine refers to. Source: FCA press release, 19 September 2013.</a:t>
+              <a:t>The trading losses from what became known as the "London Whale" trades in the bank's Chief Investment Office. Source: FCA press release, 19 September 2013.</a:t>
             </a:r>
           </a:p>
         </p:txBody>
@@ -13377,7 +13517,7 @@
                 </a:solidFill>
                 <a:latin typeface="Calibri"/>
               </a:rPr>
-              <a:t>The most natural line of Python in the week: a try that sets a failure to zero.</a:t>
+              <a:t>Invented export: the most natural line of Python in the week, a try that sets a failure to zero.</a:t>
             </a:r>
           </a:p>
         </p:txBody>
@@ -13699,7 +13839,7 @@
                 </a:solidFill>
                 <a:latin typeface="Georgia"/>
               </a:rPr>
-              <a:t>98</a:t>
+              <a:t>83</a:t>
             </a:r>
           </a:p>
         </p:txBody>
@@ -13769,7 +13909,7 @@
                 </a:solidFill>
                 <a:latin typeface="Calibri"/>
               </a:rPr>
-              <a:t>Finance: 98</a:t>
+              <a:t>Finance: 83, invented</a:t>
             </a:r>
           </a:p>
         </p:txBody>
@@ -13997,7 +14137,7 @@
                 </a:solidFill>
                 <a:latin typeface="Georgia"/>
               </a:rPr>
-              <a:t>Rs 50,63,000</a:t>
+              <a:t>Rs 31,50,000</a:t>
             </a:r>
           </a:p>
         </p:txBody>
@@ -14067,7 +14207,7 @@
                 </a:solidFill>
                 <a:latin typeface="Calibri"/>
               </a:rPr>
-              <a:t>every row kept</a:t>
+              <a:t>every row kept, invented</a:t>
             </a:r>
           </a:p>
         </p:txBody>
@@ -15239,7 +15379,7 @@
                 </a:solidFill>
                 <a:latin typeface="Georgia"/>
               </a:rPr>
-              <a:t>Answer: the rupees, and Q1 is Rs 9,85,000 short</a:t>
+              <a:t>Answer: the rupees, and one quarter is short</a:t>
             </a:r>
           </a:p>
         </p:txBody>
@@ -15274,14 +15414,14 @@
                 </a:solidFill>
                 <a:latin typeface="Calibri"/>
               </a:rPr>
-              <a:t>Counts reconcile while rupees do not: the gap is the value the try swallowed.</a:t>
+              <a:t>Invented export: counts reconcile while rupees do not, and the gap is the value the try swallowed.</a:t>
             </a:r>
           </a:p>
         </p:txBody>
       </p:sp>
       <p:pic>
         <p:nvPicPr>
-          <p:cNvPr id="9" name="mermaid diagram" descr="5950a486d2ba6b34.png"/>
+          <p:cNvPr id="9" name="mermaid diagram" descr="95f72f78b81ef260.png"/>
           <p:cNvPicPr>
             <a:picLocks noChangeAspect="1"/>
           </p:cNvPicPr>
@@ -15337,7 +15477,7 @@
                 </a:solidFill>
                 <a:latin typeface="Calibri"/>
               </a:rPr>
-              <a:t>With the base short by 16.3 percent, the note reports a fall of 14.6 percent where the books show 28.5.</a:t>
+              <a:t>With the base short by 21.3 percent, the note reports a fall of 17.5 percent where the books show 35.0.</a:t>
             </a:r>
           </a:p>
         </p:txBody>
@@ -16085,7 +16225,7 @@
                 </a:solidFill>
                 <a:latin typeface="Calibri"/>
               </a:rPr>
-              <a:t>Week 1 Day 5: the week rebuilt alone</a:t>
+              <a:t>Week 1, Day 5. Where the room broke</a:t>
             </a:r>
           </a:p>
         </p:txBody>
@@ -16361,7 +16501,7 @@
                 </a:solidFill>
                 <a:latin typeface="Calibri"/>
               </a:rPr>
-              <a:t>One value in 207, sized: what each option sends and what the checks then show.</a:t>
+              <a:t>Invented export, one value sized: what each option sends and what the checks then show.</a:t>
             </a:r>
           </a:p>
         </p:txBody>
@@ -16649,7 +16789,7 @@
                           </a:solidFill>
                           <a:latin typeface="Calibri"/>
                         </a:rPr>
-                        <a:t>-14.6%</a:t>
+                        <a:t>-17.5%</a:t>
                       </a:r>
                     </a:p>
                   </a:txBody>
@@ -16783,7 +16923,7 @@
                           </a:solidFill>
                           <a:latin typeface="Calibri"/>
                         </a:rPr>
-                        <a:t>-14.6%</a:t>
+                        <a:t>-17.5%</a:t>
                       </a:r>
                     </a:p>
                   </a:txBody>
@@ -16917,7 +17057,7 @@
                           </a:solidFill>
                           <a:latin typeface="Calibri"/>
                         </a:rPr>
-                        <a:t>-28.5%</a:t>
+                        <a:t>-35.0%</a:t>
                       </a:r>
                     </a:p>
                   </a:txBody>
@@ -17252,7 +17392,7 @@
                 </a:solidFill>
                 <a:latin typeface="Calibri"/>
               </a:rPr>
-              <a:t>C, when the value can be read without guessing, as digits with an Indian ledger's grouping commas can. D when it cannot: a word, a unit that could be lakh or crore. B when the row is not an order. A is the one option that hides its gap.</a:t>
+              <a:t>C, when the value can be read without guessing, as an amount exported with its paise, the invented export's 850000.00, can. D when it cannot: a word, a unit that could be lakh or crore. B when the row is not an order. A is the one option that hides its gap.</a:t>
             </a:r>
           </a:p>
         </p:txBody>
@@ -18548,14 +18688,14 @@
                 </a:solidFill>
                 <a:latin typeface="Calibri"/>
               </a:rPr>
-              <a:t>A filter on the segment name never sees a row whose segment is empty.</a:t>
+              <a:t>Invented export: a filter on the segment name never sees a row whose segment is empty.</a:t>
             </a:r>
           </a:p>
         </p:txBody>
       </p:sp>
       <p:pic>
         <p:nvPicPr>
-          <p:cNvPr id="10" name="mermaid diagram" descr="28fab4467ce65e82.png"/>
+          <p:cNvPr id="10" name="mermaid diagram" descr="e236f9c6a62015d1.png"/>
           <p:cNvPicPr>
             <a:picLocks noChangeAspect="1"/>
           </p:cNvPicPr>
@@ -18569,8 +18709,8 @@
         </p:blipFill>
         <p:spPr>
           <a:xfrm>
-            <a:off x="3345503" y="1956816"/>
-            <a:ext cx="5500687" cy="2043112"/>
+            <a:off x="3131191" y="1956816"/>
+            <a:ext cx="5929312" cy="2043112"/>
           </a:xfrm>
           <a:prstGeom prst="rect">
             <a:avLst/>
@@ -18763,7 +18903,7 @@
                 </a:solidFill>
                 <a:latin typeface="Calibri"/>
               </a:rPr>
-              <a:t>The segments add back to the quarter, in orders and in rupees, before any segment is read. Here they fall one order short, and a tier that grew reads as a second falling segment.</a:t>
+              <a:t>The segments add back to the quarter, in orders and in rupees, before any segment is read. On the invented export they fall one order short in Q1, and a segment that fell reads as a rise.</a:t>
             </a:r>
           </a:p>
         </p:txBody>
@@ -19276,14 +19416,14 @@
                 </a:solidFill>
                 <a:latin typeface="Calibri"/>
               </a:rPr>
-              <a:t>The rupee check finds the gap from outside the file; this finds it from inside.</a:t>
+              <a:t>Invented export: the rupee check finds the gap from outside the file; this finds it from inside.</a:t>
             </a:r>
           </a:p>
         </p:txBody>
       </p:sp>
       <p:pic>
         <p:nvPicPr>
-          <p:cNvPr id="9" name="mermaid diagram" descr="349878b4ade5e666.png"/>
+          <p:cNvPr id="9" name="mermaid diagram" descr="3c683710ff587dd5.png"/>
           <p:cNvPicPr>
             <a:picLocks noChangeAspect="1"/>
           </p:cNvPicPr>
@@ -20039,7 +20179,7 @@
                 </a:solidFill>
                 <a:latin typeface="Calibri"/>
               </a:rPr>
-              <a:t>What can ten orders carry in the note's first line?</a:t>
+              <a:t>What can a handful of orders carry in the note's first line?</a:t>
             </a:r>
           </a:p>
         </p:txBody>
@@ -20239,7 +20379,7 @@
                 </a:solidFill>
                 <a:latin typeface="Calibri"/>
               </a:rPr>
-              <a:t>Week 1 Day 5: the week rebuilt alone</a:t>
+              <a:t>Week 1, Day 5. Where the room broke</a:t>
             </a:r>
           </a:p>
         </p:txBody>
@@ -20699,7 +20839,7 @@
                 </a:solidFill>
                 <a:latin typeface="Georgia"/>
               </a:rPr>
-              <a:t>99.3%</a:t>
+              <a:t>four</a:t>
             </a:r>
           </a:p>
         </p:txBody>
@@ -20734,7 +20874,7 @@
                 </a:solidFill>
                 <a:latin typeface="Calibri"/>
               </a:rPr>
-              <a:t>CARRIED BY ONE SEGMENT</a:t>
+              <a:t>SEGMENTS</a:t>
             </a:r>
           </a:p>
         </p:txBody>
@@ -20769,7 +20909,7 @@
                 </a:solidFill>
                 <a:latin typeface="Calibri"/>
               </a:rPr>
-              <a:t>the corporate book</a:t>
+              <a:t>each with its own count</a:t>
             </a:r>
           </a:p>
         </p:txBody>
@@ -22665,7 +22805,7 @@
                 </a:solidFill>
                 <a:latin typeface="Georgia"/>
               </a:rPr>
-              <a:t>The corporate book fell 29.2 percent</a:t>
+              <a:t>A corporate book falls 36.3 percent</a:t>
             </a:r>
           </a:p>
         </p:txBody>
@@ -22700,7 +22840,7 @@
                 </a:solidFill>
                 <a:latin typeface="Calibri"/>
               </a:rPr>
-              <a:t>True to the rupee, the biggest number on the page, and the headline many notes led with.</a:t>
+              <a:t>Invented export: true to the rupee, the biggest number on the page, and the headline a hurried note leads with.</a:t>
             </a:r>
           </a:p>
         </p:txBody>
@@ -22735,7 +22875,7 @@
                 </a:solidFill>
                 <a:latin typeface="Georgia"/>
               </a:rPr>
-              <a:t>-29.2%</a:t>
+              <a:t>-36.3%</a:t>
             </a:r>
           </a:p>
         </p:txBody>
@@ -22770,7 +22910,7 @@
                 </a:solidFill>
                 <a:latin typeface="Calibri"/>
               </a:rPr>
-              <a:t>BUSINESS REVENUE</a:t>
+              <a:t>CORPORATE REVENUE</a:t>
             </a:r>
           </a:p>
         </p:txBody>
@@ -22805,7 +22945,7 @@
                 </a:solidFill>
                 <a:latin typeface="Calibri"/>
               </a:rPr>
-              <a:t>Q1 to Q2</a:t>
+              <a:t>Q1 to Q2, invented</a:t>
             </a:r>
           </a:p>
         </p:txBody>
@@ -22884,7 +23024,7 @@
                 </a:solidFill>
                 <a:latin typeface="Georgia"/>
               </a:rPr>
-              <a:t>6 then 4</a:t>
+              <a:t>5 then 2</a:t>
             </a:r>
           </a:p>
         </p:txBody>
@@ -22954,7 +23094,7 @@
                 </a:solidFill>
                 <a:latin typeface="Calibri"/>
               </a:rPr>
-              <a:t>what the rate rests on</a:t>
+              <a:t>what the rate rests on, invented</a:t>
             </a:r>
           </a:p>
         </p:txBody>
@@ -23033,7 +23173,7 @@
                 </a:solidFill>
                 <a:latin typeface="Georgia"/>
               </a:rPr>
-              <a:t>Rs 17,10,000</a:t>
+              <a:t>Rs 13,88,200</a:t>
             </a:r>
           </a:p>
         </p:txBody>
@@ -23103,7 +23243,7 @@
                 </a:solidFill>
                 <a:latin typeface="Calibri"/>
               </a:rPr>
-              <a:t>99.3% of the quarter's</a:t>
+              <a:t>99.2% of the quarter's, invented</a:t>
             </a:r>
           </a:p>
         </p:txBody>
@@ -23797,7 +23937,7 @@
                 </a:solidFill>
                 <a:latin typeface="Calibri"/>
               </a:rPr>
-              <a:t>Choose one: a) as the headline trend, since it is the largest move in rupees on the page; b) as the headline, with a shuffle test's p-value printed beside the rate; c) left out of the note, since ten orders are too few to matter to anyone; d) as counts, two fewer corporate orders, with a question to their owner.</a:t>
+              <a:t>Choose one: a) as the headline trend, since it is the largest move in rupees on the page; b) as the headline, with a test's p-value printed beside the rate; c) left out of the note, since a handful of orders is too few to matter to anyone; d) as counts, the orders in each quarter, with a question to their owner.</a:t>
             </a:r>
           </a:p>
         </p:txBody>
@@ -24310,14 +24450,14 @@
                 </a:solidFill>
                 <a:latin typeface="Calibri"/>
               </a:rPr>
-              <a:t>Ten orders split by coin flips come out at least as uneven as six and four in 75 percent of worlds.</a:t>
+              <a:t>Invented counts: seven orders split by coin flips come out at least as uneven as five and two in 45 percent of worlds.</a:t>
             </a:r>
           </a:p>
         </p:txBody>
       </p:sp>
       <p:pic>
         <p:nvPicPr>
-          <p:cNvPr id="9" name="mermaid diagram" descr="d8ada4ab7ae2a132.png"/>
+          <p:cNvPr id="9" name="mermaid diagram" descr="0577f00dfd72043f.png"/>
           <p:cNvPicPr>
             <a:picLocks noChangeAspect="1"/>
           </p:cNvPicPr>
@@ -24331,8 +24471,8 @@
         </p:blipFill>
         <p:spPr>
           <a:xfrm>
-            <a:off x="3513786" y="1682496"/>
-            <a:ext cx="5164121" cy="4517136"/>
+            <a:off x="3566721" y="1682496"/>
+            <a:ext cx="5058251" cy="4517136"/>
           </a:xfrm>
           <a:prstGeom prst="rect">
             <a:avLst/>
@@ -25180,7 +25320,7 @@
                 </a:solidFill>
                 <a:latin typeface="Georgia"/>
               </a:rPr>
-              <a:t>the sign</a:t>
+              <a:t>direction</a:t>
             </a:r>
           </a:p>
         </p:txBody>
@@ -25250,7 +25390,7 @@
                 </a:solidFill>
                 <a:latin typeface="Calibri"/>
               </a:rPr>
-              <a:t>a falling quarter reported as a rising one</a:t>
+              <a:t>a quarter reported the wrong way round</a:t>
             </a:r>
           </a:p>
         </p:txBody>
@@ -26004,7 +26144,7 @@
                 </a:solidFill>
                 <a:latin typeface="Calibri"/>
               </a:rPr>
-              <a:t>What each option leads with, on how many orders, and how often chance alone produces it.</a:t>
+              <a:t>This morning's file: what each option leads with, on how many orders, and how often chance alone produces it.</a:t>
             </a:r>
           </a:p>
         </p:txBody>
@@ -26019,7 +26159,7 @@
         </p:nvGraphicFramePr>
         <p:xfrm>
           <a:off x="530352" y="1956816"/>
-          <a:ext cx="11130989" cy="1676400"/>
+          <a:ext cx="11130988" cy="1676400"/>
         </p:xfrm>
         <a:graphic>
           <a:graphicData uri="http://schemas.openxmlformats.org/drawingml/2006/table">
@@ -26028,10 +26168,10 @@
                 <a:tableStyleId>{2D5ABB26-0587-4C30-8999-92F81FD0307C}</a:tableStyleId>
               </a:tblPr>
               <a:tblGrid>
-                <a:gridCol w="2719560"/>
-                <a:gridCol w="4434823"/>
-                <a:gridCol w="914400"/>
-                <a:gridCol w="2147806"/>
+                <a:gridCol w="2447840"/>
+                <a:gridCol w="3298298"/>
+                <a:gridCol w="1767473"/>
+                <a:gridCol w="2702977"/>
                 <a:gridCol w="914400"/>
               </a:tblGrid>
               <a:tr h="335280">
@@ -26181,7 +26321,7 @@
                           </a:solidFill>
                           <a:latin typeface="Calibri"/>
                         </a:rPr>
-                        <a:t>Business -29.2%</a:t>
+                        <a:t>the corporate rate</a:t>
                       </a:r>
                     </a:p>
                   </a:txBody>
@@ -26203,7 +26343,7 @@
                           </a:solidFill>
                           <a:latin typeface="Calibri"/>
                         </a:rPr>
-                        <a:t>10</a:t>
+                        <a:t>under thirty</a:t>
                       </a:r>
                     </a:p>
                   </a:txBody>
@@ -26225,7 +26365,7 @@
                           </a:solidFill>
                           <a:latin typeface="Calibri"/>
                         </a:rPr>
-                        <a:t>0.75, coin flips</a:t>
+                        <a:t>most coin-flip worlds</a:t>
                       </a:r>
                     </a:p>
                   </a:txBody>
@@ -26449,7 +26589,7 @@
                           </a:solidFill>
                           <a:latin typeface="Calibri"/>
                         </a:rPr>
-                        <a:t>0.0195, shuffle</a:t>
+                        <a:t>0.006, quarters flipped</a:t>
                       </a:r>
                     </a:p>
                   </a:txBody>
@@ -26495,7 +26635,7 @@
                           </a:solidFill>
                           <a:latin typeface="Calibri"/>
                         </a:rPr>
-                        <a:t>D. Test every segment</a:t>
+                        <a:t>D. Test every segment, run</a:t>
                       </a:r>
                     </a:p>
                   </a:txBody>
@@ -26517,7 +26657,7 @@
                           </a:solidFill>
                           <a:latin typeface="Calibri"/>
                         </a:rPr>
-                        <a:t>the smallest p</a:t>
+                        <a:t>the smallest of four p-values</a:t>
                       </a:r>
                     </a:p>
                   </a:txBody>
@@ -26539,7 +26679,7 @@
                           </a:solidFill>
                           <a:latin typeface="Calibri"/>
                         </a:rPr>
-                        <a:t>10 to 88</a:t>
+                        <a:t>under thirty to 88</a:t>
                       </a:r>
                     </a:p>
                   </a:txBody>
@@ -26561,7 +26701,7 @@
                           </a:solidFill>
                           <a:latin typeface="Calibri"/>
                         </a:rPr>
-                        <a:t>0.19 false alarm</a:t>
+                        <a:t>0.006, one of four under 0.05</a:t>
                       </a:r>
                     </a:p>
                   </a:txBody>
@@ -27262,7 +27402,7 @@
                 </a:solidFill>
                 <a:latin typeface="Georgia"/>
               </a:rPr>
-              <a:t>The branch that moved, tested on customers</a:t>
+              <a:t>The branch that moved, tested on its own customers</a:t>
             </a:r>
           </a:p>
         </p:txBody>
@@ -27297,7 +27437,7 @@
                 </a:solidFill>
                 <a:latin typeface="Calibri"/>
               </a:rPr>
-              <a:t>The label is shuffled across customers, because a customer's orders belong together.</a:t>
+              <a:t>The same 30 customers sit in both quarters, so each customer's own two quarters are flipped at random.</a:t>
             </a:r>
           </a:p>
         </p:txBody>
@@ -27332,7 +27472,7 @@
                 </a:solidFill>
                 <a:latin typeface="Georgia"/>
               </a:rPr>
-              <a:t>-15.6 pts</a:t>
+              <a:t>-17.1%</a:t>
             </a:r>
           </a:p>
         </p:txBody>
@@ -27367,7 +27507,7 @@
                 </a:solidFill>
                 <a:latin typeface="Calibri"/>
               </a:rPr>
-              <a:t>BASKET GAP</a:t>
+              <a:t>REVENUE PER ORDER</a:t>
             </a:r>
           </a:p>
         </p:txBody>
@@ -27402,7 +27542,7 @@
                 </a:solidFill>
                 <a:latin typeface="Calibri"/>
               </a:rPr>
-              <a:t>Retail-Core against Retail-Plus</a:t>
+              <a:t>Retail-Core, Q1 to Q2</a:t>
             </a:r>
           </a:p>
         </p:txBody>
@@ -27481,7 +27621,7 @@
                 </a:solidFill>
                 <a:latin typeface="Georgia"/>
               </a:rPr>
-              <a:t>39 of 2,000</a:t>
+              <a:t>12 of 2,000</a:t>
             </a:r>
           </a:p>
         </p:txBody>
@@ -27516,7 +27656,7 @@
                 </a:solidFill>
                 <a:latin typeface="Calibri"/>
               </a:rPr>
-              <a:t>SHUFFLES AS LARGE</a:t>
+              <a:t>FLIPPED WORLDS AS LARGE</a:t>
             </a:r>
           </a:p>
         </p:txBody>
@@ -27551,7 +27691,7 @@
                 </a:solidFill>
                 <a:latin typeface="Calibri"/>
               </a:rPr>
-              <a:t>random.Random(7)</a:t>
+              <a:t>either direction, random.Random(7)</a:t>
             </a:r>
           </a:p>
         </p:txBody>
@@ -27630,7 +27770,7 @@
                 </a:solidFill>
                 <a:latin typeface="Georgia"/>
               </a:rPr>
-              <a:t>p = 0.0195</a:t>
+              <a:t>p = 0.006</a:t>
             </a:r>
           </a:p>
         </p:txBody>
@@ -27758,7 +27898,7 @@
         <p:spPr>
           <a:xfrm>
             <a:off x="530352" y="3419856"/>
-            <a:ext cx="11130991" cy="1121664"/>
+            <a:ext cx="11130991" cy="1380744"/>
           </a:xfrm>
           <a:prstGeom prst="roundRect">
             <a:avLst>
@@ -27811,7 +27951,7 @@
         </p:nvSpPr>
         <p:spPr>
           <a:xfrm>
-            <a:off x="758952" y="3752088"/>
+            <a:off x="758952" y="3881628"/>
             <a:ext cx="457200" cy="457200"/>
           </a:xfrm>
           <a:prstGeom prst="ellipse">
@@ -27863,7 +28003,7 @@
         </p:blipFill>
         <p:spPr>
           <a:xfrm>
-            <a:off x="868680" y="3861816"/>
+            <a:off x="868680" y="3991356"/>
             <a:ext cx="237744" cy="237744"/>
           </a:xfrm>
           <a:prstGeom prst="rect">
@@ -27915,7 +28055,7 @@
         <p:spPr>
           <a:xfrm>
             <a:off x="1399031" y="3785616"/>
-            <a:ext cx="9987991" cy="682752"/>
+            <a:ext cx="9987991" cy="941832"/>
           </a:xfrm>
           <a:prstGeom prst="rect">
             <a:avLst/>
@@ -27935,7 +28075,7 @@
                 </a:solidFill>
                 <a:latin typeface="Calibri"/>
               </a:rPr>
-              <a:t>[S] Tell me about an analysis you did: what did you find, and how sure are you? The claim with its count, the check that it ties to the books, the test on the right unit, and the caveat.</a:t>
+              <a:t>[S] Tell me about an analysis you did: what did you find, and how sure are you? The claim with its count, the check that it ties to the books, a test that keeps each customer's two quarters together, and the caveat.</a:t>
             </a:r>
           </a:p>
         </p:txBody>
@@ -28448,14 +28588,14 @@
                 </a:solidFill>
                 <a:latin typeface="Calibri"/>
               </a:rPr>
-              <a:t>Of Retail-Core's 30 customers who ordered in both quarters, how many saw their own basket fall?</a:t>
+              <a:t>Of Retail-Core's 30 customers, how many saw their own basket fall, and how often would coin flips split them so?</a:t>
             </a:r>
           </a:p>
         </p:txBody>
       </p:sp>
       <p:pic>
         <p:nvPicPr>
-          <p:cNvPr id="9" name="mermaid diagram" descr="8095a9870cd63487.png"/>
+          <p:cNvPr id="9" name="mermaid diagram" descr="5721dd61f4abf3ee.png"/>
           <p:cNvPicPr>
             <a:picLocks noChangeAspect="1"/>
           </p:cNvPicPr>
@@ -28469,8 +28609,8 @@
         </p:blipFill>
         <p:spPr>
           <a:xfrm>
-            <a:off x="1873891" y="1956816"/>
-            <a:ext cx="8443912" cy="2043112"/>
+            <a:off x="1738160" y="1956816"/>
+            <a:ext cx="8715375" cy="1800225"/>
           </a:xfrm>
           <a:prstGeom prst="rect">
             <a:avLst/>
@@ -28485,7 +28625,7 @@
         </p:nvSpPr>
         <p:spPr>
           <a:xfrm>
-            <a:off x="530352" y="4146232"/>
+            <a:off x="530352" y="3903345"/>
             <a:ext cx="11130991" cy="862584"/>
           </a:xfrm>
           <a:prstGeom prst="roundRect">
@@ -28539,7 +28679,7 @@
         </p:nvSpPr>
         <p:spPr>
           <a:xfrm>
-            <a:off x="758952" y="4348924"/>
+            <a:off x="758952" y="4106037"/>
             <a:ext cx="457200" cy="457200"/>
           </a:xfrm>
           <a:prstGeom prst="ellipse">
@@ -28591,7 +28731,7 @@
         </p:blipFill>
         <p:spPr>
           <a:xfrm>
-            <a:off x="868680" y="4458652"/>
+            <a:off x="868680" y="4215765"/>
             <a:ext cx="237744" cy="237744"/>
           </a:xfrm>
           <a:prstGeom prst="rect">
@@ -28607,7 +28747,7 @@
         </p:nvSpPr>
         <p:spPr>
           <a:xfrm>
-            <a:off x="1399031" y="4292536"/>
+            <a:off x="1399031" y="4049649"/>
             <a:ext cx="9987991" cy="160401"/>
           </a:xfrm>
           <a:prstGeom prst="rect">
@@ -28642,7 +28782,7 @@
         </p:nvSpPr>
         <p:spPr>
           <a:xfrm>
-            <a:off x="1399031" y="4511992"/>
+            <a:off x="1399031" y="4269105"/>
             <a:ext cx="9987991" cy="423672"/>
           </a:xfrm>
           <a:prstGeom prst="rect">
@@ -28663,7 +28803,7 @@
                 </a:solidFill>
                 <a:latin typeface="Calibri"/>
               </a:rPr>
-              <a:t>Say the count before the rate, every time: "six orders, then four", and then the percentage.</a:t>
+              <a:t>Say the count before the rate, every time: the orders in each quarter, and then the percentage.</a:t>
             </a:r>
           </a:p>
         </p:txBody>
@@ -29141,7 +29281,7 @@
                 </a:solidFill>
                 <a:latin typeface="Georgia"/>
               </a:rPr>
-              <a:t>Reserve: shuffle what carries the label</a:t>
+              <a:t>Reserve: keep each customer's quarters together</a:t>
             </a:r>
           </a:p>
         </p:txBody>
@@ -29231,7 +29371,7 @@
                 </a:solidFill>
                 <a:latin typeface="Calibri"/>
               </a:rPr>
-              <a:t>The same gap, tested two ways, and two verdicts.</a:t>
+              <a:t>The same fall in revenue per customer, tested two ways, and two verdicts.</a:t>
             </a:r>
           </a:p>
         </p:txBody>
@@ -29245,7 +29385,7 @@
         <p:spPr>
           <a:xfrm>
             <a:off x="530352" y="1956816"/>
-            <a:ext cx="5474055" cy="2154428"/>
+            <a:ext cx="5474055" cy="1964436"/>
           </a:xfrm>
           <a:prstGeom prst="roundRect">
             <a:avLst>
@@ -29394,7 +29534,7 @@
                 </a:solidFill>
                 <a:latin typeface="Calibri"/>
               </a:rPr>
-              <a:t>SHUFFLE CUSTOMERS</a:t>
+              <a:t>FLIP EACH CUSTOMER'S OWN TWO QUARTERS</a:t>
             </a:r>
           </a:p>
         </p:txBody>
@@ -29429,7 +29569,7 @@
                 </a:solidFill>
                 <a:latin typeface="Calibri"/>
               </a:rPr>
-              <a:t>p = 0.0195</a:t>
+              <a:t>p = 0.0015</a:t>
             </a:r>
           </a:p>
         </p:txBody>
@@ -29464,7 +29604,7 @@
                 </a:solidFill>
                 <a:latin typeface="Calibri"/>
               </a:rPr>
-              <a:t>A customer's orders move together, so every world is one that could exist.</a:t>
+              <a:t>Every world is one these 30 customers could have produced, so a real fall shows as one.</a:t>
             </a:r>
           </a:p>
         </p:txBody>
@@ -29478,7 +29618,7 @@
         <p:spPr>
           <a:xfrm>
             <a:off x="6187287" y="1956816"/>
-            <a:ext cx="5474055" cy="2154428"/>
+            <a:ext cx="5474055" cy="1964436"/>
           </a:xfrm>
           <a:prstGeom prst="roundRect">
             <a:avLst>
@@ -29621,7 +29761,7 @@
                 </a:solidFill>
                 <a:latin typeface="Calibri"/>
               </a:rPr>
-              <a:t>SHUFFLE ORDERS</a:t>
+              <a:t>POOL THE Q1 AND Q2 FIGURES AND DEAL THEM</a:t>
             </a:r>
           </a:p>
         </p:txBody>
@@ -29656,7 +29796,7 @@
                 </a:solidFill>
                 <a:latin typeface="Calibri"/>
               </a:rPr>
-              <a:t>p = 0.0755</a:t>
+              <a:t>p = 0.0765</a:t>
             </a:r>
           </a:p>
         </p:txBody>
@@ -29670,7 +29810,7 @@
         <p:spPr>
           <a:xfrm>
             <a:off x="6388455" y="3303524"/>
-            <a:ext cx="5071719" cy="581406"/>
+            <a:ext cx="5071719" cy="399796"/>
           </a:xfrm>
           <a:prstGeom prst="rect">
             <a:avLst/>
@@ -29691,7 +29831,7 @@
                 </a:solidFill>
                 <a:latin typeface="Calibri"/>
               </a:rPr>
-              <a:t>Orders treated as independent. Most often that makes p too small; here it breaks each customer's Q1 to Q2 pairing, so a real gap reads as chance.</a:t>
+              <a:t>Each customer's two quarters are dealt as strangers, the steadiness of each customer is thrown away, and a real fall reads as chance.</a:t>
             </a:r>
           </a:p>
         </p:txBody>
@@ -29704,8 +29844,8 @@
         </p:nvSpPr>
         <p:spPr>
           <a:xfrm>
-            <a:off x="530352" y="4294124"/>
-            <a:ext cx="11130991" cy="862584"/>
+            <a:off x="530352" y="4104132"/>
+            <a:ext cx="11130991" cy="1380744"/>
           </a:xfrm>
           <a:prstGeom prst="roundRect">
             <a:avLst>
@@ -29758,7 +29898,7 @@
         </p:nvSpPr>
         <p:spPr>
           <a:xfrm>
-            <a:off x="758952" y="4496816"/>
+            <a:off x="758952" y="4565904"/>
             <a:ext cx="457200" cy="457200"/>
           </a:xfrm>
           <a:prstGeom prst="ellipse">
@@ -29810,7 +29950,7 @@
         </p:blipFill>
         <p:spPr>
           <a:xfrm>
-            <a:off x="868680" y="4606544"/>
+            <a:off x="868680" y="4675632"/>
             <a:ext cx="237744" cy="237744"/>
           </a:xfrm>
           <a:prstGeom prst="rect">
@@ -29826,7 +29966,7 @@
         </p:nvSpPr>
         <p:spPr>
           <a:xfrm>
-            <a:off x="1399031" y="4440428"/>
+            <a:off x="1399031" y="4250436"/>
             <a:ext cx="9987991" cy="160401"/>
           </a:xfrm>
           <a:prstGeom prst="rect">
@@ -29861,8 +30001,8 @@
         </p:nvSpPr>
         <p:spPr>
           <a:xfrm>
-            <a:off x="1399031" y="4659884"/>
-            <a:ext cx="9987991" cy="423672"/>
+            <a:off x="1399031" y="4469892"/>
+            <a:ext cx="9987991" cy="941832"/>
           </a:xfrm>
           <a:prstGeom prst="rect">
             <a:avLst/>
@@ -29882,7 +30022,7 @@
                 </a:solidFill>
                 <a:latin typeface="Calibri"/>
               </a:rPr>
-              <a:t>The unit you shuffle is the unit that carries the label. On Thursday and today, that is the customer.</a:t>
+              <a:t>Keep each customer's own two quarters together: flip them as a pair when the same customers sit in both quarters, and shuffle labels across whole customers when the groups are different customers. Pooling paired data is the hurried mistake.</a:t>
             </a:r>
           </a:p>
         </p:txBody>
@@ -30555,7 +30695,7 @@
                 </a:solidFill>
                 <a:latin typeface="Calibri"/>
               </a:rPr>
-              <a:t>pulled up by ten orders</a:t>
+              <a:t>pulled up by the corporate orders</a:t>
             </a:r>
           </a:p>
         </p:txBody>
@@ -33246,7 +33386,7 @@
                 </a:solidFill>
                 <a:latin typeface="Calibri"/>
               </a:rPr>
-              <a:t>Two true numbers for one quarter. Quote one to the owner of the other and you are out by nearly half, so every figure names its base and bridges to the books. Source: FSN E-Commerce Ventures press release, 12 August 2025.</a:t>
+              <a:t>GMV is everything ordered, before cancellations, returns and tax come out; revenue from operations is what the company books as its income. Quote one to the owner of the other and you are out by nearly half. Source: FSN E-Commerce Ventures press release, 12 August 2025.</a:t>
             </a:r>
           </a:p>
         </p:txBody>
@@ -33951,7 +34091,7 @@
                 </a:solidFill>
                 <a:latin typeface="Georgia"/>
               </a:rPr>
-              <a:t>The headline the hurried run sent</a:t>
+              <a:t>The headline a hurried run sends</a:t>
             </a:r>
           </a:p>
         </p:txBody>
@@ -33986,7 +34126,7 @@
                 </a:solidFill>
                 <a:latin typeface="Calibri"/>
               </a:rPr>
-              <a:t>Rows kept as they arrived, and a value that would not convert set to zero: no error anywhere.</a:t>
+              <a:t>Invented export: rows kept as they arrived and a value that would not convert set to zero, with no error.</a:t>
             </a:r>
           </a:p>
         </p:txBody>
@@ -34021,7 +34161,7 @@
                 </a:solidFill>
                 <a:latin typeface="Georgia"/>
               </a:rPr>
-              <a:t>Rs 50,63,000</a:t>
+              <a:t>Rs 31,50,000</a:t>
             </a:r>
           </a:p>
         </p:txBody>
@@ -34091,7 +34231,7 @@
                 </a:solidFill>
                 <a:latin typeface="Calibri"/>
               </a:rPr>
-              <a:t>98 rows</a:t>
+              <a:t>83 rows, invented</a:t>
             </a:r>
           </a:p>
         </p:txBody>
@@ -34170,7 +34310,7 @@
                 </a:solidFill>
                 <a:latin typeface="Georgia"/>
               </a:rPr>
-              <a:t>Rs 56,60,890</a:t>
+              <a:t>Rs 38,16,420</a:t>
             </a:r>
           </a:p>
         </p:txBody>
@@ -34240,7 +34380,7 @@
                 </a:solidFill>
                 <a:latin typeface="Calibri"/>
               </a:rPr>
-              <a:t>109 rows</a:t>
+              <a:t>92 rows, invented</a:t>
             </a:r>
           </a:p>
         </p:txBody>
@@ -34319,7 +34459,7 @@
                 </a:solidFill>
                 <a:latin typeface="Georgia"/>
               </a:rPr>
-              <a:t>+11.8%</a:t>
+              <a:t>+21.2%</a:t>
             </a:r>
           </a:p>
         </p:txBody>
@@ -35122,7 +35262,7 @@
                 </a:solidFill>
                 <a:latin typeface="Calibri"/>
               </a:rPr>
-              <a:t>Choose one: a) the median order, in case one large order moved the total on its own; b) the p-value of the Q1 to Q2 change, with 2,000 shuffles on customers; c) orders and rupees per quarter against Finance's control totals; d) the segment split, to see which of the four segments grew the most.</a:t>
+              <a:t>Choose one: a) the median order, in case one large order moved the total on its own; b) the p-value of the Q1 to Q2 change, with 2,000 shuffles; c) orders and rupees per quarter against Finance's control totals; d) the segment split, to see which of the four segments grew the most.</a:t>
             </a:r>
           </a:p>
         </p:txBody>
@@ -35635,7 +35775,7 @@
                 </a:solidFill>
                 <a:latin typeface="Calibri"/>
               </a:rPr>
-              <a:t>The hurried run against the control totals, in orders and in rupees.</a:t>
+              <a:t>Invented export: the hurried run against the control totals, in orders and in rupees.</a:t>
             </a:r>
           </a:p>
         </p:txBody>
@@ -35650,7 +35790,7 @@
         </p:nvGraphicFramePr>
         <p:xfrm>
           <a:off x="530352" y="1956816"/>
-          <a:ext cx="11130988" cy="1005840"/>
+          <a:ext cx="11130990" cy="1005840"/>
         </p:xfrm>
         <a:graphic>
           <a:graphicData uri="http://schemas.openxmlformats.org/drawingml/2006/table">
@@ -35660,10 +35800,10 @@
               </a:tblPr>
               <a:tblGrid>
                 <a:gridCol w="914400"/>
-                <a:gridCol w="2328575"/>
-                <a:gridCol w="2779719"/>
-                <a:gridCol w="2328575"/>
-                <a:gridCol w="2779719"/>
+                <a:gridCol w="2089319"/>
+                <a:gridCol w="2864033"/>
+                <a:gridCol w="2399205"/>
+                <a:gridCol w="2864033"/>
               </a:tblGrid>
               <a:tr h="335280">
                 <a:tc>
@@ -35700,7 +35840,7 @@
                           </a:solidFill>
                           <a:latin typeface="Calibri"/>
                         </a:rPr>
-                        <a:t>Orders summed</a:t>
+                        <a:t>Rows summed</a:t>
                       </a:r>
                     </a:p>
                   </a:txBody>
@@ -35812,7 +35952,7 @@
                           </a:solidFill>
                           <a:latin typeface="Calibri"/>
                         </a:rPr>
-                        <a:t>98</a:t>
+                        <a:t>83</a:t>
                       </a:r>
                     </a:p>
                   </a:txBody>
@@ -35834,7 +35974,7 @@
                           </a:solidFill>
                           <a:latin typeface="Calibri"/>
                         </a:rPr>
-                        <a:t>98</a:t>
+                        <a:t>83</a:t>
                       </a:r>
                     </a:p>
                   </a:txBody>
@@ -35856,7 +35996,7 @@
                           </a:solidFill>
                           <a:latin typeface="Calibri"/>
                         </a:rPr>
-                        <a:t>Rs 50,63,000</a:t>
+                        <a:t>Rs 31,50,000</a:t>
                       </a:r>
                     </a:p>
                   </a:txBody>
@@ -35878,7 +36018,7 @@
                           </a:solidFill>
                           <a:latin typeface="Calibri"/>
                         </a:rPr>
-                        <a:t>Rs 60,48,000</a:t>
+                        <a:t>Rs 40,00,000</a:t>
                       </a:r>
                     </a:p>
                   </a:txBody>
@@ -35924,7 +36064,7 @@
                           </a:solidFill>
                           <a:latin typeface="Calibri"/>
                         </a:rPr>
-                        <a:t>109</a:t>
+                        <a:t>92</a:t>
                       </a:r>
                     </a:p>
                   </a:txBody>
@@ -35946,7 +36086,7 @@
                           </a:solidFill>
                           <a:latin typeface="Calibri"/>
                         </a:rPr>
-                        <a:t>99</a:t>
+                        <a:t>84</a:t>
                       </a:r>
                     </a:p>
                   </a:txBody>
@@ -35968,7 +36108,7 @@
                           </a:solidFill>
                           <a:latin typeface="Calibri"/>
                         </a:rPr>
-                        <a:t>Rs 56,60,890</a:t>
+                        <a:t>Rs 38,16,420</a:t>
                       </a:r>
                     </a:p>
                   </a:txBody>
@@ -35990,7 +36130,7 @@
                           </a:solidFill>
                           <a:latin typeface="Calibri"/>
                         </a:rPr>
-                        <a:t>Rs 43,25,480</a:t>
+                        <a:t>Rs 26,00,000</a:t>
                       </a:r>
                     </a:p>
                   </a:txBody>
@@ -36517,7 +36657,7 @@
                 </a:solidFill>
                 <a:latin typeface="Georgia"/>
               </a:rPr>
-              <a:t>Four ways to check, sized on this morning's file</a:t>
+              <a:t>Four ways to check, sized</a:t>
             </a:r>
           </a:p>
         </p:txBody>
@@ -36552,7 +36692,7 @@
                 </a:solidFill>
                 <a:latin typeface="Calibri"/>
               </a:rPr>
-              <a:t>Minutes of thought decide it; every option runs in under a millisecond.</a:t>
+              <a:t>Invented export: minutes of thought decide it, and what each option needs from outside the file.</a:t>
             </a:r>
           </a:p>
         </p:txBody>
@@ -36567,7 +36707,7 @@
         </p:nvGraphicFramePr>
         <p:xfrm>
           <a:off x="530352" y="1956816"/>
-          <a:ext cx="11130990" cy="1676400"/>
+          <a:ext cx="11130989" cy="1676400"/>
         </p:xfrm>
         <a:graphic>
           <a:graphicData uri="http://schemas.openxmlformats.org/drawingml/2006/table">
@@ -36576,10 +36716,11 @@
                 <a:tableStyleId>{2D5ABB26-0587-4C30-8999-92F81FD0307C}</a:tableStyleId>
               </a:tblPr>
               <a:tblGrid>
-                <a:gridCol w="4029473"/>
-                <a:gridCol w="2088463"/>
-                <a:gridCol w="2327357"/>
-                <a:gridCol w="2685697"/>
+                <a:gridCol w="3069921"/>
+                <a:gridCol w="1591130"/>
+                <a:gridCol w="2013642"/>
+                <a:gridCol w="2410153"/>
+                <a:gridCol w="2046143"/>
               </a:tblGrid>
               <a:tr h="335280">
                 <a:tc>
@@ -36638,7 +36779,29 @@
                           </a:solidFill>
                           <a:latin typeface="Calibri"/>
                         </a:rPr>
-                        <a:t>Headline it sends</a:t>
+                        <a:t>Needs</a:t>
+                      </a:r>
+                    </a:p>
+                  </a:txBody>
+                  <a:tcPr marL="101600" marR="101600" marT="38100" marB="38100" anchor="ctr">
+                    <a:solidFill>
+                      <a:srgbClr val="1A0F5C"/>
+                    </a:solidFill>
+                  </a:tcPr>
+                </a:tc>
+                <a:tc>
+                  <a:txBody>
+                    <a:bodyPr/>
+                    <a:lstStyle/>
+                    <a:p>
+                      <a:r>
+                        <a:rPr sz="1250" b="1" i="0">
+                          <a:solidFill>
+                            <a:srgbClr val="FFFFFF"/>
+                          </a:solidFill>
+                          <a:latin typeface="Calibri"/>
+                        </a:rPr>
+                        <a:t>Headline it lets through</a:t>
                       </a:r>
                     </a:p>
                   </a:txBody>
@@ -36728,7 +36891,7 @@
                           </a:solidFill>
                           <a:latin typeface="Calibri"/>
                         </a:rPr>
-                        <a:t>+11.8%</a:t>
+                        <a:t>nothing</a:t>
                       </a:r>
                     </a:p>
                   </a:txBody>
@@ -36750,7 +36913,29 @@
                           </a:solidFill>
                           <a:latin typeface="Calibri"/>
                         </a:rPr>
-                        <a:t>40.3</a:t>
+                        <a:t>+21.2%</a:t>
+                      </a:r>
+                    </a:p>
+                  </a:txBody>
+                  <a:tcPr marL="101600" marR="101600" marT="38100" marB="38100" anchor="ctr">
+                    <a:solidFill>
+                      <a:srgbClr val="FFFFFF"/>
+                    </a:solidFill>
+                  </a:tcPr>
+                </a:tc>
+                <a:tc>
+                  <a:txBody>
+                    <a:bodyPr/>
+                    <a:lstStyle/>
+                    <a:p>
+                      <a:r>
+                        <a:rPr sz="1200" b="0" i="0">
+                          <a:solidFill>
+                            <a:srgbClr val="1A1440"/>
+                          </a:solidFill>
+                          <a:latin typeface="Calibri"/>
+                        </a:rPr>
+                        <a:t>56.2</a:t>
                       </a:r>
                     </a:p>
                   </a:txBody>
@@ -36818,7 +37003,7 @@
                           </a:solidFill>
                           <a:latin typeface="Calibri"/>
                         </a:rPr>
-                        <a:t>-14.6%</a:t>
+                        <a:t>Finance's order counts</a:t>
                       </a:r>
                     </a:p>
                   </a:txBody>
@@ -36840,7 +37025,29 @@
                           </a:solidFill>
                           <a:latin typeface="Calibri"/>
                         </a:rPr>
-                        <a:t>13.9</a:t>
+                        <a:t>-17.5%</a:t>
+                      </a:r>
+                    </a:p>
+                  </a:txBody>
+                  <a:tcPr marL="101600" marR="101600" marT="38100" marB="38100" anchor="ctr">
+                    <a:solidFill>
+                      <a:srgbClr val="F4F2FA"/>
+                    </a:solidFill>
+                  </a:tcPr>
+                </a:tc>
+                <a:tc>
+                  <a:txBody>
+                    <a:bodyPr/>
+                    <a:lstStyle/>
+                    <a:p>
+                      <a:r>
+                        <a:rPr sz="1200" b="0" i="0">
+                          <a:solidFill>
+                            <a:srgbClr val="1A1440"/>
+                          </a:solidFill>
+                          <a:latin typeface="Calibri"/>
+                        </a:rPr>
+                        <a:t>17.5</a:t>
                       </a:r>
                     </a:p>
                   </a:txBody>
@@ -36908,7 +37115,29 @@
                           </a:solidFill>
                           <a:latin typeface="Calibri"/>
                         </a:rPr>
-                        <a:t>-28.5%</a:t>
+                        <a:t>Finance's rupee totals</a:t>
+                      </a:r>
+                    </a:p>
+                  </a:txBody>
+                  <a:tcPr marL="101600" marR="101600" marT="38100" marB="38100" anchor="ctr">
+                    <a:solidFill>
+                      <a:srgbClr val="FFFFFF"/>
+                    </a:solidFill>
+                  </a:tcPr>
+                </a:tc>
+                <a:tc>
+                  <a:txBody>
+                    <a:bodyPr/>
+                    <a:lstStyle/>
+                    <a:p>
+                      <a:r>
+                        <a:rPr sz="1200" b="0" i="0">
+                          <a:solidFill>
+                            <a:srgbClr val="1A1440"/>
+                          </a:solidFill>
+                          <a:latin typeface="Calibri"/>
+                        </a:rPr>
+                        <a:t>-35.0%</a:t>
                       </a:r>
                     </a:p>
                   </a:txBody>
@@ -36998,7 +37227,29 @@
                           </a:solidFill>
                           <a:latin typeface="Calibri"/>
                         </a:rPr>
-                        <a:t>-28.5%</a:t>
+                        <a:t>Finance's ledger</a:t>
+                      </a:r>
+                    </a:p>
+                  </a:txBody>
+                  <a:tcPr marL="101600" marR="101600" marT="38100" marB="38100" anchor="ctr">
+                    <a:solidFill>
+                      <a:srgbClr val="F4F2FA"/>
+                    </a:solidFill>
+                  </a:tcPr>
+                </a:tc>
+                <a:tc>
+                  <a:txBody>
+                    <a:bodyPr/>
+                    <a:lstStyle/>
+                    <a:p>
+                      <a:r>
+                        <a:rPr sz="1200" b="0" i="0">
+                          <a:solidFill>
+                            <a:srgbClr val="1A1440"/>
+                          </a:solidFill>
+                          <a:latin typeface="Calibri"/>
+                        </a:rPr>
+                        <a:t>-35.0%, each order named</a:t>
                       </a:r>
                     </a:p>
                   </a:txBody>
@@ -37734,14 +37985,14 @@
                 </a:solidFill>
                 <a:latin typeface="Calibri"/>
               </a:rPr>
-              <a:t>Two moves, each a line in the decisions log, and the walk closes on Finance's total.</a:t>
+              <a:t>Invented export: two moves, each a line in the decisions log, and the walk closes on Finance's total.</a:t>
             </a:r>
           </a:p>
         </p:txBody>
       </p:sp>
       <p:pic>
         <p:nvPicPr>
-          <p:cNvPr id="9" name="mermaid diagram" descr="07d5400dbcc5a57a.png"/>
+          <p:cNvPr id="9" name="mermaid diagram" descr="b8037ce6427ca687.png"/>
           <p:cNvPicPr>
             <a:picLocks noChangeAspect="1"/>
           </p:cNvPicPr>
@@ -37772,7 +38023,7 @@
         <p:spPr>
           <a:xfrm>
             <a:off x="530352" y="3799760"/>
-            <a:ext cx="11130991" cy="495807"/>
+            <a:ext cx="11130991" cy="772160"/>
           </a:xfrm>
           <a:prstGeom prst="rect">
             <a:avLst/>
@@ -37797,7 +38048,7 @@
                 </a:solidFill>
                 <a:latin typeface="Calibri"/>
               </a:rPr>
-              <a:t>With both quarters on the books the headline is a fall of 28.5 percent, Rs 60,48,000 to Rs 43,25,480.</a:t>
+              <a:t>With both quarters on the books, the invented export's headline is a fall of 35.0 percent, Rs 40,00,000 to Rs 26,00,000.</a:t>
             </a:r>
           </a:p>
         </p:txBody>

</xml_diff>

<commit_message>
W01 D5: debrief S6 and the notes mark option D not run, since no ledger came with the export, matching notebook 1; the deck rebuilt
Co-Authored-By: Claude Opus 5.5 <noreply@anthropic.com>
Claude-Session: https://claude.ai/code/session_01P7zaoR4dQ5pzBFnsX549JQ
</commit_message>
<xml_diff>
--- a/content/W01/D5/slides/C2_W01_D05_debrief_STUDENT.pptx
+++ b/content/W01/D5/slides/C2_W01_D05_debrief_STUDENT.pptx
@@ -3211,22 +3211,22 @@
           </a:p>
           <a:p>
             <a:r>
-              <a:t>morning's file, with D marked not run because the lab had no ledger. Land two points: B is where</a:t>
-            </a:r>
-          </a:p>
-          <a:p>
-            <a:r>
-              <a:t>most people who did check stopped, and it still leaves the headline well off the books; D is right</a:t>
-            </a:r>
-          </a:p>
-          <a:p>
-            <a:r>
-              <a:t>and costs the afternoon. Minutes are the lab brief's pace, D's an estimate for a request to Finance</a:t>
-            </a:r>
-          </a:p>
-          <a:p>
-            <a:r>
-              <a:t>and a join.</a:t>
+              <a:t>morning's file, with D marked not run for the same reason: no ledger came with either export. Land</a:t>
+            </a:r>
+          </a:p>
+          <a:p>
+            <a:r>
+              <a:t>two points: B is where most people who did check stopped, and it still leaves the headline well off</a:t>
+            </a:r>
+          </a:p>
+          <a:p>
+            <a:r>
+              <a:t>the books; D would name every order that differs and costs the afternoon, once Finance sends the</a:t>
+            </a:r>
+          </a:p>
+          <a:p>
+            <a:r>
+              <a:t>ledger. Minutes are the lab brief's pace, D's an estimate for a request to Finance and a join.</a:t>
             </a:r>
           </a:p>
         </p:txBody>
@@ -36707,7 +36707,7 @@
         </p:nvGraphicFramePr>
         <p:xfrm>
           <a:off x="530352" y="1956816"/>
-          <a:ext cx="11130989" cy="1676400"/>
+          <a:ext cx="11130989" cy="2298192"/>
         </p:xfrm>
         <a:graphic>
           <a:graphicData uri="http://schemas.openxmlformats.org/drawingml/2006/table">
@@ -36716,11 +36716,11 @@
                 <a:tableStyleId>{2D5ABB26-0587-4C30-8999-92F81FD0307C}</a:tableStyleId>
               </a:tblPr>
               <a:tblGrid>
-                <a:gridCol w="3069921"/>
-                <a:gridCol w="1591130"/>
-                <a:gridCol w="2013642"/>
-                <a:gridCol w="2410153"/>
-                <a:gridCol w="2046143"/>
+                <a:gridCol w="2820396"/>
+                <a:gridCol w="1461802"/>
+                <a:gridCol w="1849972"/>
+                <a:gridCol w="3118988"/>
+                <a:gridCol w="1879831"/>
               </a:tblGrid>
               <a:tr h="335280">
                 <a:tc>
@@ -36946,7 +36946,7 @@
                   </a:tcPr>
                 </a:tc>
               </a:tr>
-              <a:tr h="335280">
+              <a:tr h="542544">
                 <a:tc>
                   <a:txBody>
                     <a:bodyPr/>
@@ -37058,7 +37058,7 @@
                   </a:tcPr>
                 </a:tc>
               </a:tr>
-              <a:tr h="335280">
+              <a:tr h="542544">
                 <a:tc>
                   <a:txBody>
                     <a:bodyPr/>
@@ -37170,7 +37170,7 @@
                   </a:tcPr>
                 </a:tc>
               </a:tr>
-              <a:tr h="335280">
+              <a:tr h="542544">
                 <a:tc>
                   <a:txBody>
                     <a:bodyPr/>
@@ -37249,7 +37249,7 @@
                           </a:solidFill>
                           <a:latin typeface="Calibri"/>
                         </a:rPr>
-                        <a:t>-35.0%, each order named</a:t>
+                        <a:t>not run: no ledger came with the export</a:t>
                       </a:r>
                     </a:p>
                   </a:txBody>
@@ -37271,7 +37271,7 @@
                           </a:solidFill>
                           <a:latin typeface="Calibri"/>
                         </a:rPr>
-                        <a:t>0.0</a:t>
+                        <a:t>not run</a:t>
                       </a:r>
                     </a:p>
                   </a:txBody>
@@ -37294,7 +37294,7 @@
         </p:nvSpPr>
         <p:spPr>
           <a:xfrm>
-            <a:off x="530352" y="3889248"/>
+            <a:off x="530352" y="4511040"/>
             <a:ext cx="11130991" cy="1121664"/>
           </a:xfrm>
           <a:prstGeom prst="roundRect">
@@ -37348,7 +37348,7 @@
         </p:nvSpPr>
         <p:spPr>
           <a:xfrm>
-            <a:off x="758952" y="4221480"/>
+            <a:off x="758952" y="4843272"/>
             <a:ext cx="457200" cy="457200"/>
           </a:xfrm>
           <a:prstGeom prst="ellipse">
@@ -37400,7 +37400,7 @@
         </p:blipFill>
         <p:spPr>
           <a:xfrm>
-            <a:off x="868680" y="4331208"/>
+            <a:off x="868680" y="4953000"/>
             <a:ext cx="237744" cy="237744"/>
           </a:xfrm>
           <a:prstGeom prst="rect">
@@ -37416,7 +37416,7 @@
         </p:nvSpPr>
         <p:spPr>
           <a:xfrm>
-            <a:off x="1399031" y="4035552"/>
+            <a:off x="1399031" y="4657344"/>
             <a:ext cx="9987991" cy="160401"/>
           </a:xfrm>
           <a:prstGeom prst="rect">
@@ -37451,7 +37451,7 @@
         </p:nvSpPr>
         <p:spPr>
           <a:xfrm>
-            <a:off x="1399031" y="4255008"/>
+            <a:off x="1399031" y="4876800"/>
             <a:ext cx="9987991" cy="682752"/>
           </a:xfrm>
           <a:prstGeom prst="rect">

</xml_diff>

<commit_message>
W01 D5: the humanizer's read of the decks, the study notes and the notebooks' markdown
Rehearsal S15's subtitle becomes the question it answers, S14's switch rule follows the key's own wording, and the Retail-Plus head's card drops a pronoun the lock never gave. Fragment stacks, aphorisms, "rather than" contrasts, a repeated-opening triad and "Your your-turn" are restated in the debrief and lab decks, the notes, the three chapter notebooks and the reference run; chapter 1's review now cites the invented export's hurried run instead of the room. All three decks rebuilt and rendered through LibreOffice with Carlito, 93 slides looked at; every notebook output is byte-identical to the last build.

Co-Authored-By: Claude Opus 5.5 <noreply@anthropic.com>
Claude-Session: https://claude.ai/code/session_01SjahrTf7jZ3ViL54dzqiBa
</commit_message>
<xml_diff>
--- a/content/W01/D5/slides/C2_W01_D05_debrief_STUDENT.pptx
+++ b/content/W01/D5/slides/C2_W01_D05_debrief_STUDENT.pptx
@@ -14340,7 +14340,7 @@
                 </a:solidFill>
                 <a:latin typeface="Calibri"/>
               </a:rPr>
-              <a:t>[F] You have two hours and a raw export; what do you do first, and what do you skip? Profile first, and never skip the reconciliation, the step that can flip the sign for fifteen minutes.</a:t>
+              <a:t>[F] You have two hours and a raw export; what do you do first, and what do you skip? Profile first, and never skip the reconciliation: it costs fifteen minutes and can flip the headline's sign.</a:t>
             </a:r>
           </a:p>
         </p:txBody>
@@ -26225,7 +26225,7 @@
         <p:spPr>
           <a:xfrm>
             <a:off x="530352" y="3889248"/>
-            <a:ext cx="11130991" cy="1380744"/>
+            <a:ext cx="11130991" cy="1639824"/>
           </a:xfrm>
           <a:prstGeom prst="roundRect">
             <a:avLst>
@@ -26278,7 +26278,7 @@
         </p:nvSpPr>
         <p:spPr>
           <a:xfrm>
-            <a:off x="758952" y="4351019"/>
+            <a:off x="758952" y="4480560"/>
             <a:ext cx="457200" cy="457200"/>
           </a:xfrm>
           <a:prstGeom prst="ellipse">
@@ -26330,7 +26330,7 @@
         </p:blipFill>
         <p:spPr>
           <a:xfrm>
-            <a:off x="868680" y="4460748"/>
+            <a:off x="868680" y="4590288"/>
             <a:ext cx="237744" cy="237744"/>
           </a:xfrm>
           <a:prstGeom prst="rect">
@@ -26382,7 +26382,7 @@
         <p:spPr>
           <a:xfrm>
             <a:off x="1399031" y="4255008"/>
-            <a:ext cx="9987991" cy="941832"/>
+            <a:ext cx="9987991" cy="1200912"/>
           </a:xfrm>
           <a:prstGeom prst="rect">
             <a:avLst/>
@@ -26402,7 +26402,7 @@
                 </a:solidFill>
                 <a:latin typeface="Calibri"/>
               </a:rPr>
-              <a:t>C, when the value can be read without guessing, as the invented export's "850000.00", an amount exported with its paise, can. D when it cannot: a word, a unit that could be lakh or crore. B when the row is not an order. A is the one option that hides its gap.</a:t>
+              <a:t>Choose C when the value can be read without a guess, as the invented export's "850000.00", an amount exported with its paise, can. Choose D when reading it needs a guess, such as a word or a unit that could be lakh or crore, and B when the row is not an order at all. A is the one option that hides its gap.</a:t>
             </a:r>
           </a:p>
         </p:txBody>
@@ -40371,7 +40371,7 @@
                 </a:solidFill>
                 <a:latin typeface="Calibri"/>
               </a:rPr>
-              <a:t>True to the rupee, the biggest number on the page, and the headline a hurried note leads with: "corporate is declining; we recommend a retention plan".</a:t>
+              <a:t>The rate is true to the rupee and the biggest move on the page, so a hurried note leads with it: "corporate is declining; we recommend a retention plan".</a:t>
             </a:r>
           </a:p>
         </p:txBody>
@@ -42713,7 +42713,7 @@
         <p:spPr>
           <a:xfrm>
             <a:off x="530352" y="3889248"/>
-            <a:ext cx="11130991" cy="1380744"/>
+            <a:ext cx="11130991" cy="1639824"/>
           </a:xfrm>
           <a:prstGeom prst="roundRect">
             <a:avLst>
@@ -42766,7 +42766,7 @@
         </p:nvSpPr>
         <p:spPr>
           <a:xfrm>
-            <a:off x="758952" y="4351019"/>
+            <a:off x="758952" y="4480560"/>
             <a:ext cx="457200" cy="457200"/>
           </a:xfrm>
           <a:prstGeom prst="ellipse">
@@ -42818,7 +42818,7 @@
         </p:blipFill>
         <p:spPr>
           <a:xfrm>
-            <a:off x="868680" y="4460748"/>
+            <a:off x="868680" y="4590288"/>
             <a:ext cx="237744" cy="237744"/>
           </a:xfrm>
           <a:prstGeom prst="rect">
@@ -42870,7 +42870,7 @@
         <p:spPr>
           <a:xfrm>
             <a:off x="1399031" y="4255008"/>
-            <a:ext cx="9987991" cy="941832"/>
+            <a:ext cx="9987991" cy="1200912"/>
           </a:xfrm>
           <a:prstGeom prst="rect">
             <a:avLst/>
@@ -42890,7 +42890,7 @@
                 </a:solidFill>
                 <a:latin typeface="Calibri"/>
               </a:rPr>
-              <a:t>C: the one consumer move on enough orders to test, small in rupees and led beside the corporate move said as counts. Switch when Meera's question is about accounts, when a segment carries hundreds of orders a quarter, or when a second quarter repeats the move.</a:t>
+              <a:t>C, because Retail-Plus's basket is the one consumer move on enough orders to test; it is small in rupees, so it leads beside the corporate move, which is said as counts. Switch when Meera's question is about accounts, when a segment carries hundreds of orders a quarter, or when a second quarter repeats the move.</a:t>
             </a:r>
           </a:p>
         </p:txBody>
@@ -56584,7 +56584,7 @@
                 </a:solidFill>
                 <a:latin typeface="Calibri"/>
               </a:rPr>
-              <a:t>The answer is c. Q1 has the right count and the wrong rupees; Q2 has too many rows and too many rupees. Two errors, and the invented headline carries both.</a:t>
+              <a:t>The answer is c. Q1 has the right count and the wrong rupees; Q2 has too many rows and too many rupees. The invented headline carries both errors.</a:t>
             </a:r>
           </a:p>
         </p:txBody>

</xml_diff>

<commit_message>
W01 D5: the second look fits its twenty minutes, S41 labels its figure invented, and three lines say what Saturday's paper holds
The lab deck's S10 and S11 now add to the day sheet's twenty minutes. Debrief S41's subtitle labels
the -15.0 percent as invented. S42's notes, S48 and notebook 3's close say the note's four parts and
the p-value sentence are on Saturday's paper, which tests them, rather than saying the paper asks for
them from memory. Rehearsal S20's title answers its subtitle, and the pre-read's carry line states
the rule in place of a saying. Decks rebuilt; notebook 3 rebuilt and executed.

Co-Authored-By: Claude Opus 5.5 <noreply@anthropic.com>
Claude-Session: https://claude.ai/code/session_01SjahrTf7jZ3ViL54dzqiBa
</commit_message>
<xml_diff>
--- a/content/W01/D5/slides/C2_W01_D05_debrief_STUDENT.pptx
+++ b/content/W01/D5/slides/C2_W01_D05_debrief_STUDENT.pptx
@@ -3688,12 +3688,12 @@
           </a:p>
           <a:p>
             <a:r>
-              <a:t>directions. Read the p-value sentence aloud once, word for word, because Saturday's paper asks for</a:t>
-            </a:r>
-          </a:p>
-          <a:p>
-            <a:r>
-              <a:t>it: "In 1.1 percent of worlds where the quarter made no difference to each member's basket, chance</a:t>
+              <a:t>directions. Read the p-value sentence aloud once, word for word, since Saturday's paper tests what it</a:t>
+            </a:r>
+          </a:p>
+          <a:p>
+            <a:r>
+              <a:t>means: "In 1.1 percent of worlds where the quarter made no difference to each member's basket, chance</a:t>
             </a:r>
           </a:p>
           <a:p>
@@ -44019,7 +44019,7 @@
                 </a:solidFill>
                 <a:latin typeface="Calibri"/>
               </a:rPr>
-              <a:t>Among 2,000 worlds with each member's two quarters flipped, how extreme is -15.0 percent?</a:t>
+              <a:t>Among 2,000 worlds with each member's two quarters flipped, how extreme is the invented -15.0 percent?</a:t>
             </a:r>
           </a:p>
         </p:txBody>
@@ -52784,7 +52784,7 @@
                 </a:solidFill>
                 <a:latin typeface="Calibri"/>
               </a:rPr>
-              <a:t>The note's four parts and the p-value sentence, from memory.</a:t>
+              <a:t>The note's four parts and the p-value sentence are both on it.</a:t>
             </a:r>
           </a:p>
         </p:txBody>

</xml_diff>